<commit_message>
Pac-Man deck: same essentials, different form
The five ghost modes as a state diagram, the enum's problem as a
question (a sixth mode touches every switch), the four personalities
with the ghosts' sprites, State vs. Strategy side by side, and the two
levels of state machine as a flow; old text in the speaker notes and
the site's Check yourself questions at the end.

Co-Authored-By: Claude Opus 5.5 <noreply@anthropic.com>
Claude-Session: https://claude.ai/code/session_012sjsUQBbC7zon57rWHoo9d
</commit_message>
<xml_diff>
--- a/slides/05 Pac-Man.pptx
+++ b/slides/05 Pac-Man.pptx
@@ -32,6 +32,7 @@
     <p:sldId id="280" r:id="rId30"/>
     <p:sldId id="292" r:id="rId42"/>
     <p:sldId id="293" r:id="rId52"/>
+    <p:sldId id="314" r:id="rId41"/>
     <p:sldId id="294" r:id="rId53"/>
     <p:sldId id="296" r:id="rId55"/>
   </p:sldIdLst>
@@ -830,6 +831,343 @@
 </p:notes>
 </file>
 
+<file path=ppt/notesSlides/notesSlide10.xml><?xml version="1.0" encoding="utf-8"?>
+<p:notes xmlns:a="http://schemas.openxmlformats.org/drawingml/2006/main" xmlns:p="http://schemas.openxmlformats.org/presentationml/2006/main" xmlns:r="http://schemas.openxmlformats.org/officeDocument/2006/relationships">
+  <p:cSld>
+    <p:spTree>
+      <p:nvGrpSpPr>
+        <p:cNvPr id="1" name=""/>
+        <p:cNvGrpSpPr/>
+        <p:nvPr/>
+      </p:nvGrpSpPr>
+      <p:grpSpPr>
+        <a:xfrm>
+          <a:off x="0" y="0"/>
+          <a:ext cx="0" cy="0"/>
+          <a:chOff x="0" y="0"/>
+          <a:chExt cx="0" cy="0"/>
+        </a:xfrm>
+      </p:grpSpPr>
+      <p:sp>
+        <p:nvSpPr>
+          <p:cNvPr id="2" name="Slide Image Placeholder 1"/>
+          <p:cNvSpPr>
+            <a:spLocks noGrp="1"/>
+          </p:cNvSpPr>
+          <p:nvPr>
+            <p:ph type="sldImg" idx="2"/>
+          </p:nvPr>
+        </p:nvSpPr>
+        <p:spPr/>
+      </p:sp>
+      <p:sp>
+        <p:nvSpPr>
+          <p:cNvPr id="3" name="Notes Placeholder 2"/>
+          <p:cNvSpPr>
+            <a:spLocks noGrp="1"/>
+          </p:cNvSpPr>
+          <p:nvPr>
+            <p:ph type="body" idx="1"/>
+          </p:nvPr>
+        </p:nvSpPr>
+        <p:spPr/>
+        <p:txBody>
+          <a:bodyPr/>
+          <a:lstStyle/>
+          <a:p>
+            <a:r>
+              <a:t>Talking points:</a:t>
+            </a:r>
+          </a:p>
+          <a:p>
+            <a:r>
+              <a:t>- So far, every ghost chases straight at Pac-Man</a:t>
+            </a:r>
+          </a:p>
+          <a:p>
+            <a:r>
+              <a:t>  - They line up behind him: easy to escape</a:t>
+            </a:r>
+          </a:p>
+          <a:p>
+            <a:r>
+              <a:t>- Blinky: Pac-Man’s tile</a:t>
+            </a:r>
+          </a:p>
+          <a:p>
+            <a:r>
+              <a:t>- Pinky: four tiles ahead of Pac-Man</a:t>
+            </a:r>
+          </a:p>
+          <a:p>
+            <a:r>
+              <a:t>- Inky: two tiles ahead of Pac-Man, and double the line from Blinky</a:t>
+            </a:r>
+          </a:p>
+          <a:p>
+            <a:r>
+              <a:t>- Clyde: Pac-Man, until within eight tiles; then his corner</a:t>
+            </a:r>
+          </a:p>
+          <a:p>
+            <a:r>
+              <a:t>- Together, they trap Pac-Man</a:t>
+            </a:r>
+          </a:p>
+        </p:txBody>
+      </p:sp>
+    </p:spTree>
+  </p:cSld>
+  <p:clrMapOvr>
+    <a:masterClrMapping/>
+  </p:clrMapOvr>
+</p:notes>
+</file>
+
+<file path=ppt/notesSlides/notesSlide11.xml><?xml version="1.0" encoding="utf-8"?>
+<p:notes xmlns:a="http://schemas.openxmlformats.org/drawingml/2006/main" xmlns:p="http://schemas.openxmlformats.org/presentationml/2006/main" xmlns:r="http://schemas.openxmlformats.org/officeDocument/2006/relationships">
+  <p:cSld>
+    <p:spTree>
+      <p:nvGrpSpPr>
+        <p:cNvPr id="1" name=""/>
+        <p:cNvGrpSpPr/>
+        <p:nvPr/>
+      </p:nvGrpSpPr>
+      <p:grpSpPr>
+        <a:xfrm>
+          <a:off x="0" y="0"/>
+          <a:ext cx="0" cy="0"/>
+          <a:chOff x="0" y="0"/>
+          <a:chExt cx="0" cy="0"/>
+        </a:xfrm>
+      </p:grpSpPr>
+      <p:sp>
+        <p:nvSpPr>
+          <p:cNvPr id="2" name="Slide Image Placeholder 1"/>
+          <p:cNvSpPr>
+            <a:spLocks noGrp="1"/>
+          </p:cNvSpPr>
+          <p:nvPr>
+            <p:ph type="sldImg" idx="2"/>
+          </p:nvPr>
+        </p:nvSpPr>
+        <p:spPr/>
+      </p:sp>
+      <p:sp>
+        <p:nvSpPr>
+          <p:cNvPr id="3" name="Notes Placeholder 2"/>
+          <p:cNvSpPr>
+            <a:spLocks noGrp="1"/>
+          </p:cNvSpPr>
+          <p:nvPr>
+            <p:ph type="body" idx="1"/>
+          </p:nvPr>
+        </p:nvSpPr>
+        <p:spPr/>
+        <p:txBody>
+          <a:bodyPr/>
+          <a:lstStyle/>
+          <a:p>
+            <a:r>
+              <a:t>Talking points:</a:t>
+            </a:r>
+          </a:p>
+          <a:p>
+            <a:r>
+              <a:t>- The same structure: hold an interface, forward to it</a:t>
+            </a:r>
+          </a:p>
+          <a:p>
+            <a:r>
+              <a:t>- State: the ghost’s mode</a:t>
+            </a:r>
+          </a:p>
+          <a:p>
+            <a:r>
+              <a:t>  - Picked by the states themselves, and changes all the time</a:t>
+            </a:r>
+          </a:p>
+          <a:p>
+            <a:r>
+              <a:t>  - A state knows the next state</a:t>
+            </a:r>
+          </a:p>
+          <a:p>
+            <a:r>
+              <a:t>- Strategy: the ghost’s targeting</a:t>
+            </a:r>
+          </a:p>
+          <a:p>
+            <a:r>
+              <a:t>  - Picked from outside (World), once, and never changes</a:t>
+            </a:r>
+          </a:p>
+          <a:p>
+            <a:r>
+              <a:t>  - Strategies don’t know each other</a:t>
+            </a:r>
+          </a:p>
+          <a:p>
+            <a:r>
+              <a:t>- Together: the state decides whether to chase, the strategy how</a:t>
+            </a:r>
+          </a:p>
+        </p:txBody>
+      </p:sp>
+    </p:spTree>
+  </p:cSld>
+  <p:clrMapOvr>
+    <a:masterClrMapping/>
+  </p:clrMapOvr>
+</p:notes>
+</file>
+
+<file path=ppt/notesSlides/notesSlide12.xml><?xml version="1.0" encoding="utf-8"?>
+<p:notes xmlns:a="http://schemas.openxmlformats.org/drawingml/2006/main" xmlns:p="http://schemas.openxmlformats.org/presentationml/2006/main" xmlns:r="http://schemas.openxmlformats.org/officeDocument/2006/relationships">
+  <p:cSld>
+    <p:spTree>
+      <p:nvGrpSpPr>
+        <p:cNvPr id="1" name=""/>
+        <p:cNvGrpSpPr/>
+        <p:nvPr/>
+      </p:nvGrpSpPr>
+      <p:grpSpPr>
+        <a:xfrm>
+          <a:off x="0" y="0"/>
+          <a:ext cx="0" cy="0"/>
+          <a:chOff x="0" y="0"/>
+          <a:chExt cx="0" cy="0"/>
+        </a:xfrm>
+      </p:grpSpPr>
+      <p:sp>
+        <p:nvSpPr>
+          <p:cNvPr id="2" name="Slide Image Placeholder 1"/>
+          <p:cNvSpPr>
+            <a:spLocks noGrp="1"/>
+          </p:cNvSpPr>
+          <p:nvPr>
+            <p:ph type="sldImg" idx="2"/>
+          </p:nvPr>
+        </p:nvSpPr>
+        <p:spPr/>
+      </p:sp>
+      <p:sp>
+        <p:nvSpPr>
+          <p:cNvPr id="3" name="Notes Placeholder 2"/>
+          <p:cNvSpPr>
+            <a:spLocks noGrp="1"/>
+          </p:cNvSpPr>
+          <p:nvPr>
+            <p:ph type="body" idx="1"/>
+          </p:nvPr>
+        </p:nvSpPr>
+        <p:spPr/>
+        <p:txBody>
+          <a:bodyPr/>
+          <a:lstStyle/>
+          <a:p>
+            <a:r>
+              <a:t>Talking points:</a:t>
+            </a:r>
+          </a:p>
+          <a:p>
+            <a:r>
+              <a:t>- Lives, Pac-Man’s death, a new level when the dots are gone</a:t>
+            </a:r>
+          </a:p>
+          <a:p>
+            <a:r>
+              <a:t>- The game’s flow: a state machine, like Flappy Bird’s</a:t>
+            </a:r>
+          </a:p>
+          <a:p>
+            <a:r>
+              <a:t>  - Ready → Play → Dying → Ready or Game Over</a:t>
+            </a:r>
+          </a:p>
+          <a:p>
+            <a:r>
+              <a:t>- Two levels of state machine in one game</a:t>
+            </a:r>
+          </a:p>
+          <a:p>
+            <a:r>
+              <a:t>  - The game’s states, and each ghost’s states</a:t>
+            </a:r>
+          </a:p>
+          <a:p>
+            <a:r>
+              <a:t>  - Ghosts only update in PlayState: while Pac-Man dies, their states pause</a:t>
+            </a:r>
+          </a:p>
+        </p:txBody>
+      </p:sp>
+    </p:spTree>
+  </p:cSld>
+  <p:clrMapOvr>
+    <a:masterClrMapping/>
+  </p:clrMapOvr>
+</p:notes>
+</file>
+
+<file path=ppt/notesSlides/notesSlide13.xml><?xml version="1.0" encoding="utf-8"?>
+<p:notes xmlns:a="http://schemas.openxmlformats.org/drawingml/2006/main" xmlns:p="http://schemas.openxmlformats.org/presentationml/2006/main" xmlns:r="http://schemas.openxmlformats.org/officeDocument/2006/relationships">
+  <p:cSld>
+    <p:spTree>
+      <p:nvGrpSpPr>
+        <p:cNvPr id="1" name=""/>
+        <p:cNvGrpSpPr/>
+        <p:nvPr/>
+      </p:nvGrpSpPr>
+      <p:grpSpPr>
+        <a:xfrm>
+          <a:off x="0" y="0"/>
+          <a:ext cx="0" cy="0"/>
+          <a:chOff x="0" y="0"/>
+          <a:chExt cx="0" cy="0"/>
+        </a:xfrm>
+      </p:grpSpPr>
+      <p:sp>
+        <p:nvSpPr>
+          <p:cNvPr id="2" name="Slide Image Placeholder 1"/>
+          <p:cNvSpPr>
+            <a:spLocks noGrp="1"/>
+          </p:cNvSpPr>
+          <p:nvPr>
+            <p:ph type="sldImg" idx="2"/>
+          </p:nvPr>
+        </p:nvSpPr>
+        <p:spPr/>
+      </p:sp>
+      <p:sp>
+        <p:nvSpPr>
+          <p:cNvPr id="3" name="Notes Placeholder 2"/>
+          <p:cNvSpPr>
+            <a:spLocks noGrp="1"/>
+          </p:cNvSpPr>
+          <p:nvPr>
+            <p:ph type="body" idx="1"/>
+          </p:nvPr>
+        </p:nvSpPr>
+        <p:spPr/>
+        <p:txBody>
+          <a:bodyPr/>
+          <a:lstStyle/>
+          <a:p>
+            <a:r>
+              <a:t>Ask, let them answer in pairs for a minute, then take a few answers. These are the site’s Check yourself questions.</a:t>
+            </a:r>
+          </a:p>
+        </p:txBody>
+      </p:sp>
+    </p:spTree>
+  </p:cSld>
+  <p:clrMapOvr>
+    <a:masterClrMapping/>
+  </p:clrMapOvr>
+</p:notes>
+</file>
+
 <file path=ppt/notesSlides/notesSlide2.xml><?xml version="1.0" encoding="utf-8"?>
 <p:notes xmlns:a="http://schemas.openxmlformats.org/drawingml/2006/main" xmlns:r="http://schemas.openxmlformats.org/officeDocument/2006/relationships" xmlns:mc="http://schemas.openxmlformats.org/markup-compatibility/2006" xmlns:mv="urn:schemas-microsoft-com:mac:vml" xmlns:p="http://schemas.openxmlformats.org/presentationml/2006/main" xmlns:c="http://schemas.openxmlformats.org/drawingml/2006/chart" xmlns:dgm="http://schemas.openxmlformats.org/drawingml/2006/diagram" xmlns:o="urn:schemas-microsoft-com:office:office" xmlns:v="urn:schemas-microsoft-com:vml" xmlns:pvml="urn:schemas-microsoft-com:office:powerpoint" xmlns:com="http://schemas.openxmlformats.org/drawingml/2006/compatibility" xmlns:p14="http://schemas.microsoft.com/office/powerpoint/2010/main" xmlns:p15="http://schemas.microsoft.com/office/powerpoint/2012/main" xmlns:ahyp="http://schemas.microsoft.com/office/drawing/2018/hyperlinkcolor" showMasterPhAnim="0" showMasterSp="0">
   <p:cSld>
@@ -1301,19 +1639,323 @@
           </a:bodyPr>
           <a:lstStyle/>
           <a:p>
-            <a:pPr indent="0" lvl="0" marL="0" rtl="0" algn="l">
-              <a:spcBef>
-                <a:spcPts val="0"/>
-              </a:spcBef>
-              <a:spcAft>
-                <a:spcPts val="0"/>
-              </a:spcAft>
-              <a:buNone/>
-            </a:pPr>
-            <a:r>
-              <a:t/>
-            </a:r>
-            <a:endParaRPr/>
+            <a:r>
+              <a:t>Talking points:</a:t>
+            </a:r>
+          </a:p>
+          <a:p>
+            <a:r>
+              <a:t>- All Source code for today’s game can be found here:</a:t>
+            </a:r>
+          </a:p>
+          <a:p>
+            <a:r>
+              <a:t>  - github.com/Metamate/gar-games (folder 05-pacman)</a:t>
+            </a:r>
+          </a:p>
+          <a:p>
+            <a:r>
+              <a:t>- The game is built up in steps: Pacman0 → Pacman4, and the tests in Pacman.Tests</a:t>
+            </a:r>
+          </a:p>
+          <a:p>
+            <a:r>
+              <a:t>  - Each step is a separate project that adds one concept</a:t>
+            </a:r>
+          </a:p>
+          <a:p>
+            <a:r>
+              <a:t>  - Compare neighbouring steps to see exactly what changed</a:t>
+            </a:r>
+          </a:p>
+          <a:p>
+            <a:r>
+              <a:t>- Pacman4 is the finished game, and the starting point for the exercises</a:t>
+            </a:r>
+          </a:p>
+        </p:txBody>
+      </p:sp>
+    </p:spTree>
+  </p:cSld>
+  <p:clrMapOvr>
+    <a:masterClrMapping/>
+  </p:clrMapOvr>
+</p:notes>
+</file>
+
+<file path=ppt/notesSlides/notesSlide7.xml><?xml version="1.0" encoding="utf-8"?>
+<p:notes xmlns:a="http://schemas.openxmlformats.org/drawingml/2006/main" xmlns:p="http://schemas.openxmlformats.org/presentationml/2006/main" xmlns:r="http://schemas.openxmlformats.org/officeDocument/2006/relationships">
+  <p:cSld>
+    <p:spTree>
+      <p:nvGrpSpPr>
+        <p:cNvPr id="1" name=""/>
+        <p:cNvGrpSpPr/>
+        <p:nvPr/>
+      </p:nvGrpSpPr>
+      <p:grpSpPr>
+        <a:xfrm>
+          <a:off x="0" y="0"/>
+          <a:ext cx="0" cy="0"/>
+          <a:chOff x="0" y="0"/>
+          <a:chExt cx="0" cy="0"/>
+        </a:xfrm>
+      </p:grpSpPr>
+      <p:sp>
+        <p:nvSpPr>
+          <p:cNvPr id="2" name="Slide Image Placeholder 1"/>
+          <p:cNvSpPr>
+            <a:spLocks noGrp="1"/>
+          </p:cNvSpPr>
+          <p:nvPr>
+            <p:ph type="sldImg" idx="2"/>
+          </p:nvPr>
+        </p:nvSpPr>
+        <p:spPr/>
+      </p:sp>
+      <p:sp>
+        <p:nvSpPr>
+          <p:cNvPr id="3" name="Notes Placeholder 2"/>
+          <p:cNvSpPr>
+            <a:spLocks noGrp="1"/>
+          </p:cNvSpPr>
+          <p:nvPr>
+            <p:ph type="body" idx="1"/>
+          </p:nvPr>
+        </p:nvSpPr>
+        <p:spPr/>
+        <p:txBody>
+          <a:bodyPr/>
+          <a:lstStyle/>
+          <a:p>
+            <a:r>
+              <a:t>Talking points:</a:t>
+            </a:r>
+          </a:p>
+          <a:p>
+            <a:r>
+              <a:t>- In the house: waits, then leaves through the door</a:t>
+            </a:r>
+          </a:p>
+          <a:p>
+            <a:r>
+              <a:t>- Scatter: heads for its own corner</a:t>
+            </a:r>
+          </a:p>
+          <a:p>
+            <a:r>
+              <a:t>- Chase: hunts Pac-Man</a:t>
+            </a:r>
+          </a:p>
+          <a:p>
+            <a:r>
+              <a:t>  - Scatter and chase take turns on a schedule: 7 s, 20 s, …</a:t>
+            </a:r>
+          </a:p>
+          <a:p>
+            <a:r>
+              <a:t>- Frightened: blue, slow, random; can be eaten</a:t>
+            </a:r>
+          </a:p>
+          <a:p>
+            <a:r>
+              <a:t>- Eaten: only the eyes, racing back to the house</a:t>
+            </a:r>
+          </a:p>
+          <a:p>
+            <a:r>
+              <a:t>- At each tile centre: never turn back, and take the direction closest to a target tile</a:t>
+            </a:r>
+          </a:p>
+          <a:p>
+            <a:r>
+              <a:t>  - The mode decides the target</a:t>
+            </a:r>
+          </a:p>
+        </p:txBody>
+      </p:sp>
+    </p:spTree>
+  </p:cSld>
+  <p:clrMapOvr>
+    <a:masterClrMapping/>
+  </p:clrMapOvr>
+</p:notes>
+</file>
+
+<file path=ppt/notesSlides/notesSlide8.xml><?xml version="1.0" encoding="utf-8"?>
+<p:notes xmlns:a="http://schemas.openxmlformats.org/drawingml/2006/main" xmlns:p="http://schemas.openxmlformats.org/presentationml/2006/main" xmlns:r="http://schemas.openxmlformats.org/officeDocument/2006/relationships">
+  <p:cSld>
+    <p:spTree>
+      <p:nvGrpSpPr>
+        <p:cNvPr id="1" name=""/>
+        <p:cNvGrpSpPr/>
+        <p:nvPr/>
+      </p:nvGrpSpPr>
+      <p:grpSpPr>
+        <a:xfrm>
+          <a:off x="0" y="0"/>
+          <a:ext cx="0" cy="0"/>
+          <a:chOff x="0" y="0"/>
+          <a:chExt cx="0" cy="0"/>
+        </a:xfrm>
+      </p:grpSpPr>
+      <p:sp>
+        <p:nvSpPr>
+          <p:cNvPr id="2" name="Slide Image Placeholder 1"/>
+          <p:cNvSpPr>
+            <a:spLocks noGrp="1"/>
+          </p:cNvSpPr>
+          <p:nvPr>
+            <p:ph type="sldImg" idx="2"/>
+          </p:nvPr>
+        </p:nvSpPr>
+        <p:spPr/>
+      </p:sp>
+      <p:sp>
+        <p:nvSpPr>
+          <p:cNvPr id="3" name="Notes Placeholder 2"/>
+          <p:cNvSpPr>
+            <a:spLocks noGrp="1"/>
+          </p:cNvSpPr>
+          <p:nvPr>
+            <p:ph type="body" idx="1"/>
+          </p:nvPr>
+        </p:nvSpPr>
+        <p:spPr/>
+        <p:txBody>
+          <a:bodyPr/>
+          <a:lstStyle/>
+          <a:p>
+            <a:r>
+              <a:t>Talking points:</a:t>
+            </a:r>
+          </a:p>
+          <a:p>
+            <a:r>
+              <a:t>- One mode is spread over many methods</a:t>
+            </a:r>
+          </a:p>
+          <a:p>
+            <a:r>
+              <a:t>  - To understand frightened ghosts, read seven methods</a:t>
+            </a:r>
+          </a:p>
+          <a:p>
+            <a:r>
+              <a:t>- Fields that belong to one mode</a:t>
+            </a:r>
+          </a:p>
+          <a:p>
+            <a:r>
+              <a:t>  - _houseTimer, _frightenedTimer, _enteringHouse: always there</a:t>
+            </a:r>
+          </a:p>
+          <a:p>
+            <a:r>
+              <a:t>- A new mode touches every switch</a:t>
+            </a:r>
+          </a:p>
+          <a:p>
+            <a:r>
+              <a:t>  - Miss one, and the compiler won’t tell you</a:t>
+            </a:r>
+          </a:p>
+          <a:p>
+            <a:r>
+              <a:t>- Pong’s string-based game state, all over again</a:t>
+            </a:r>
+          </a:p>
+        </p:txBody>
+      </p:sp>
+    </p:spTree>
+  </p:cSld>
+  <p:clrMapOvr>
+    <a:masterClrMapping/>
+  </p:clrMapOvr>
+</p:notes>
+</file>
+
+<file path=ppt/notesSlides/notesSlide9.xml><?xml version="1.0" encoding="utf-8"?>
+<p:notes xmlns:a="http://schemas.openxmlformats.org/drawingml/2006/main" xmlns:p="http://schemas.openxmlformats.org/presentationml/2006/main" xmlns:r="http://schemas.openxmlformats.org/officeDocument/2006/relationships">
+  <p:cSld>
+    <p:spTree>
+      <p:nvGrpSpPr>
+        <p:cNvPr id="1" name=""/>
+        <p:cNvGrpSpPr/>
+        <p:nvPr/>
+      </p:nvGrpSpPr>
+      <p:grpSpPr>
+        <a:xfrm>
+          <a:off x="0" y="0"/>
+          <a:ext cx="0" cy="0"/>
+          <a:chOff x="0" y="0"/>
+          <a:chExt cx="0" cy="0"/>
+        </a:xfrm>
+      </p:grpSpPr>
+      <p:sp>
+        <p:nvSpPr>
+          <p:cNvPr id="2" name="Slide Image Placeholder 1"/>
+          <p:cNvSpPr>
+            <a:spLocks noGrp="1"/>
+          </p:cNvSpPr>
+          <p:nvPr>
+            <p:ph type="sldImg" idx="2"/>
+          </p:nvPr>
+        </p:nvSpPr>
+        <p:spPr/>
+      </p:sp>
+      <p:sp>
+        <p:nvSpPr>
+          <p:cNvPr id="3" name="Notes Placeholder 2"/>
+          <p:cNvSpPr>
+            <a:spLocks noGrp="1"/>
+          </p:cNvSpPr>
+          <p:nvPr>
+            <p:ph type="body" idx="1"/>
+          </p:nvPr>
+        </p:nvSpPr>
+        <p:spPr/>
+        <p:txBody>
+          <a:bodyPr/>
+          <a:lstStyle/>
+          <a:p>
+            <a:r>
+              <a:t>Talking points:</a:t>
+            </a:r>
+          </a:p>
+          <a:p>
+            <a:r>
+              <a:t>- The states decide the transitions</a:t>
+            </a:r>
+          </a:p>
+          <a:p>
+            <a:r>
+              <a:t>  - Ghost doesn’t know which states exist</a:t>
+            </a:r>
+          </a:p>
+          <a:p>
+            <a:r>
+              <a:t>- The same event, handled differently</a:t>
+            </a:r>
+          </a:p>
+          <a:p>
+            <a:r>
+              <a:t>  - Power pellet: scatter and chase get frightened, frightened starts over, eaten ignores it</a:t>
+            </a:r>
+          </a:p>
+          <a:p>
+            <a:r>
+              <a:t>- Enter and Exit: start and clean up, in one place</a:t>
+            </a:r>
+          </a:p>
+          <a:p>
+            <a:r>
+              <a:t>- Each state is small, and can be read on its own</a:t>
+            </a:r>
+          </a:p>
+          <a:p>
+            <a:r>
+              <a:t>- Pacman1 → Pacman2: World didn’t change at all</a:t>
+            </a:r>
           </a:p>
         </p:txBody>
       </p:sp>
@@ -5055,7 +5697,7 @@
         <p:spPr>
           <a:xfrm>
             <a:off x="311700" y="885950"/>
-            <a:ext cx="8520600" cy="4023300"/>
+            <a:ext cx="8520600" cy="521208"/>
           </a:xfrm>
           <a:prstGeom prst="rect">
             <a:avLst/>
@@ -5079,111 +5721,467 @@
             </a:pPr>
             <a:r>
               <a:rPr lang="en"/>
-              <a:t>One mode is spread over many methods</a:t>
+              <a:t>A sixth mode: a short pause when a ghost is eaten. What do you change?</a:t>
             </a:r>
             <a:endParaRPr/>
           </a:p>
-          <a:p>
-            <a:pPr indent="-317500" lvl="1" marL="914400" rtl="0" algn="l">
-              <a:spcBef>
-                <a:spcPts val="0"/>
-              </a:spcBef>
-              <a:spcAft>
-                <a:spcPts val="0"/>
-              </a:spcAft>
-              <a:buSzPts val="1400"/>
-              <a:buChar char="○"/>
-            </a:pPr>
-            <a:r>
-              <a:rPr lang="en"/>
-              <a:t>To understand frightened ghosts, read seven methods</a:t>
-            </a:r>
-            <a:endParaRPr/>
-          </a:p>
-          <a:p>
-            <a:pPr indent="-330200" lvl="0" marL="457200" rtl="0" algn="l">
-              <a:spcBef>
-                <a:spcPts val="0"/>
-              </a:spcBef>
-              <a:spcAft>
-                <a:spcPts val="0"/>
-              </a:spcAft>
-              <a:buSzPts val="1600"/>
-              <a:buChar char="●"/>
-            </a:pPr>
-            <a:r>
-              <a:rPr lang="en"/>
-              <a:t>Fields that belong to one mode</a:t>
-            </a:r>
-            <a:endParaRPr/>
-          </a:p>
-          <a:p>
-            <a:pPr indent="-317500" lvl="1" marL="914400" rtl="0" algn="l">
-              <a:spcBef>
-                <a:spcPts val="0"/>
-              </a:spcBef>
-              <a:spcAft>
-                <a:spcPts val="0"/>
-              </a:spcAft>
-              <a:buSzPts val="1400"/>
-              <a:buChar char="○"/>
-            </a:pPr>
-            <a:r>
-              <a:rPr lang="en"/>
-              <a:t>_houseTimer, _frightenedTimer, _enteringHouse: always there</a:t>
-            </a:r>
-            <a:endParaRPr/>
-          </a:p>
-          <a:p>
-            <a:pPr indent="-330200" lvl="0" marL="457200" rtl="0" algn="l">
-              <a:spcBef>
-                <a:spcPts val="0"/>
-              </a:spcBef>
-              <a:spcAft>
-                <a:spcPts val="0"/>
-              </a:spcAft>
-              <a:buSzPts val="1600"/>
-              <a:buChar char="●"/>
-            </a:pPr>
-            <a:r>
-              <a:rPr lang="en"/>
-              <a:t>A new mode touches every switch</a:t>
-            </a:r>
-            <a:endParaRPr/>
-          </a:p>
-          <a:p>
-            <a:pPr indent="-317500" lvl="1" marL="914400" rtl="0" algn="l">
-              <a:spcBef>
-                <a:spcPts val="0"/>
-              </a:spcBef>
-              <a:spcAft>
-                <a:spcPts val="0"/>
-              </a:spcAft>
-              <a:buSzPts val="1400"/>
-              <a:buChar char="○"/>
-            </a:pPr>
-            <a:r>
-              <a:rPr lang="en"/>
-              <a:t>Miss one, and the compiler won’t tell you</a:t>
-            </a:r>
-            <a:endParaRPr/>
-          </a:p>
-          <a:p>
-            <a:pPr indent="-330200" lvl="0" marL="457200" rtl="0" algn="l">
-              <a:spcBef>
-                <a:spcPts val="0"/>
-              </a:spcBef>
-              <a:spcAft>
-                <a:spcPts val="0"/>
-              </a:spcAft>
-              <a:buSzPts val="1600"/>
-              <a:buChar char="●"/>
-            </a:pPr>
-            <a:r>
-              <a:rPr lang="en"/>
-              <a:t>Pong’s string-based game state, all over again</a:t>
-            </a:r>
-            <a:endParaRPr/>
+        </p:txBody>
+      </p:sp>
+      <p:sp>
+        <p:nvSpPr>
+          <p:cNvPr id="295" name="Rounded Rectangle 294"/>
+          <p:cNvSpPr/>
+          <p:nvPr/>
+        </p:nvSpPr>
+        <p:spPr>
+          <a:xfrm>
+            <a:off x="411480" y="1463040"/>
+            <a:ext cx="1280160" cy="548640"/>
+          </a:xfrm>
+          <a:prstGeom prst="roundRect">
+            <a:avLst>
+              <a:gd name="adj" fmla="val 12000"/>
+            </a:avLst>
+          </a:prstGeom>
+          <a:solidFill>
+            <a:srgbClr val="2E3338"/>
+          </a:solidFill>
+          <a:ln w="25400">
+            <a:solidFill>
+              <a:srgbClr val="D45D35"/>
+            </a:solidFill>
+          </a:ln>
+          <a:effectLst/>
+        </p:spPr>
+        <p:style>
+          <a:lnRef idx="1">
+            <a:schemeClr val="accent1"/>
+          </a:lnRef>
+          <a:fillRef idx="3">
+            <a:schemeClr val="accent1"/>
+          </a:fillRef>
+          <a:effectRef idx="2">
+            <a:schemeClr val="accent1"/>
+          </a:effectRef>
+          <a:fontRef idx="minor">
+            <a:schemeClr val="lt1"/>
+          </a:fontRef>
+        </p:style>
+        <p:txBody>
+          <a:bodyPr rtlCol="0" anchor="ctr" wrap="square" lIns="73152" rIns="73152"/>
+          <a:lstStyle/>
+          <a:p>
+            <a:pPr algn="ctr"/>
+            <a:r>
+              <a:rPr sz="1300" b="1">
+                <a:solidFill>
+                  <a:srgbClr val="DEE2E6"/>
+                </a:solidFill>
+              </a:rPr>
+              <a:t>switch in</a:t>
+            </a:r>
+          </a:p>
+          <a:p>
+            <a:pPr algn="ctr"/>
+            <a:r>
+              <a:rPr sz="1100" b="0">
+                <a:solidFill>
+                  <a:srgbClr val="9AA3AB"/>
+                </a:solidFill>
+              </a:rPr>
+              <a:t>Update</a:t>
+            </a:r>
+          </a:p>
+        </p:txBody>
+      </p:sp>
+      <p:sp>
+        <p:nvSpPr>
+          <p:cNvPr id="296" name="Rounded Rectangle 295"/>
+          <p:cNvSpPr/>
+          <p:nvPr/>
+        </p:nvSpPr>
+        <p:spPr>
+          <a:xfrm>
+            <a:off x="1810512" y="1463040"/>
+            <a:ext cx="1280160" cy="548640"/>
+          </a:xfrm>
+          <a:prstGeom prst="roundRect">
+            <a:avLst>
+              <a:gd name="adj" fmla="val 12000"/>
+            </a:avLst>
+          </a:prstGeom>
+          <a:solidFill>
+            <a:srgbClr val="2E3338"/>
+          </a:solidFill>
+          <a:ln w="25400">
+            <a:solidFill>
+              <a:srgbClr val="D45D35"/>
+            </a:solidFill>
+          </a:ln>
+          <a:effectLst/>
+        </p:spPr>
+        <p:style>
+          <a:lnRef idx="1">
+            <a:schemeClr val="accent1"/>
+          </a:lnRef>
+          <a:fillRef idx="3">
+            <a:schemeClr val="accent1"/>
+          </a:fillRef>
+          <a:effectRef idx="2">
+            <a:schemeClr val="accent1"/>
+          </a:effectRef>
+          <a:fontRef idx="minor">
+            <a:schemeClr val="lt1"/>
+          </a:fontRef>
+        </p:style>
+        <p:txBody>
+          <a:bodyPr rtlCol="0" anchor="ctr" wrap="square" lIns="73152" rIns="73152"/>
+          <a:lstStyle/>
+          <a:p>
+            <a:pPr algn="ctr"/>
+            <a:r>
+              <a:rPr sz="1300" b="1">
+                <a:solidFill>
+                  <a:srgbClr val="DEE2E6"/>
+                </a:solidFill>
+              </a:rPr>
+              <a:t>switch in</a:t>
+            </a:r>
+          </a:p>
+          <a:p>
+            <a:pPr algn="ctr"/>
+            <a:r>
+              <a:rPr sz="1100" b="0">
+                <a:solidFill>
+                  <a:srgbClr val="9AA3AB"/>
+                </a:solidFill>
+              </a:rPr>
+              <a:t>ChooseDirection</a:t>
+            </a:r>
+          </a:p>
+        </p:txBody>
+      </p:sp>
+      <p:sp>
+        <p:nvSpPr>
+          <p:cNvPr id="297" name="Rounded Rectangle 296"/>
+          <p:cNvSpPr/>
+          <p:nvPr/>
+        </p:nvSpPr>
+        <p:spPr>
+          <a:xfrm>
+            <a:off x="3209544" y="1463040"/>
+            <a:ext cx="1280160" cy="548640"/>
+          </a:xfrm>
+          <a:prstGeom prst="roundRect">
+            <a:avLst>
+              <a:gd name="adj" fmla="val 12000"/>
+            </a:avLst>
+          </a:prstGeom>
+          <a:solidFill>
+            <a:srgbClr val="2E3338"/>
+          </a:solidFill>
+          <a:ln w="25400">
+            <a:solidFill>
+              <a:srgbClr val="D45D35"/>
+            </a:solidFill>
+          </a:ln>
+          <a:effectLst/>
+        </p:spPr>
+        <p:style>
+          <a:lnRef idx="1">
+            <a:schemeClr val="accent1"/>
+          </a:lnRef>
+          <a:fillRef idx="3">
+            <a:schemeClr val="accent1"/>
+          </a:fillRef>
+          <a:effectRef idx="2">
+            <a:schemeClr val="accent1"/>
+          </a:effectRef>
+          <a:fontRef idx="minor">
+            <a:schemeClr val="lt1"/>
+          </a:fontRef>
+        </p:style>
+        <p:txBody>
+          <a:bodyPr rtlCol="0" anchor="ctr" wrap="square" lIns="73152" rIns="73152"/>
+          <a:lstStyle/>
+          <a:p>
+            <a:pPr algn="ctr"/>
+            <a:r>
+              <a:rPr sz="1300" b="1">
+                <a:solidFill>
+                  <a:srgbClr val="DEE2E6"/>
+                </a:solidFill>
+              </a:rPr>
+              <a:t>switch in</a:t>
+            </a:r>
+          </a:p>
+          <a:p>
+            <a:pPr algn="ctr"/>
+            <a:r>
+              <a:rPr sz="1100" b="0">
+                <a:solidFill>
+                  <a:srgbClr val="9AA3AB"/>
+                </a:solidFill>
+              </a:rPr>
+              <a:t>OnPowerPellet</a:t>
+            </a:r>
+          </a:p>
+        </p:txBody>
+      </p:sp>
+      <p:sp>
+        <p:nvSpPr>
+          <p:cNvPr id="298" name="Rounded Rectangle 297"/>
+          <p:cNvSpPr/>
+          <p:nvPr/>
+        </p:nvSpPr>
+        <p:spPr>
+          <a:xfrm>
+            <a:off x="4608576" y="1463040"/>
+            <a:ext cx="1280160" cy="548640"/>
+          </a:xfrm>
+          <a:prstGeom prst="roundRect">
+            <a:avLst>
+              <a:gd name="adj" fmla="val 12000"/>
+            </a:avLst>
+          </a:prstGeom>
+          <a:solidFill>
+            <a:srgbClr val="2E3338"/>
+          </a:solidFill>
+          <a:ln w="25400">
+            <a:solidFill>
+              <a:srgbClr val="D45D35"/>
+            </a:solidFill>
+          </a:ln>
+          <a:effectLst/>
+        </p:spPr>
+        <p:style>
+          <a:lnRef idx="1">
+            <a:schemeClr val="accent1"/>
+          </a:lnRef>
+          <a:fillRef idx="3">
+            <a:schemeClr val="accent1"/>
+          </a:fillRef>
+          <a:effectRef idx="2">
+            <a:schemeClr val="accent1"/>
+          </a:effectRef>
+          <a:fontRef idx="minor">
+            <a:schemeClr val="lt1"/>
+          </a:fontRef>
+        </p:style>
+        <p:txBody>
+          <a:bodyPr rtlCol="0" anchor="ctr" wrap="square" lIns="73152" rIns="73152"/>
+          <a:lstStyle/>
+          <a:p>
+            <a:pPr algn="ctr"/>
+            <a:r>
+              <a:rPr sz="1300" b="1">
+                <a:solidFill>
+                  <a:srgbClr val="DEE2E6"/>
+                </a:solidFill>
+              </a:rPr>
+              <a:t>switch in</a:t>
+            </a:r>
+          </a:p>
+          <a:p>
+            <a:pPr algn="ctr"/>
+            <a:r>
+              <a:rPr sz="1100" b="0">
+                <a:solidFill>
+                  <a:srgbClr val="9AA3AB"/>
+                </a:solidFill>
+              </a:rPr>
+              <a:t>Touch</a:t>
+            </a:r>
+          </a:p>
+        </p:txBody>
+      </p:sp>
+      <p:sp>
+        <p:nvSpPr>
+          <p:cNvPr id="299" name="Rounded Rectangle 298"/>
+          <p:cNvSpPr/>
+          <p:nvPr/>
+        </p:nvSpPr>
+        <p:spPr>
+          <a:xfrm>
+            <a:off x="6007608" y="1463040"/>
+            <a:ext cx="1280160" cy="548640"/>
+          </a:xfrm>
+          <a:prstGeom prst="roundRect">
+            <a:avLst>
+              <a:gd name="adj" fmla="val 12000"/>
+            </a:avLst>
+          </a:prstGeom>
+          <a:solidFill>
+            <a:srgbClr val="2E3338"/>
+          </a:solidFill>
+          <a:ln w="25400">
+            <a:solidFill>
+              <a:srgbClr val="D45D35"/>
+            </a:solidFill>
+          </a:ln>
+          <a:effectLst/>
+        </p:spPr>
+        <p:style>
+          <a:lnRef idx="1">
+            <a:schemeClr val="accent1"/>
+          </a:lnRef>
+          <a:fillRef idx="3">
+            <a:schemeClr val="accent1"/>
+          </a:fillRef>
+          <a:effectRef idx="2">
+            <a:schemeClr val="accent1"/>
+          </a:effectRef>
+          <a:fontRef idx="minor">
+            <a:schemeClr val="lt1"/>
+          </a:fontRef>
+        </p:style>
+        <p:txBody>
+          <a:bodyPr rtlCol="0" anchor="ctr" wrap="square" lIns="73152" rIns="73152"/>
+          <a:lstStyle/>
+          <a:p>
+            <a:pPr algn="ctr"/>
+            <a:r>
+              <a:rPr sz="1300" b="1">
+                <a:solidFill>
+                  <a:srgbClr val="DEE2E6"/>
+                </a:solidFill>
+              </a:rPr>
+              <a:t>switch in</a:t>
+            </a:r>
+          </a:p>
+          <a:p>
+            <a:pPr algn="ctr"/>
+            <a:r>
+              <a:rPr sz="1100" b="0">
+                <a:solidFill>
+                  <a:srgbClr val="9AA3AB"/>
+                </a:solidFill>
+              </a:rPr>
+              <a:t>Look</a:t>
+            </a:r>
+          </a:p>
+        </p:txBody>
+      </p:sp>
+      <p:sp>
+        <p:nvSpPr>
+          <p:cNvPr id="300" name="Rounded Rectangle 299"/>
+          <p:cNvSpPr/>
+          <p:nvPr/>
+        </p:nvSpPr>
+        <p:spPr>
+          <a:xfrm>
+            <a:off x="7406640" y="1463040"/>
+            <a:ext cx="1280160" cy="548640"/>
+          </a:xfrm>
+          <a:prstGeom prst="roundRect">
+            <a:avLst>
+              <a:gd name="adj" fmla="val 12000"/>
+            </a:avLst>
+          </a:prstGeom>
+          <a:solidFill>
+            <a:srgbClr val="2E3338"/>
+          </a:solidFill>
+          <a:ln w="25400">
+            <a:solidFill>
+              <a:srgbClr val="D45D35"/>
+            </a:solidFill>
+          </a:ln>
+          <a:effectLst/>
+        </p:spPr>
+        <p:style>
+          <a:lnRef idx="1">
+            <a:schemeClr val="accent1"/>
+          </a:lnRef>
+          <a:fillRef idx="3">
+            <a:schemeClr val="accent1"/>
+          </a:fillRef>
+          <a:effectRef idx="2">
+            <a:schemeClr val="accent1"/>
+          </a:effectRef>
+          <a:fontRef idx="minor">
+            <a:schemeClr val="lt1"/>
+          </a:fontRef>
+        </p:style>
+        <p:txBody>
+          <a:bodyPr rtlCol="0" anchor="ctr" wrap="square" lIns="73152" rIns="73152"/>
+          <a:lstStyle/>
+          <a:p>
+            <a:pPr algn="ctr"/>
+            <a:r>
+              <a:rPr sz="1300" b="1">
+                <a:solidFill>
+                  <a:srgbClr val="DEE2E6"/>
+                </a:solidFill>
+              </a:rPr>
+              <a:t>switch in</a:t>
+            </a:r>
+          </a:p>
+          <a:p>
+            <a:pPr algn="ctr"/>
+            <a:r>
+              <a:rPr sz="1100" b="0">
+                <a:solidFill>
+                  <a:srgbClr val="9AA3AB"/>
+                </a:solidFill>
+              </a:rPr>
+              <a:t>SetMode</a:t>
+            </a:r>
+          </a:p>
+        </p:txBody>
+      </p:sp>
+      <p:sp>
+        <p:nvSpPr>
+          <p:cNvPr id="301" name="TextBox 300"/>
+          <p:cNvSpPr txBox="1"/>
+          <p:nvPr/>
+        </p:nvSpPr>
+        <p:spPr>
+          <a:xfrm>
+            <a:off x="411480" y="2240280"/>
+            <a:ext cx="8321040" cy="1097280"/>
+          </a:xfrm>
+          <a:prstGeom prst="rect">
+            <a:avLst/>
+          </a:prstGeom>
+          <a:noFill/>
+        </p:spPr>
+        <p:txBody>
+          <a:bodyPr wrap="square">
+            <a:spAutoFit/>
+          </a:bodyPr>
+          <a:lstStyle/>
+          <a:p>
+            <a:pPr algn="ctr"/>
+            <a:r>
+              <a:rPr sz="1500" b="0" i="0">
+                <a:solidFill>
+                  <a:srgbClr val="9AA3AB"/>
+                </a:solidFill>
+              </a:rPr>
+              <a:t>Every switch, and nothing tells you if you miss one.</a:t>
+            </a:r>
+          </a:p>
+          <a:p>
+            <a:pPr algn="ctr"/>
+            <a:r>
+              <a:rPr sz="1500" b="0" i="0">
+                <a:solidFill>
+                  <a:srgbClr val="9AA3AB"/>
+                </a:solidFill>
+              </a:rPr>
+              <a:t>Fields that belong to one mode live in the ghost all the time.</a:t>
+            </a:r>
+          </a:p>
+          <a:p>
+            <a:pPr algn="ctr"/>
+            <a:r>
+              <a:rPr sz="1500" b="0" i="0">
+                <a:solidFill>
+                  <a:srgbClr val="9AA3AB"/>
+                </a:solidFill>
+              </a:rPr>
+              <a:t>Pong’s string-based game state, all over again.</a:t>
+            </a:r>
           </a:p>
         </p:txBody>
       </p:sp>
@@ -7083,7 +8081,7 @@
         <p:spPr>
           <a:xfrm>
             <a:off x="311700" y="885950"/>
-            <a:ext cx="8520600" cy="4023300"/>
+            <a:ext cx="8520600" cy="521208"/>
           </a:xfrm>
           <a:prstGeom prst="rect">
             <a:avLst/>
@@ -7107,111 +8105,260 @@
             </a:pPr>
             <a:r>
               <a:rPr lang="en"/>
-              <a:t>The states decide the transitions</a:t>
+              <a:t>The states decide the transitions; the ghost only forwards to its state.</a:t>
             </a:r>
             <a:endParaRPr/>
           </a:p>
-          <a:p>
-            <a:pPr indent="-317500" lvl="1" marL="914400" rtl="0" algn="l">
-              <a:spcBef>
-                <a:spcPts val="0"/>
-              </a:spcBef>
-              <a:spcAft>
-                <a:spcPts val="0"/>
-              </a:spcAft>
-              <a:buSzPts val="1400"/>
-              <a:buChar char="○"/>
-            </a:pPr>
-            <a:r>
-              <a:rPr lang="en"/>
-              <a:t>Ghost doesn’t know which states exist</a:t>
-            </a:r>
-            <a:endParaRPr/>
-          </a:p>
-          <a:p>
-            <a:pPr indent="-330200" lvl="0" marL="457200" rtl="0" algn="l">
-              <a:spcBef>
-                <a:spcPts val="0"/>
-              </a:spcBef>
-              <a:spcAft>
-                <a:spcPts val="0"/>
-              </a:spcAft>
-              <a:buSzPts val="1600"/>
-              <a:buChar char="●"/>
-            </a:pPr>
-            <a:r>
-              <a:rPr lang="en"/>
-              <a:t>The same event, handled differently</a:t>
-            </a:r>
-            <a:endParaRPr/>
-          </a:p>
-          <a:p>
-            <a:pPr indent="-317500" lvl="1" marL="914400" rtl="0" algn="l">
-              <a:spcBef>
-                <a:spcPts val="0"/>
-              </a:spcBef>
-              <a:spcAft>
-                <a:spcPts val="0"/>
-              </a:spcAft>
-              <a:buSzPts val="1400"/>
-              <a:buChar char="○"/>
-            </a:pPr>
-            <a:r>
-              <a:rPr lang="en"/>
-              <a:t>Power pellet: scatter and chase get frightened, frightened starts over, eaten ignores it</a:t>
-            </a:r>
-            <a:endParaRPr/>
-          </a:p>
-          <a:p>
-            <a:pPr indent="-330200" lvl="0" marL="457200" rtl="0" algn="l">
-              <a:spcBef>
-                <a:spcPts val="0"/>
-              </a:spcBef>
-              <a:spcAft>
-                <a:spcPts val="0"/>
-              </a:spcAft>
-              <a:buSzPts val="1600"/>
-              <a:buChar char="●"/>
-            </a:pPr>
-            <a:r>
-              <a:rPr lang="en"/>
-              <a:t>Enter and Exit: start and clean up, in one place</a:t>
-            </a:r>
-            <a:endParaRPr/>
-          </a:p>
-          <a:p>
-            <a:pPr indent="-330200" lvl="0" marL="457200" rtl="0" algn="l">
-              <a:spcBef>
-                <a:spcPts val="0"/>
-              </a:spcBef>
-              <a:spcAft>
-                <a:spcPts val="0"/>
-              </a:spcAft>
-              <a:buSzPts val="1600"/>
-              <a:buChar char="●"/>
-            </a:pPr>
-            <a:r>
-              <a:rPr lang="en"/>
-              <a:t>Each state is small, and can be read on its own</a:t>
-            </a:r>
-            <a:endParaRPr/>
-          </a:p>
-          <a:p>
-            <a:pPr indent="-330200" lvl="0" marL="457200" rtl="0" algn="l">
-              <a:spcBef>
-                <a:spcPts val="0"/>
-              </a:spcBef>
-              <a:spcAft>
-                <a:spcPts val="0"/>
-              </a:spcAft>
-              <a:buSzPts val="1600"/>
-              <a:buChar char="●"/>
-            </a:pPr>
-            <a:r>
-              <a:rPr lang="en"/>
-              <a:t>Pacman1 → Pacman2: World didn’t change at all</a:t>
-            </a:r>
-            <a:endParaRPr/>
+        </p:txBody>
+      </p:sp>
+      <p:sp>
+        <p:nvSpPr>
+          <p:cNvPr id="295" name="Rounded Rectangle 294"/>
+          <p:cNvSpPr/>
+          <p:nvPr/>
+        </p:nvSpPr>
+        <p:spPr>
+          <a:xfrm>
+            <a:off x="411480" y="1463040"/>
+            <a:ext cx="2651760" cy="1097280"/>
+          </a:xfrm>
+          <a:prstGeom prst="roundRect">
+            <a:avLst>
+              <a:gd name="adj" fmla="val 12000"/>
+            </a:avLst>
+          </a:prstGeom>
+          <a:solidFill>
+            <a:srgbClr val="2E3338"/>
+          </a:solidFill>
+          <a:ln>
+            <a:noFill/>
+          </a:ln>
+          <a:effectLst/>
+        </p:spPr>
+        <p:style>
+          <a:lnRef idx="1">
+            <a:schemeClr val="accent1"/>
+          </a:lnRef>
+          <a:fillRef idx="3">
+            <a:schemeClr val="accent1"/>
+          </a:fillRef>
+          <a:effectRef idx="2">
+            <a:schemeClr val="accent1"/>
+          </a:effectRef>
+          <a:fontRef idx="minor">
+            <a:schemeClr val="lt1"/>
+          </a:fontRef>
+        </p:style>
+        <p:txBody>
+          <a:bodyPr rtlCol="0" anchor="ctr" wrap="square" lIns="73152" rIns="73152"/>
+          <a:lstStyle/>
+          <a:p>
+            <a:pPr algn="ctr"/>
+            <a:r>
+              <a:rPr sz="1500" b="1">
+                <a:solidFill>
+                  <a:srgbClr val="DEE2E6"/>
+                </a:solidFill>
+              </a:rPr>
+              <a:t>One place per mode</a:t>
+            </a:r>
+          </a:p>
+          <a:p>
+            <a:pPr algn="ctr"/>
+            <a:r>
+              <a:rPr sz="1300" b="0">
+                <a:solidFill>
+                  <a:srgbClr val="9AA3AB"/>
+                </a:solidFill>
+              </a:rPr>
+              <a:t>read a state on its own</a:t>
+            </a:r>
+          </a:p>
+        </p:txBody>
+      </p:sp>
+      <p:sp>
+        <p:nvSpPr>
+          <p:cNvPr id="296" name="Rounded Rectangle 295"/>
+          <p:cNvSpPr/>
+          <p:nvPr/>
+        </p:nvSpPr>
+        <p:spPr>
+          <a:xfrm>
+            <a:off x="3246120" y="1463040"/>
+            <a:ext cx="2651760" cy="1097280"/>
+          </a:xfrm>
+          <a:prstGeom prst="roundRect">
+            <a:avLst>
+              <a:gd name="adj" fmla="val 12000"/>
+            </a:avLst>
+          </a:prstGeom>
+          <a:solidFill>
+            <a:srgbClr val="2E3338"/>
+          </a:solidFill>
+          <a:ln>
+            <a:noFill/>
+          </a:ln>
+          <a:effectLst/>
+        </p:spPr>
+        <p:style>
+          <a:lnRef idx="1">
+            <a:schemeClr val="accent1"/>
+          </a:lnRef>
+          <a:fillRef idx="3">
+            <a:schemeClr val="accent1"/>
+          </a:fillRef>
+          <a:effectRef idx="2">
+            <a:schemeClr val="accent1"/>
+          </a:effectRef>
+          <a:fontRef idx="minor">
+            <a:schemeClr val="lt1"/>
+          </a:fontRef>
+        </p:style>
+        <p:txBody>
+          <a:bodyPr rtlCol="0" anchor="ctr" wrap="square" lIns="73152" rIns="73152"/>
+          <a:lstStyle/>
+          <a:p>
+            <a:pPr algn="ctr"/>
+            <a:r>
+              <a:rPr sz="1500" b="1">
+                <a:solidFill>
+                  <a:srgbClr val="DEE2E6"/>
+                </a:solidFill>
+              </a:rPr>
+              <a:t>Same event, different handling</a:t>
+            </a:r>
+          </a:p>
+          <a:p>
+            <a:pPr algn="ctr"/>
+            <a:r>
+              <a:rPr sz="1300" b="0">
+                <a:solidFill>
+                  <a:srgbClr val="9AA3AB"/>
+                </a:solidFill>
+              </a:rPr>
+              <a:t>a power pellet: frightened,</a:t>
+            </a:r>
+          </a:p>
+          <a:p>
+            <a:pPr algn="ctr"/>
+            <a:r>
+              <a:rPr sz="1300" b="0">
+                <a:solidFill>
+                  <a:srgbClr val="9AA3AB"/>
+                </a:solidFill>
+              </a:rPr>
+              <a:t>start over, or ignored</a:t>
+            </a:r>
+          </a:p>
+        </p:txBody>
+      </p:sp>
+      <p:sp>
+        <p:nvSpPr>
+          <p:cNvPr id="297" name="Rounded Rectangle 296"/>
+          <p:cNvSpPr/>
+          <p:nvPr/>
+        </p:nvSpPr>
+        <p:spPr>
+          <a:xfrm>
+            <a:off x="6080760" y="1463040"/>
+            <a:ext cx="2651760" cy="1097280"/>
+          </a:xfrm>
+          <a:prstGeom prst="roundRect">
+            <a:avLst>
+              <a:gd name="adj" fmla="val 12000"/>
+            </a:avLst>
+          </a:prstGeom>
+          <a:solidFill>
+            <a:srgbClr val="2E3338"/>
+          </a:solidFill>
+          <a:ln>
+            <a:noFill/>
+          </a:ln>
+          <a:effectLst/>
+        </p:spPr>
+        <p:style>
+          <a:lnRef idx="1">
+            <a:schemeClr val="accent1"/>
+          </a:lnRef>
+          <a:fillRef idx="3">
+            <a:schemeClr val="accent1"/>
+          </a:fillRef>
+          <a:effectRef idx="2">
+            <a:schemeClr val="accent1"/>
+          </a:effectRef>
+          <a:fontRef idx="minor">
+            <a:schemeClr val="lt1"/>
+          </a:fontRef>
+        </p:style>
+        <p:txBody>
+          <a:bodyPr rtlCol="0" anchor="ctr" wrap="square" lIns="73152" rIns="73152"/>
+          <a:lstStyle/>
+          <a:p>
+            <a:pPr algn="ctr"/>
+            <a:r>
+              <a:rPr sz="1500" b="1">
+                <a:solidFill>
+                  <a:srgbClr val="DEE2E6"/>
+                </a:solidFill>
+              </a:rPr>
+              <a:t>Enter and Exit</a:t>
+            </a:r>
+          </a:p>
+          <a:p>
+            <a:pPr algn="ctr"/>
+            <a:r>
+              <a:rPr sz="1300" b="0">
+                <a:solidFill>
+                  <a:srgbClr val="9AA3AB"/>
+                </a:solidFill>
+              </a:rPr>
+              <a:t>start and clean up</a:t>
+            </a:r>
+          </a:p>
+          <a:p>
+            <a:pPr algn="ctr"/>
+            <a:r>
+              <a:rPr sz="1300" b="0">
+                <a:solidFill>
+                  <a:srgbClr val="9AA3AB"/>
+                </a:solidFill>
+              </a:rPr>
+              <a:t>in one place</a:t>
+            </a:r>
+          </a:p>
+        </p:txBody>
+      </p:sp>
+      <p:sp>
+        <p:nvSpPr>
+          <p:cNvPr id="298" name="TextBox 297"/>
+          <p:cNvSpPr txBox="1"/>
+          <p:nvPr/>
+        </p:nvSpPr>
+        <p:spPr>
+          <a:xfrm>
+            <a:off x="411480" y="2834640"/>
+            <a:ext cx="8321040" cy="365760"/>
+          </a:xfrm>
+          <a:prstGeom prst="rect">
+            <a:avLst/>
+          </a:prstGeom>
+          <a:noFill/>
+        </p:spPr>
+        <p:txBody>
+          <a:bodyPr wrap="square">
+            <a:spAutoFit/>
+          </a:bodyPr>
+          <a:lstStyle/>
+          <a:p>
+            <a:pPr algn="ctr"/>
+            <a:r>
+              <a:rPr sz="1400" b="0" i="0">
+                <a:solidFill>
+                  <a:srgbClr val="9AA3AB"/>
+                </a:solidFill>
+              </a:rPr>
+              <a:t>Pacman1 → Pacman2: World didn’t change at all.</a:t>
+            </a:r>
           </a:p>
         </p:txBody>
       </p:sp>
@@ -7419,7 +8566,7 @@
         <p:spPr>
           <a:xfrm>
             <a:off x="311700" y="885950"/>
-            <a:ext cx="8520600" cy="4023300"/>
+            <a:ext cx="8520600" cy="521208"/>
           </a:xfrm>
           <a:prstGeom prst="rect">
             <a:avLst/>
@@ -7443,111 +8590,421 @@
             </a:pPr>
             <a:r>
               <a:rPr lang="en"/>
-              <a:t>So far, every ghost chases straight at Pac-Man</a:t>
+              <a:t>Four personalities, so the ghosts trap Pac-Man instead of lining up behind him.</a:t>
             </a:r>
             <a:endParaRPr/>
           </a:p>
-          <a:p>
-            <a:pPr indent="-317500" lvl="1" marL="914400" rtl="0" algn="l">
-              <a:spcBef>
-                <a:spcPts val="0"/>
-              </a:spcBef>
-              <a:spcAft>
-                <a:spcPts val="0"/>
-              </a:spcAft>
-              <a:buSzPts val="1400"/>
-              <a:buChar char="○"/>
-            </a:pPr>
-            <a:r>
-              <a:rPr lang="en"/>
-              <a:t>They line up behind him: easy to escape</a:t>
-            </a:r>
-            <a:endParaRPr/>
-          </a:p>
-          <a:p>
-            <a:pPr indent="-330200" lvl="0" marL="457200" rtl="0" algn="l">
-              <a:spcBef>
-                <a:spcPts val="0"/>
-              </a:spcBef>
-              <a:spcAft>
-                <a:spcPts val="0"/>
-              </a:spcAft>
-              <a:buSzPts val="1600"/>
-              <a:buChar char="●"/>
-            </a:pPr>
-            <a:r>
-              <a:rPr lang="en"/>
-              <a:t>Blinky: Pac-Man’s tile</a:t>
-            </a:r>
-            <a:endParaRPr/>
-          </a:p>
-          <a:p>
-            <a:pPr indent="-330200" lvl="0" marL="457200" rtl="0" algn="l">
-              <a:spcBef>
-                <a:spcPts val="0"/>
-              </a:spcBef>
-              <a:spcAft>
-                <a:spcPts val="0"/>
-              </a:spcAft>
-              <a:buSzPts val="1600"/>
-              <a:buChar char="●"/>
-            </a:pPr>
-            <a:r>
-              <a:rPr lang="en"/>
-              <a:t>Pinky: four tiles ahead of Pac-Man</a:t>
-            </a:r>
-            <a:endParaRPr/>
-          </a:p>
-          <a:p>
-            <a:pPr indent="-330200" lvl="0" marL="457200" rtl="0" algn="l">
-              <a:spcBef>
-                <a:spcPts val="0"/>
-              </a:spcBef>
-              <a:spcAft>
-                <a:spcPts val="0"/>
-              </a:spcAft>
-              <a:buSzPts val="1600"/>
-              <a:buChar char="●"/>
-            </a:pPr>
-            <a:r>
-              <a:rPr lang="en"/>
-              <a:t>Inky: two tiles ahead of Pac-Man, and double the line from Blinky</a:t>
-            </a:r>
-            <a:endParaRPr/>
-          </a:p>
-          <a:p>
-            <a:pPr indent="-330200" lvl="0" marL="457200" rtl="0" algn="l">
-              <a:spcBef>
-                <a:spcPts val="0"/>
-              </a:spcBef>
-              <a:spcAft>
-                <a:spcPts val="0"/>
-              </a:spcAft>
-              <a:buSzPts val="1600"/>
-              <a:buChar char="●"/>
-            </a:pPr>
-            <a:r>
-              <a:rPr lang="en"/>
-              <a:t>Clyde: Pac-Man, until within eight tiles; then his corner</a:t>
-            </a:r>
-            <a:endParaRPr/>
-          </a:p>
-          <a:p>
-            <a:pPr indent="-330200" lvl="0" marL="457200" rtl="0" algn="l">
-              <a:spcBef>
-                <a:spcPts val="0"/>
-              </a:spcBef>
-              <a:spcAft>
-                <a:spcPts val="0"/>
-              </a:spcAft>
-              <a:buSzPts val="1600"/>
-              <a:buChar char="●"/>
-            </a:pPr>
-            <a:r>
-              <a:rPr lang="en"/>
-              <a:t>Together, they trap Pac-Man</a:t>
-            </a:r>
-            <a:endParaRPr/>
+        </p:txBody>
+      </p:sp>
+      <p:pic>
+        <p:nvPicPr>
+          <p:cNvPr id="295" name="Picture 294" descr="ghost_blinky.png"/>
+          <p:cNvPicPr>
+            <a:picLocks noChangeAspect="1"/>
+          </p:cNvPicPr>
+          <p:nvPr/>
+        </p:nvPicPr>
+        <p:blipFill>
+          <a:blip r:embed="rId3"/>
+          <a:stretch>
+            <a:fillRect/>
+          </a:stretch>
+        </p:blipFill>
+        <p:spPr>
+          <a:xfrm>
+            <a:off x="1005840" y="1417320"/>
+            <a:ext cx="822960" cy="822960"/>
+          </a:xfrm>
+          <a:prstGeom prst="rect">
+            <a:avLst/>
+          </a:prstGeom>
+        </p:spPr>
+      </p:pic>
+      <p:sp>
+        <p:nvSpPr>
+          <p:cNvPr id="296" name="Rounded Rectangle 295"/>
+          <p:cNvSpPr/>
+          <p:nvPr/>
+        </p:nvSpPr>
+        <p:spPr>
+          <a:xfrm>
+            <a:off x="502920" y="2331720"/>
+            <a:ext cx="1828800" cy="914400"/>
+          </a:xfrm>
+          <a:prstGeom prst="roundRect">
+            <a:avLst>
+              <a:gd name="adj" fmla="val 12000"/>
+            </a:avLst>
+          </a:prstGeom>
+          <a:solidFill>
+            <a:srgbClr val="2E3338"/>
+          </a:solidFill>
+          <a:ln>
+            <a:noFill/>
+          </a:ln>
+          <a:effectLst/>
+        </p:spPr>
+        <p:style>
+          <a:lnRef idx="1">
+            <a:schemeClr val="accent1"/>
+          </a:lnRef>
+          <a:fillRef idx="3">
+            <a:schemeClr val="accent1"/>
+          </a:fillRef>
+          <a:effectRef idx="2">
+            <a:schemeClr val="accent1"/>
+          </a:effectRef>
+          <a:fontRef idx="minor">
+            <a:schemeClr val="lt1"/>
+          </a:fontRef>
+        </p:style>
+        <p:txBody>
+          <a:bodyPr rtlCol="0" anchor="ctr" wrap="square" lIns="73152" rIns="73152"/>
+          <a:lstStyle/>
+          <a:p>
+            <a:pPr algn="ctr"/>
+            <a:r>
+              <a:rPr sz="1500" b="1">
+                <a:solidFill>
+                  <a:srgbClr val="DEE2E6"/>
+                </a:solidFill>
+              </a:rPr>
+              <a:t>Blinky</a:t>
+            </a:r>
+          </a:p>
+          <a:p>
+            <a:pPr algn="ctr"/>
+            <a:r>
+              <a:rPr sz="1300" b="0">
+                <a:solidFill>
+                  <a:srgbClr val="9AA3AB"/>
+                </a:solidFill>
+              </a:rPr>
+              <a:t>Pac-Man’s tile</a:t>
+            </a:r>
+          </a:p>
+        </p:txBody>
+      </p:sp>
+      <p:pic>
+        <p:nvPicPr>
+          <p:cNvPr id="297" name="Picture 296" descr="ghost_pinky.png"/>
+          <p:cNvPicPr>
+            <a:picLocks noChangeAspect="1"/>
+          </p:cNvPicPr>
+          <p:nvPr/>
+        </p:nvPicPr>
+        <p:blipFill>
+          <a:blip r:embed="rId4"/>
+          <a:stretch>
+            <a:fillRect/>
+          </a:stretch>
+        </p:blipFill>
+        <p:spPr>
+          <a:xfrm>
+            <a:off x="3108959" y="1417320"/>
+            <a:ext cx="822960" cy="822960"/>
+          </a:xfrm>
+          <a:prstGeom prst="rect">
+            <a:avLst/>
+          </a:prstGeom>
+        </p:spPr>
+      </p:pic>
+      <p:sp>
+        <p:nvSpPr>
+          <p:cNvPr id="298" name="Rounded Rectangle 297"/>
+          <p:cNvSpPr/>
+          <p:nvPr/>
+        </p:nvSpPr>
+        <p:spPr>
+          <a:xfrm>
+            <a:off x="2606039" y="2331720"/>
+            <a:ext cx="1828800" cy="914400"/>
+          </a:xfrm>
+          <a:prstGeom prst="roundRect">
+            <a:avLst>
+              <a:gd name="adj" fmla="val 12000"/>
+            </a:avLst>
+          </a:prstGeom>
+          <a:solidFill>
+            <a:srgbClr val="2E3338"/>
+          </a:solidFill>
+          <a:ln>
+            <a:noFill/>
+          </a:ln>
+          <a:effectLst/>
+        </p:spPr>
+        <p:style>
+          <a:lnRef idx="1">
+            <a:schemeClr val="accent1"/>
+          </a:lnRef>
+          <a:fillRef idx="3">
+            <a:schemeClr val="accent1"/>
+          </a:fillRef>
+          <a:effectRef idx="2">
+            <a:schemeClr val="accent1"/>
+          </a:effectRef>
+          <a:fontRef idx="minor">
+            <a:schemeClr val="lt1"/>
+          </a:fontRef>
+        </p:style>
+        <p:txBody>
+          <a:bodyPr rtlCol="0" anchor="ctr" wrap="square" lIns="73152" rIns="73152"/>
+          <a:lstStyle/>
+          <a:p>
+            <a:pPr algn="ctr"/>
+            <a:r>
+              <a:rPr sz="1500" b="1">
+                <a:solidFill>
+                  <a:srgbClr val="DEE2E6"/>
+                </a:solidFill>
+              </a:rPr>
+              <a:t>Pinky</a:t>
+            </a:r>
+          </a:p>
+          <a:p>
+            <a:pPr algn="ctr"/>
+            <a:r>
+              <a:rPr sz="1300" b="0">
+                <a:solidFill>
+                  <a:srgbClr val="9AA3AB"/>
+                </a:solidFill>
+              </a:rPr>
+              <a:t>4 tiles ahead of him</a:t>
+            </a:r>
+          </a:p>
+        </p:txBody>
+      </p:sp>
+      <p:pic>
+        <p:nvPicPr>
+          <p:cNvPr id="299" name="Picture 298" descr="ghost_inky.png"/>
+          <p:cNvPicPr>
+            <a:picLocks noChangeAspect="1"/>
+          </p:cNvPicPr>
+          <p:nvPr/>
+        </p:nvPicPr>
+        <p:blipFill>
+          <a:blip r:embed="rId5"/>
+          <a:stretch>
+            <a:fillRect/>
+          </a:stretch>
+        </p:blipFill>
+        <p:spPr>
+          <a:xfrm>
+            <a:off x="5212079" y="1417320"/>
+            <a:ext cx="822960" cy="822960"/>
+          </a:xfrm>
+          <a:prstGeom prst="rect">
+            <a:avLst/>
+          </a:prstGeom>
+        </p:spPr>
+      </p:pic>
+      <p:sp>
+        <p:nvSpPr>
+          <p:cNvPr id="300" name="Rounded Rectangle 299"/>
+          <p:cNvSpPr/>
+          <p:nvPr/>
+        </p:nvSpPr>
+        <p:spPr>
+          <a:xfrm>
+            <a:off x="4709159" y="2331720"/>
+            <a:ext cx="1828800" cy="914400"/>
+          </a:xfrm>
+          <a:prstGeom prst="roundRect">
+            <a:avLst>
+              <a:gd name="adj" fmla="val 12000"/>
+            </a:avLst>
+          </a:prstGeom>
+          <a:solidFill>
+            <a:srgbClr val="2E3338"/>
+          </a:solidFill>
+          <a:ln>
+            <a:noFill/>
+          </a:ln>
+          <a:effectLst/>
+        </p:spPr>
+        <p:style>
+          <a:lnRef idx="1">
+            <a:schemeClr val="accent1"/>
+          </a:lnRef>
+          <a:fillRef idx="3">
+            <a:schemeClr val="accent1"/>
+          </a:fillRef>
+          <a:effectRef idx="2">
+            <a:schemeClr val="accent1"/>
+          </a:effectRef>
+          <a:fontRef idx="minor">
+            <a:schemeClr val="lt1"/>
+          </a:fontRef>
+        </p:style>
+        <p:txBody>
+          <a:bodyPr rtlCol="0" anchor="ctr" wrap="square" lIns="73152" rIns="73152"/>
+          <a:lstStyle/>
+          <a:p>
+            <a:pPr algn="ctr"/>
+            <a:r>
+              <a:rPr sz="1500" b="1">
+                <a:solidFill>
+                  <a:srgbClr val="DEE2E6"/>
+                </a:solidFill>
+              </a:rPr>
+              <a:t>Inky</a:t>
+            </a:r>
+          </a:p>
+          <a:p>
+            <a:pPr algn="ctr"/>
+            <a:r>
+              <a:rPr sz="1300" b="0">
+                <a:solidFill>
+                  <a:srgbClr val="9AA3AB"/>
+                </a:solidFill>
+              </a:rPr>
+              <a:t>2 ahead, doubled</a:t>
+            </a:r>
+          </a:p>
+          <a:p>
+            <a:pPr algn="ctr"/>
+            <a:r>
+              <a:rPr sz="1300" b="0">
+                <a:solidFill>
+                  <a:srgbClr val="9AA3AB"/>
+                </a:solidFill>
+              </a:rPr>
+              <a:t>from Blinky</a:t>
+            </a:r>
+          </a:p>
+        </p:txBody>
+      </p:sp>
+      <p:pic>
+        <p:nvPicPr>
+          <p:cNvPr id="301" name="Picture 300" descr="ghost_clyde.png"/>
+          <p:cNvPicPr>
+            <a:picLocks noChangeAspect="1"/>
+          </p:cNvPicPr>
+          <p:nvPr/>
+        </p:nvPicPr>
+        <p:blipFill>
+          <a:blip r:embed="rId6"/>
+          <a:stretch>
+            <a:fillRect/>
+          </a:stretch>
+        </p:blipFill>
+        <p:spPr>
+          <a:xfrm>
+            <a:off x="7315199" y="1417320"/>
+            <a:ext cx="822960" cy="822960"/>
+          </a:xfrm>
+          <a:prstGeom prst="rect">
+            <a:avLst/>
+          </a:prstGeom>
+        </p:spPr>
+      </p:pic>
+      <p:sp>
+        <p:nvSpPr>
+          <p:cNvPr id="302" name="Rounded Rectangle 301"/>
+          <p:cNvSpPr/>
+          <p:nvPr/>
+        </p:nvSpPr>
+        <p:spPr>
+          <a:xfrm>
+            <a:off x="6812279" y="2331720"/>
+            <a:ext cx="1828800" cy="914400"/>
+          </a:xfrm>
+          <a:prstGeom prst="roundRect">
+            <a:avLst>
+              <a:gd name="adj" fmla="val 12000"/>
+            </a:avLst>
+          </a:prstGeom>
+          <a:solidFill>
+            <a:srgbClr val="2E3338"/>
+          </a:solidFill>
+          <a:ln>
+            <a:noFill/>
+          </a:ln>
+          <a:effectLst/>
+        </p:spPr>
+        <p:style>
+          <a:lnRef idx="1">
+            <a:schemeClr val="accent1"/>
+          </a:lnRef>
+          <a:fillRef idx="3">
+            <a:schemeClr val="accent1"/>
+          </a:fillRef>
+          <a:effectRef idx="2">
+            <a:schemeClr val="accent1"/>
+          </a:effectRef>
+          <a:fontRef idx="minor">
+            <a:schemeClr val="lt1"/>
+          </a:fontRef>
+        </p:style>
+        <p:txBody>
+          <a:bodyPr rtlCol="0" anchor="ctr" wrap="square" lIns="73152" rIns="73152"/>
+          <a:lstStyle/>
+          <a:p>
+            <a:pPr algn="ctr"/>
+            <a:r>
+              <a:rPr sz="1500" b="1">
+                <a:solidFill>
+                  <a:srgbClr val="DEE2E6"/>
+                </a:solidFill>
+              </a:rPr>
+              <a:t>Clyde</a:t>
+            </a:r>
+          </a:p>
+          <a:p>
+            <a:pPr algn="ctr"/>
+            <a:r>
+              <a:rPr sz="1300" b="0">
+                <a:solidFill>
+                  <a:srgbClr val="9AA3AB"/>
+                </a:solidFill>
+              </a:rPr>
+              <a:t>Pac-Man, until</a:t>
+            </a:r>
+          </a:p>
+          <a:p>
+            <a:pPr algn="ctr"/>
+            <a:r>
+              <a:rPr sz="1300" b="0">
+                <a:solidFill>
+                  <a:srgbClr val="9AA3AB"/>
+                </a:solidFill>
+              </a:rPr>
+              <a:t>close: then his corner</a:t>
+            </a:r>
+          </a:p>
+        </p:txBody>
+      </p:sp>
+      <p:sp>
+        <p:nvSpPr>
+          <p:cNvPr id="303" name="TextBox 302"/>
+          <p:cNvSpPr txBox="1"/>
+          <p:nvPr/>
+        </p:nvSpPr>
+        <p:spPr>
+          <a:xfrm>
+            <a:off x="457200" y="3520440"/>
+            <a:ext cx="8229600" cy="731520"/>
+          </a:xfrm>
+          <a:prstGeom prst="rect">
+            <a:avLst/>
+          </a:prstGeom>
+          <a:noFill/>
+        </p:spPr>
+        <p:txBody>
+          <a:bodyPr wrap="square">
+            <a:spAutoFit/>
+          </a:bodyPr>
+          <a:lstStyle/>
+          <a:p>
+            <a:pPr algn="ctr"/>
+            <a:r>
+              <a:rPr sz="1600" b="1" i="0">
+                <a:solidFill>
+                  <a:srgbClr val="DEE2E6"/>
+                </a:solidFill>
+              </a:rPr>
+              <a:t>Where does the targeting code go, so every ghost can have its own?</a:t>
+            </a:r>
           </a:p>
         </p:txBody>
       </p:sp>
@@ -8665,7 +10122,7 @@
         <p:spPr>
           <a:xfrm>
             <a:off x="311700" y="885950"/>
-            <a:ext cx="8520600" cy="4023300"/>
+            <a:ext cx="8520600" cy="521208"/>
           </a:xfrm>
           <a:prstGeom prst="rect">
             <a:avLst/>
@@ -8689,128 +10146,219 @@
             </a:pPr>
             <a:r>
               <a:rPr lang="en"/>
-              <a:t>The same structure: hold an interface, forward to it</a:t>
+              <a:t>The same structure: hold an interface, forward to it. Different jobs.</a:t>
             </a:r>
             <a:endParaRPr/>
           </a:p>
-          <a:p>
-            <a:pPr indent="-330200" lvl="0" marL="457200" rtl="0" algn="l">
-              <a:spcBef>
-                <a:spcPts val="0"/>
-              </a:spcBef>
-              <a:spcAft>
-                <a:spcPts val="0"/>
-              </a:spcAft>
-              <a:buSzPts val="1600"/>
-              <a:buChar char="●"/>
-            </a:pPr>
-            <a:r>
-              <a:rPr lang="en"/>
-              <a:t>State: the ghost’s mode</a:t>
-            </a:r>
-            <a:endParaRPr/>
-          </a:p>
-          <a:p>
-            <a:pPr indent="-317500" lvl="1" marL="914400" rtl="0" algn="l">
-              <a:spcBef>
-                <a:spcPts val="0"/>
-              </a:spcBef>
-              <a:spcAft>
-                <a:spcPts val="0"/>
-              </a:spcAft>
-              <a:buSzPts val="1400"/>
-              <a:buChar char="○"/>
-            </a:pPr>
-            <a:r>
-              <a:rPr lang="en"/>
-              <a:t>Picked by the states themselves, and changes all the time</a:t>
-            </a:r>
-            <a:endParaRPr/>
-          </a:p>
-          <a:p>
-            <a:pPr indent="-317500" lvl="1" marL="914400" rtl="0" algn="l">
-              <a:spcBef>
-                <a:spcPts val="0"/>
-              </a:spcBef>
-              <a:spcAft>
-                <a:spcPts val="0"/>
-              </a:spcAft>
-              <a:buSzPts val="1400"/>
-              <a:buChar char="○"/>
-            </a:pPr>
-            <a:r>
-              <a:rPr lang="en"/>
-              <a:t>A state knows the next state</a:t>
-            </a:r>
-            <a:endParaRPr/>
-          </a:p>
-          <a:p>
-            <a:pPr indent="-330200" lvl="0" marL="457200" rtl="0" algn="l">
-              <a:spcBef>
-                <a:spcPts val="0"/>
-              </a:spcBef>
-              <a:spcAft>
-                <a:spcPts val="0"/>
-              </a:spcAft>
-              <a:buSzPts val="1600"/>
-              <a:buChar char="●"/>
-            </a:pPr>
-            <a:r>
-              <a:rPr lang="en"/>
-              <a:t>Strategy: the ghost’s targeting</a:t>
-            </a:r>
-            <a:endParaRPr/>
-          </a:p>
-          <a:p>
-            <a:pPr indent="-317500" lvl="1" marL="914400" rtl="0" algn="l">
-              <a:spcBef>
-                <a:spcPts val="0"/>
-              </a:spcBef>
-              <a:spcAft>
-                <a:spcPts val="0"/>
-              </a:spcAft>
-              <a:buSzPts val="1400"/>
-              <a:buChar char="○"/>
-            </a:pPr>
-            <a:r>
-              <a:rPr lang="en"/>
-              <a:t>Picked from outside (World), once, and never changes</a:t>
-            </a:r>
-            <a:endParaRPr/>
-          </a:p>
-          <a:p>
-            <a:pPr indent="-317500" lvl="1" marL="914400" rtl="0" algn="l">
-              <a:spcBef>
-                <a:spcPts val="0"/>
-              </a:spcBef>
-              <a:spcAft>
-                <a:spcPts val="0"/>
-              </a:spcAft>
-              <a:buSzPts val="1400"/>
-              <a:buChar char="○"/>
-            </a:pPr>
-            <a:r>
-              <a:rPr lang="en"/>
-              <a:t>Strategies don’t know each other</a:t>
-            </a:r>
-            <a:endParaRPr/>
-          </a:p>
-          <a:p>
-            <a:pPr indent="-330200" lvl="0" marL="457200" rtl="0" algn="l">
-              <a:spcBef>
-                <a:spcPts val="0"/>
-              </a:spcBef>
-              <a:spcAft>
-                <a:spcPts val="0"/>
-              </a:spcAft>
-              <a:buSzPts val="1600"/>
-              <a:buChar char="●"/>
-            </a:pPr>
-            <a:r>
-              <a:rPr lang="en"/>
-              <a:t>Together: the state decides whether to chase, the strategy how</a:t>
-            </a:r>
-            <a:endParaRPr/>
+        </p:txBody>
+      </p:sp>
+      <p:sp>
+        <p:nvSpPr>
+          <p:cNvPr id="295" name="Rounded Rectangle 294"/>
+          <p:cNvSpPr/>
+          <p:nvPr/>
+        </p:nvSpPr>
+        <p:spPr>
+          <a:xfrm>
+            <a:off x="548640" y="1417320"/>
+            <a:ext cx="3749039" cy="1554480"/>
+          </a:xfrm>
+          <a:prstGeom prst="roundRect">
+            <a:avLst>
+              <a:gd name="adj" fmla="val 12000"/>
+            </a:avLst>
+          </a:prstGeom>
+          <a:solidFill>
+            <a:srgbClr val="2E3338"/>
+          </a:solidFill>
+          <a:ln w="25400">
+            <a:solidFill>
+              <a:srgbClr val="D45D35"/>
+            </a:solidFill>
+          </a:ln>
+          <a:effectLst/>
+        </p:spPr>
+        <p:style>
+          <a:lnRef idx="1">
+            <a:schemeClr val="accent1"/>
+          </a:lnRef>
+          <a:fillRef idx="3">
+            <a:schemeClr val="accent1"/>
+          </a:fillRef>
+          <a:effectRef idx="2">
+            <a:schemeClr val="accent1"/>
+          </a:effectRef>
+          <a:fontRef idx="minor">
+            <a:schemeClr val="lt1"/>
+          </a:fontRef>
+        </p:style>
+        <p:txBody>
+          <a:bodyPr rtlCol="0" anchor="ctr" wrap="square" lIns="73152" rIns="73152"/>
+          <a:lstStyle/>
+          <a:p>
+            <a:pPr algn="ctr"/>
+            <a:r>
+              <a:rPr sz="1600" b="1">
+                <a:solidFill>
+                  <a:srgbClr val="DEE2E6"/>
+                </a:solidFill>
+              </a:rPr>
+              <a:t>State: the mode</a:t>
+            </a:r>
+          </a:p>
+          <a:p>
+            <a:pPr algn="ctr"/>
+            <a:r>
+              <a:rPr sz="1400" b="0">
+                <a:solidFill>
+                  <a:srgbClr val="9AA3AB"/>
+                </a:solidFill>
+              </a:rPr>
+              <a:t>chosen by the states themselves</a:t>
+            </a:r>
+          </a:p>
+          <a:p>
+            <a:pPr algn="ctr"/>
+            <a:r>
+              <a:rPr sz="1400" b="0">
+                <a:solidFill>
+                  <a:srgbClr val="9AA3AB"/>
+                </a:solidFill>
+              </a:rPr>
+              <a:t>changes all the time</a:t>
+            </a:r>
+          </a:p>
+          <a:p>
+            <a:pPr algn="ctr"/>
+            <a:r>
+              <a:rPr sz="1400" b="0">
+                <a:solidFill>
+                  <a:srgbClr val="9AA3AB"/>
+                </a:solidFill>
+              </a:rPr>
+              <a:t>a state knows the next state</a:t>
+            </a:r>
+          </a:p>
+        </p:txBody>
+      </p:sp>
+      <p:sp>
+        <p:nvSpPr>
+          <p:cNvPr id="296" name="Rounded Rectangle 295"/>
+          <p:cNvSpPr/>
+          <p:nvPr/>
+        </p:nvSpPr>
+        <p:spPr>
+          <a:xfrm>
+            <a:off x="4846320" y="1417320"/>
+            <a:ext cx="3749039" cy="1554480"/>
+          </a:xfrm>
+          <a:prstGeom prst="roundRect">
+            <a:avLst>
+              <a:gd name="adj" fmla="val 12000"/>
+            </a:avLst>
+          </a:prstGeom>
+          <a:solidFill>
+            <a:srgbClr val="2E3338"/>
+          </a:solidFill>
+          <a:ln>
+            <a:noFill/>
+          </a:ln>
+          <a:effectLst/>
+        </p:spPr>
+        <p:style>
+          <a:lnRef idx="1">
+            <a:schemeClr val="accent1"/>
+          </a:lnRef>
+          <a:fillRef idx="3">
+            <a:schemeClr val="accent1"/>
+          </a:fillRef>
+          <a:effectRef idx="2">
+            <a:schemeClr val="accent1"/>
+          </a:effectRef>
+          <a:fontRef idx="minor">
+            <a:schemeClr val="lt1"/>
+          </a:fontRef>
+        </p:style>
+        <p:txBody>
+          <a:bodyPr rtlCol="0" anchor="ctr" wrap="square" lIns="73152" rIns="73152"/>
+          <a:lstStyle/>
+          <a:p>
+            <a:pPr algn="ctr"/>
+            <a:r>
+              <a:rPr sz="1600" b="1">
+                <a:solidFill>
+                  <a:srgbClr val="DEE2E6"/>
+                </a:solidFill>
+              </a:rPr>
+              <a:t>Strategy: the targeting</a:t>
+            </a:r>
+          </a:p>
+          <a:p>
+            <a:pPr algn="ctr"/>
+            <a:r>
+              <a:rPr sz="1400" b="0">
+                <a:solidFill>
+                  <a:srgbClr val="9AA3AB"/>
+                </a:solidFill>
+              </a:rPr>
+              <a:t>chosen from outside, once</a:t>
+            </a:r>
+          </a:p>
+          <a:p>
+            <a:pPr algn="ctr"/>
+            <a:r>
+              <a:rPr sz="1400" b="0">
+                <a:solidFill>
+                  <a:srgbClr val="9AA3AB"/>
+                </a:solidFill>
+              </a:rPr>
+              <a:t>never changes</a:t>
+            </a:r>
+          </a:p>
+          <a:p>
+            <a:pPr algn="ctr"/>
+            <a:r>
+              <a:rPr sz="1400" b="0">
+                <a:solidFill>
+                  <a:srgbClr val="9AA3AB"/>
+                </a:solidFill>
+              </a:rPr>
+              <a:t>strategies don’t know each other</a:t>
+            </a:r>
+          </a:p>
+        </p:txBody>
+      </p:sp>
+      <p:sp>
+        <p:nvSpPr>
+          <p:cNvPr id="297" name="TextBox 296"/>
+          <p:cNvSpPr txBox="1"/>
+          <p:nvPr/>
+        </p:nvSpPr>
+        <p:spPr>
+          <a:xfrm>
+            <a:off x="457200" y="3246120"/>
+            <a:ext cx="8229600" cy="731520"/>
+          </a:xfrm>
+          <a:prstGeom prst="rect">
+            <a:avLst/>
+          </a:prstGeom>
+          <a:noFill/>
+        </p:spPr>
+        <p:txBody>
+          <a:bodyPr wrap="square">
+            <a:spAutoFit/>
+          </a:bodyPr>
+          <a:lstStyle/>
+          <a:p>
+            <a:pPr algn="ctr"/>
+            <a:r>
+              <a:rPr sz="1600" b="1" i="0">
+                <a:solidFill>
+                  <a:srgbClr val="DEE2E6"/>
+                </a:solidFill>
+              </a:rPr>
+              <a:t>Together: the state decides whether to chase, the strategy how.</a:t>
+            </a:r>
           </a:p>
         </p:txBody>
       </p:sp>
@@ -9724,7 +11272,7 @@
         <p:spPr>
           <a:xfrm>
             <a:off x="311700" y="885950"/>
-            <a:ext cx="8520600" cy="4023300"/>
+            <a:ext cx="8520600" cy="521208"/>
           </a:xfrm>
           <a:prstGeom prst="rect">
             <a:avLst/>
@@ -9748,94 +11296,470 @@
             </a:pPr>
             <a:r>
               <a:rPr lang="en"/>
-              <a:t>Lives, Pac-Man’s death, a new level when the dots are gone</a:t>
+              <a:t>Two levels of state machine: the game’s, and each ghost’s.</a:t>
             </a:r>
             <a:endParaRPr/>
           </a:p>
-          <a:p>
-            <a:pPr indent="-330200" lvl="0" marL="457200" rtl="0" algn="l">
-              <a:spcBef>
-                <a:spcPts val="0"/>
-              </a:spcBef>
-              <a:spcAft>
-                <a:spcPts val="0"/>
-              </a:spcAft>
-              <a:buSzPts val="1600"/>
-              <a:buChar char="●"/>
-            </a:pPr>
-            <a:r>
-              <a:rPr lang="en"/>
-              <a:t>The game’s flow: a state machine, like Flappy Bird’s</a:t>
-            </a:r>
-            <a:endParaRPr/>
-          </a:p>
-          <a:p>
-            <a:pPr indent="-317500" lvl="1" marL="914400" rtl="0" algn="l">
-              <a:spcBef>
-                <a:spcPts val="0"/>
-              </a:spcBef>
-              <a:spcAft>
-                <a:spcPts val="0"/>
-              </a:spcAft>
-              <a:buSzPts val="1400"/>
-              <a:buChar char="○"/>
-            </a:pPr>
-            <a:r>
-              <a:rPr lang="en"/>
-              <a:t>Ready → Play → Dying → Ready or Game Over</a:t>
-            </a:r>
-            <a:endParaRPr/>
-          </a:p>
-          <a:p>
-            <a:pPr indent="-330200" lvl="0" marL="457200" rtl="0" algn="l">
-              <a:spcBef>
-                <a:spcPts val="0"/>
-              </a:spcBef>
-              <a:spcAft>
-                <a:spcPts val="0"/>
-              </a:spcAft>
-              <a:buSzPts val="1600"/>
-              <a:buChar char="●"/>
-            </a:pPr>
-            <a:r>
-              <a:rPr lang="en"/>
-              <a:t>Two levels of state machine in one game</a:t>
-            </a:r>
-            <a:endParaRPr/>
-          </a:p>
-          <a:p>
-            <a:pPr indent="-317500" lvl="1" marL="914400" rtl="0" algn="l">
-              <a:spcBef>
-                <a:spcPts val="0"/>
-              </a:spcBef>
-              <a:spcAft>
-                <a:spcPts val="0"/>
-              </a:spcAft>
-              <a:buSzPts val="1400"/>
-              <a:buChar char="○"/>
-            </a:pPr>
-            <a:r>
-              <a:rPr lang="en"/>
-              <a:t>The game’s states, and each ghost’s states</a:t>
-            </a:r>
-            <a:endParaRPr/>
-          </a:p>
-          <a:p>
-            <a:pPr indent="-317500" lvl="1" marL="914400" rtl="0" algn="l">
-              <a:spcBef>
-                <a:spcPts val="0"/>
-              </a:spcBef>
-              <a:spcAft>
-                <a:spcPts val="0"/>
-              </a:spcAft>
-              <a:buSzPts val="1400"/>
-              <a:buChar char="○"/>
-            </a:pPr>
-            <a:r>
-              <a:rPr lang="en"/>
-              <a:t>Ghosts only update in PlayState: while Pac-Man dies, their states pause</a:t>
-            </a:r>
-            <a:endParaRPr/>
+        </p:txBody>
+      </p:sp>
+      <p:sp>
+        <p:nvSpPr>
+          <p:cNvPr id="295" name="Rounded Rectangle 294"/>
+          <p:cNvSpPr/>
+          <p:nvPr/>
+        </p:nvSpPr>
+        <p:spPr>
+          <a:xfrm>
+            <a:off x="822960" y="1463040"/>
+            <a:ext cx="1645920" cy="548640"/>
+          </a:xfrm>
+          <a:prstGeom prst="roundRect">
+            <a:avLst>
+              <a:gd name="adj" fmla="val 12000"/>
+            </a:avLst>
+          </a:prstGeom>
+          <a:solidFill>
+            <a:srgbClr val="2E3338"/>
+          </a:solidFill>
+          <a:ln>
+            <a:noFill/>
+          </a:ln>
+          <a:effectLst/>
+        </p:spPr>
+        <p:style>
+          <a:lnRef idx="1">
+            <a:schemeClr val="accent1"/>
+          </a:lnRef>
+          <a:fillRef idx="3">
+            <a:schemeClr val="accent1"/>
+          </a:fillRef>
+          <a:effectRef idx="2">
+            <a:schemeClr val="accent1"/>
+          </a:effectRef>
+          <a:fontRef idx="minor">
+            <a:schemeClr val="lt1"/>
+          </a:fontRef>
+        </p:style>
+        <p:txBody>
+          <a:bodyPr rtlCol="0" anchor="ctr" wrap="square" lIns="73152" rIns="73152"/>
+          <a:lstStyle/>
+          <a:p>
+            <a:pPr algn="ctr"/>
+            <a:r>
+              <a:rPr sz="1500" b="1">
+                <a:solidFill>
+                  <a:srgbClr val="DEE2E6"/>
+                </a:solidFill>
+              </a:rPr>
+              <a:t>Ready</a:t>
+            </a:r>
+          </a:p>
+        </p:txBody>
+      </p:sp>
+      <p:cxnSp>
+        <p:nvCxnSpPr>
+          <p:cNvPr id="296" name="Connector 295"/>
+          <p:cNvCxnSpPr/>
+          <p:nvPr/>
+        </p:nvCxnSpPr>
+        <p:spPr>
+          <a:xfrm>
+            <a:off x="2487168" y="1737360"/>
+            <a:ext cx="237744" cy="0"/>
+          </a:xfrm>
+          <a:prstGeom prst="line">
+            <a:avLst/>
+          </a:prstGeom>
+          <a:ln w="25400">
+            <a:solidFill>
+              <a:srgbClr val="9AA3AB"/>
+            </a:solidFill>
+            <a:tailEnd type="triangle"/>
+          </a:ln>
+        </p:spPr>
+        <p:style>
+          <a:lnRef idx="2">
+            <a:schemeClr val="accent1"/>
+          </a:lnRef>
+          <a:fillRef idx="0">
+            <a:schemeClr val="accent1"/>
+          </a:fillRef>
+          <a:effectRef idx="1">
+            <a:schemeClr val="accent1"/>
+          </a:effectRef>
+          <a:fontRef idx="minor">
+            <a:schemeClr val="tx1"/>
+          </a:fontRef>
+        </p:style>
+      </p:cxnSp>
+      <p:sp>
+        <p:nvSpPr>
+          <p:cNvPr id="297" name="Rounded Rectangle 296"/>
+          <p:cNvSpPr/>
+          <p:nvPr/>
+        </p:nvSpPr>
+        <p:spPr>
+          <a:xfrm>
+            <a:off x="2743200" y="1463040"/>
+            <a:ext cx="1645920" cy="548640"/>
+          </a:xfrm>
+          <a:prstGeom prst="roundRect">
+            <a:avLst>
+              <a:gd name="adj" fmla="val 12000"/>
+            </a:avLst>
+          </a:prstGeom>
+          <a:solidFill>
+            <a:srgbClr val="2E3338"/>
+          </a:solidFill>
+          <a:ln w="25400">
+            <a:solidFill>
+              <a:srgbClr val="D45D35"/>
+            </a:solidFill>
+          </a:ln>
+          <a:effectLst/>
+        </p:spPr>
+        <p:style>
+          <a:lnRef idx="1">
+            <a:schemeClr val="accent1"/>
+          </a:lnRef>
+          <a:fillRef idx="3">
+            <a:schemeClr val="accent1"/>
+          </a:fillRef>
+          <a:effectRef idx="2">
+            <a:schemeClr val="accent1"/>
+          </a:effectRef>
+          <a:fontRef idx="minor">
+            <a:schemeClr val="lt1"/>
+          </a:fontRef>
+        </p:style>
+        <p:txBody>
+          <a:bodyPr rtlCol="0" anchor="ctr" wrap="square" lIns="73152" rIns="73152"/>
+          <a:lstStyle/>
+          <a:p>
+            <a:pPr algn="ctr"/>
+            <a:r>
+              <a:rPr sz="1500" b="1">
+                <a:solidFill>
+                  <a:srgbClr val="DEE2E6"/>
+                </a:solidFill>
+              </a:rPr>
+              <a:t>Play</a:t>
+            </a:r>
+          </a:p>
+        </p:txBody>
+      </p:sp>
+      <p:cxnSp>
+        <p:nvCxnSpPr>
+          <p:cNvPr id="298" name="Connector 297"/>
+          <p:cNvCxnSpPr/>
+          <p:nvPr/>
+        </p:nvCxnSpPr>
+        <p:spPr>
+          <a:xfrm>
+            <a:off x="4407407" y="1737360"/>
+            <a:ext cx="237745" cy="0"/>
+          </a:xfrm>
+          <a:prstGeom prst="line">
+            <a:avLst/>
+          </a:prstGeom>
+          <a:ln w="25400">
+            <a:solidFill>
+              <a:srgbClr val="9AA3AB"/>
+            </a:solidFill>
+            <a:tailEnd type="triangle"/>
+          </a:ln>
+        </p:spPr>
+        <p:style>
+          <a:lnRef idx="2">
+            <a:schemeClr val="accent1"/>
+          </a:lnRef>
+          <a:fillRef idx="0">
+            <a:schemeClr val="accent1"/>
+          </a:fillRef>
+          <a:effectRef idx="1">
+            <a:schemeClr val="accent1"/>
+          </a:effectRef>
+          <a:fontRef idx="minor">
+            <a:schemeClr val="tx1"/>
+          </a:fontRef>
+        </p:style>
+      </p:cxnSp>
+      <p:sp>
+        <p:nvSpPr>
+          <p:cNvPr id="299" name="Rounded Rectangle 298"/>
+          <p:cNvSpPr/>
+          <p:nvPr/>
+        </p:nvSpPr>
+        <p:spPr>
+          <a:xfrm>
+            <a:off x="4663440" y="1463040"/>
+            <a:ext cx="1645920" cy="548640"/>
+          </a:xfrm>
+          <a:prstGeom prst="roundRect">
+            <a:avLst>
+              <a:gd name="adj" fmla="val 12000"/>
+            </a:avLst>
+          </a:prstGeom>
+          <a:solidFill>
+            <a:srgbClr val="2E3338"/>
+          </a:solidFill>
+          <a:ln>
+            <a:noFill/>
+          </a:ln>
+          <a:effectLst/>
+        </p:spPr>
+        <p:style>
+          <a:lnRef idx="1">
+            <a:schemeClr val="accent1"/>
+          </a:lnRef>
+          <a:fillRef idx="3">
+            <a:schemeClr val="accent1"/>
+          </a:fillRef>
+          <a:effectRef idx="2">
+            <a:schemeClr val="accent1"/>
+          </a:effectRef>
+          <a:fontRef idx="minor">
+            <a:schemeClr val="lt1"/>
+          </a:fontRef>
+        </p:style>
+        <p:txBody>
+          <a:bodyPr rtlCol="0" anchor="ctr" wrap="square" lIns="73152" rIns="73152"/>
+          <a:lstStyle/>
+          <a:p>
+            <a:pPr algn="ctr"/>
+            <a:r>
+              <a:rPr sz="1500" b="1">
+                <a:solidFill>
+                  <a:srgbClr val="DEE2E6"/>
+                </a:solidFill>
+              </a:rPr>
+              <a:t>Dying</a:t>
+            </a:r>
+          </a:p>
+        </p:txBody>
+      </p:sp>
+      <p:cxnSp>
+        <p:nvCxnSpPr>
+          <p:cNvPr id="300" name="Connector 299"/>
+          <p:cNvCxnSpPr/>
+          <p:nvPr/>
+        </p:nvCxnSpPr>
+        <p:spPr>
+          <a:xfrm>
+            <a:off x="6327648" y="1737360"/>
+            <a:ext cx="237744" cy="0"/>
+          </a:xfrm>
+          <a:prstGeom prst="line">
+            <a:avLst/>
+          </a:prstGeom>
+          <a:ln w="25400">
+            <a:solidFill>
+              <a:srgbClr val="9AA3AB"/>
+            </a:solidFill>
+            <a:tailEnd type="triangle"/>
+          </a:ln>
+        </p:spPr>
+        <p:style>
+          <a:lnRef idx="2">
+            <a:schemeClr val="accent1"/>
+          </a:lnRef>
+          <a:fillRef idx="0">
+            <a:schemeClr val="accent1"/>
+          </a:fillRef>
+          <a:effectRef idx="1">
+            <a:schemeClr val="accent1"/>
+          </a:effectRef>
+          <a:fontRef idx="minor">
+            <a:schemeClr val="tx1"/>
+          </a:fontRef>
+        </p:style>
+      </p:cxnSp>
+      <p:sp>
+        <p:nvSpPr>
+          <p:cNvPr id="301" name="Rounded Rectangle 300"/>
+          <p:cNvSpPr/>
+          <p:nvPr/>
+        </p:nvSpPr>
+        <p:spPr>
+          <a:xfrm>
+            <a:off x="6583680" y="1463040"/>
+            <a:ext cx="1645920" cy="548640"/>
+          </a:xfrm>
+          <a:prstGeom prst="roundRect">
+            <a:avLst>
+              <a:gd name="adj" fmla="val 12000"/>
+            </a:avLst>
+          </a:prstGeom>
+          <a:solidFill>
+            <a:srgbClr val="2E3338"/>
+          </a:solidFill>
+          <a:ln>
+            <a:noFill/>
+          </a:ln>
+          <a:effectLst/>
+        </p:spPr>
+        <p:style>
+          <a:lnRef idx="1">
+            <a:schemeClr val="accent1"/>
+          </a:lnRef>
+          <a:fillRef idx="3">
+            <a:schemeClr val="accent1"/>
+          </a:fillRef>
+          <a:effectRef idx="2">
+            <a:schemeClr val="accent1"/>
+          </a:effectRef>
+          <a:fontRef idx="minor">
+            <a:schemeClr val="lt1"/>
+          </a:fontRef>
+        </p:style>
+        <p:txBody>
+          <a:bodyPr rtlCol="0" anchor="ctr" wrap="square" lIns="73152" rIns="73152"/>
+          <a:lstStyle/>
+          <a:p>
+            <a:pPr algn="ctr"/>
+            <a:r>
+              <a:rPr sz="1500" b="1">
+                <a:solidFill>
+                  <a:srgbClr val="DEE2E6"/>
+                </a:solidFill>
+              </a:rPr>
+              <a:t>Ready or Game Over</a:t>
+            </a:r>
+          </a:p>
+        </p:txBody>
+      </p:sp>
+      <p:sp>
+        <p:nvSpPr>
+          <p:cNvPr id="302" name="Rounded Rectangle 301"/>
+          <p:cNvSpPr/>
+          <p:nvPr/>
+        </p:nvSpPr>
+        <p:spPr>
+          <a:xfrm>
+            <a:off x="2651760" y="2377440"/>
+            <a:ext cx="3840480" cy="731520"/>
+          </a:xfrm>
+          <a:prstGeom prst="roundRect">
+            <a:avLst>
+              <a:gd name="adj" fmla="val 12000"/>
+            </a:avLst>
+          </a:prstGeom>
+          <a:solidFill>
+            <a:srgbClr val="2E3338"/>
+          </a:solidFill>
+          <a:ln>
+            <a:noFill/>
+          </a:ln>
+          <a:effectLst/>
+        </p:spPr>
+        <p:style>
+          <a:lnRef idx="1">
+            <a:schemeClr val="accent1"/>
+          </a:lnRef>
+          <a:fillRef idx="3">
+            <a:schemeClr val="accent1"/>
+          </a:fillRef>
+          <a:effectRef idx="2">
+            <a:schemeClr val="accent1"/>
+          </a:effectRef>
+          <a:fontRef idx="minor">
+            <a:schemeClr val="lt1"/>
+          </a:fontRef>
+        </p:style>
+        <p:txBody>
+          <a:bodyPr rtlCol="0" anchor="ctr" wrap="square" lIns="73152" rIns="73152"/>
+          <a:lstStyle/>
+          <a:p>
+            <a:pPr algn="ctr"/>
+            <a:r>
+              <a:rPr sz="1400" b="1">
+                <a:solidFill>
+                  <a:srgbClr val="DEE2E6"/>
+                </a:solidFill>
+              </a:rPr>
+              <a:t>Each ghost: InHouse, Scatter, Chase, ...</a:t>
+            </a:r>
+          </a:p>
+          <a:p>
+            <a:pPr algn="ctr"/>
+            <a:r>
+              <a:rPr sz="1200" b="0">
+                <a:solidFill>
+                  <a:srgbClr val="9AA3AB"/>
+                </a:solidFill>
+              </a:rPr>
+              <a:t>updated only while the game is in Play</a:t>
+            </a:r>
+          </a:p>
+        </p:txBody>
+      </p:sp>
+      <p:cxnSp>
+        <p:nvCxnSpPr>
+          <p:cNvPr id="303" name="Connector 302"/>
+          <p:cNvCxnSpPr/>
+          <p:nvPr/>
+        </p:nvCxnSpPr>
+        <p:spPr>
+          <a:xfrm>
+            <a:off x="3749039" y="2057400"/>
+            <a:ext cx="457201" cy="301752"/>
+          </a:xfrm>
+          <a:prstGeom prst="line">
+            <a:avLst/>
+          </a:prstGeom>
+          <a:ln w="25400">
+            <a:solidFill>
+              <a:srgbClr val="9AA3AB"/>
+            </a:solidFill>
+            <a:tailEnd type="triangle"/>
+          </a:ln>
+        </p:spPr>
+        <p:style>
+          <a:lnRef idx="2">
+            <a:schemeClr val="accent1"/>
+          </a:lnRef>
+          <a:fillRef idx="0">
+            <a:schemeClr val="accent1"/>
+          </a:fillRef>
+          <a:effectRef idx="1">
+            <a:schemeClr val="accent1"/>
+          </a:effectRef>
+          <a:fontRef idx="minor">
+            <a:schemeClr val="tx1"/>
+          </a:fontRef>
+        </p:style>
+      </p:cxnSp>
+      <p:sp>
+        <p:nvSpPr>
+          <p:cNvPr id="304" name="TextBox 303"/>
+          <p:cNvSpPr txBox="1"/>
+          <p:nvPr/>
+        </p:nvSpPr>
+        <p:spPr>
+          <a:xfrm>
+            <a:off x="548640" y="3383280"/>
+            <a:ext cx="8046720" cy="365760"/>
+          </a:xfrm>
+          <a:prstGeom prst="rect">
+            <a:avLst/>
+          </a:prstGeom>
+          <a:noFill/>
+        </p:spPr>
+        <p:txBody>
+          <a:bodyPr wrap="square">
+            <a:spAutoFit/>
+          </a:bodyPr>
+          <a:lstStyle/>
+          <a:p>
+            <a:pPr algn="ctr"/>
+            <a:r>
+              <a:rPr sz="1400" b="0" i="0">
+                <a:solidFill>
+                  <a:srgbClr val="9AA3AB"/>
+                </a:solidFill>
+              </a:rPr>
+              <a:t>While Pac-Man dies, the ghosts’ states simply pause.</a:t>
+            </a:r>
           </a:p>
         </p:txBody>
       </p:sp>
@@ -12719,6 +14643,179 @@
 </p:sld>
 </file>
 
+<file path=ppt/slides/slide27.xml><?xml version="1.0" encoding="utf-8"?>
+<p:sld xmlns:a="http://schemas.openxmlformats.org/drawingml/2006/main" xmlns:p="http://schemas.openxmlformats.org/presentationml/2006/main" xmlns:r="http://schemas.openxmlformats.org/officeDocument/2006/relationships">
+  <p:cSld>
+    <p:spTree>
+      <p:nvGrpSpPr>
+        <p:cNvPr id="1" name=""/>
+        <p:cNvGrpSpPr/>
+        <p:nvPr/>
+      </p:nvGrpSpPr>
+      <p:grpSpPr/>
+      <p:sp>
+        <p:nvSpPr>
+          <p:cNvPr id="2" name="Title 1"/>
+          <p:cNvSpPr>
+            <a:spLocks noGrp="1"/>
+          </p:cNvSpPr>
+          <p:nvPr>
+            <p:ph type="title"/>
+          </p:nvPr>
+        </p:nvSpPr>
+        <p:spPr/>
+        <p:txBody>
+          <a:bodyPr/>
+          <a:lstStyle/>
+          <a:p>
+            <a:pPr indent="0" lvl="0" marL="0" rtl="0" algn="l">
+              <a:spcBef>
+                <a:spcPts val="0"/>
+              </a:spcBef>
+              <a:spcAft>
+                <a:spcPts val="0"/>
+              </a:spcAft>
+              <a:buNone/>
+            </a:pPr>
+            <a:r>
+              <a:rPr lang="en"/>
+              <a:t>Check Yourself</a:t>
+            </a:r>
+            <a:endParaRPr/>
+          </a:p>
+        </p:txBody>
+      </p:sp>
+      <p:sp>
+        <p:nvSpPr>
+          <p:cNvPr id="3" name="Text Placeholder 2"/>
+          <p:cNvSpPr>
+            <a:spLocks noGrp="1"/>
+          </p:cNvSpPr>
+          <p:nvPr>
+            <p:ph type="body" idx="1"/>
+          </p:nvPr>
+        </p:nvSpPr>
+        <p:spPr>
+          <a:xfrm>
+            <a:off x="311700" y="885950"/>
+            <a:ext cx="8520600" cy="1719072"/>
+          </a:xfrm>
+        </p:spPr>
+        <p:txBody>
+          <a:bodyPr/>
+          <a:lstStyle/>
+          <a:p>
+            <a:pPr indent="-330200" lvl="0" marL="457200" rtl="0" algn="l">
+              <a:spcBef>
+                <a:spcPts val="0"/>
+              </a:spcBef>
+              <a:spcAft>
+                <a:spcPts val="0"/>
+              </a:spcAft>
+              <a:buSzPts val="1600"/>
+              <a:buChar char="●"/>
+            </a:pPr>
+            <a:r>
+              <a:rPr lang="en"/>
+              <a:t>What problems does the enum version of the ghost have?</a:t>
+            </a:r>
+            <a:endParaRPr/>
+          </a:p>
+          <a:p>
+            <a:pPr indent="-330200" lvl="0" marL="457200" rtl="0" algn="l">
+              <a:spcBef>
+                <a:spcPts val="0"/>
+              </a:spcBef>
+              <a:spcAft>
+                <a:spcPts val="0"/>
+              </a:spcAft>
+              <a:buSzPts val="1600"/>
+              <a:buChar char="●"/>
+            </a:pPr>
+            <a:r>
+              <a:rPr lang="en"/>
+              <a:t>In the State pattern, who decides when to change state?</a:t>
+            </a:r>
+            <a:endParaRPr/>
+          </a:p>
+          <a:p>
+            <a:pPr indent="-330200" lvl="0" marL="457200" rtl="0" algn="l">
+              <a:spcBef>
+                <a:spcPts val="0"/>
+              </a:spcBef>
+              <a:spcAft>
+                <a:spcPts val="0"/>
+              </a:spcAft>
+              <a:buSzPts val="1600"/>
+              <a:buChar char="●"/>
+            </a:pPr>
+            <a:r>
+              <a:rPr lang="en"/>
+              <a:t>What are Enter and Exit for?</a:t>
+            </a:r>
+            <a:endParaRPr/>
+          </a:p>
+          <a:p>
+            <a:pPr indent="-330200" lvl="0" marL="457200" rtl="0" algn="l">
+              <a:spcBef>
+                <a:spcPts val="0"/>
+              </a:spcBef>
+              <a:spcAft>
+                <a:spcPts val="0"/>
+              </a:spcAft>
+              <a:buSzPts val="1600"/>
+              <a:buChar char="●"/>
+            </a:pPr>
+            <a:r>
+              <a:rPr lang="en"/>
+              <a:t>State and Strategy have the same structure. How do they differ?</a:t>
+            </a:r>
+            <a:endParaRPr/>
+          </a:p>
+        </p:txBody>
+      </p:sp>
+      <p:sp>
+        <p:nvSpPr>
+          <p:cNvPr id="4" name="TextBox 3"/>
+          <p:cNvSpPr txBox="1"/>
+          <p:nvPr/>
+        </p:nvSpPr>
+        <p:spPr>
+          <a:xfrm>
+            <a:off x="457200" y="3182112"/>
+            <a:ext cx="8229600" cy="457200"/>
+          </a:xfrm>
+          <a:prstGeom prst="rect">
+            <a:avLst/>
+          </a:prstGeom>
+          <a:noFill/>
+        </p:spPr>
+        <p:txBody>
+          <a:bodyPr wrap="square">
+            <a:spAutoFit/>
+          </a:bodyPr>
+          <a:lstStyle/>
+          <a:p>
+            <a:pPr algn="ctr"/>
+            <a:r>
+              <a:rPr sz="1400" b="0" i="0">
+                <a:solidFill>
+                  <a:srgbClr val="9AA3AB"/>
+                </a:solidFill>
+              </a:rPr>
+              <a:t>The answers, and more questions, are on the course site.</a:t>
+            </a:r>
+          </a:p>
+        </p:txBody>
+      </p:sp>
+    </p:spTree>
+  </p:cSld>
+  <p:clrMapOvr>
+    <a:masterClrMapping/>
+  </p:clrMapOvr>
+</p:sld>
+</file>
+
 <file path=ppt/slides/slide3.xml><?xml version="1.0" encoding="utf-8"?>
 <p:sld xmlns:a="http://schemas.openxmlformats.org/drawingml/2006/main" xmlns:r="http://schemas.openxmlformats.org/officeDocument/2006/relationships" xmlns:mc="http://schemas.openxmlformats.org/markup-compatibility/2006" xmlns:mv="urn:schemas-microsoft-com:mac:vml" xmlns:p="http://schemas.openxmlformats.org/presentationml/2006/main" xmlns:c="http://schemas.openxmlformats.org/drawingml/2006/chart" xmlns:dgm="http://schemas.openxmlformats.org/drawingml/2006/diagram" xmlns:o="urn:schemas-microsoft-com:office:office" xmlns:v="urn:schemas-microsoft-com:vml" xmlns:pvml="urn:schemas-microsoft-com:office:powerpoint" xmlns:com="http://schemas.openxmlformats.org/drawingml/2006/compatibility" xmlns:p14="http://schemas.microsoft.com/office/powerpoint/2010/main" xmlns:p15="http://schemas.microsoft.com/office/powerpoint/2012/main" xmlns:ahyp="http://schemas.microsoft.com/office/drawing/2018/hyperlinkcolor">
   <p:cSld>
@@ -13253,7 +15350,7 @@
         <p:spPr>
           <a:xfrm>
             <a:off x="311700" y="885950"/>
-            <a:ext cx="8520600" cy="4023300"/>
+            <a:ext cx="8520600" cy="1289304"/>
           </a:xfrm>
           <a:prstGeom prst="rect">
             <a:avLst/>
@@ -13277,29 +15374,7 @@
             </a:pPr>
             <a:r>
               <a:rPr lang="en"/>
-              <a:t>All Source code for today’s game can be found here:</a:t>
-            </a:r>
-            <a:endParaRPr/>
-          </a:p>
-          <a:p>
-            <a:pPr indent="-317500" lvl="1" marL="914400" rtl="0" algn="l">
-              <a:spcBef>
-                <a:spcPts val="0"/>
-              </a:spcBef>
-              <a:spcAft>
-                <a:spcPts val="0"/>
-              </a:spcAft>
-              <a:buSzPts val="1400"/>
-              <a:buChar char="○"/>
-            </a:pPr>
-            <a:r>
-              <a:rPr lang="en" u="sng">
-                <a:solidFill>
-                  <a:schemeClr val="hlink"/>
-                </a:solidFill>
-                <a:hlinkClick r:id="rId3"/>
-              </a:rPr>
-              <a:t>github.com/Metamate/gar-games (folder 05-pacman)</a:t>
+              <a:t>github.com/Metamate/gar-games, folder 05-pacman</a:t>
             </a:r>
             <a:endParaRPr/>
           </a:p>
@@ -13316,41 +15391,7 @@
             </a:pPr>
             <a:r>
               <a:rPr lang="en"/>
-              <a:t>The game is built up in steps: Pacman0 → Pacman4, and the tests in Pacman.Tests</a:t>
-            </a:r>
-            <a:endParaRPr/>
-          </a:p>
-          <a:p>
-            <a:pPr indent="-317500" lvl="1" marL="914400" rtl="0" algn="l">
-              <a:spcBef>
-                <a:spcPts val="0"/>
-              </a:spcBef>
-              <a:spcAft>
-                <a:spcPts val="0"/>
-              </a:spcAft>
-              <a:buSzPts val="1400"/>
-              <a:buChar char="○"/>
-            </a:pPr>
-            <a:r>
-              <a:rPr lang="en"/>
-              <a:t>Each step is a separate project that adds one concept</a:t>
-            </a:r>
-            <a:endParaRPr/>
-          </a:p>
-          <a:p>
-            <a:pPr indent="-317500" lvl="1" marL="914400" rtl="0" algn="l">
-              <a:spcBef>
-                <a:spcPts val="0"/>
-              </a:spcBef>
-              <a:spcAft>
-                <a:spcPts val="0"/>
-              </a:spcAft>
-              <a:buSzPts val="1400"/>
-              <a:buChar char="○"/>
-            </a:pPr>
-            <a:r>
-              <a:rPr lang="en"/>
-              <a:t>Compare neighbouring steps to see exactly what changed</a:t>
+              <a:t>Its README: the steps (Pacman0 to Pacman4, and Pacman.Tests), a map of the code, how to run it</a:t>
             </a:r>
             <a:endParaRPr/>
           </a:p>
@@ -13367,7 +15408,7 @@
             </a:pPr>
             <a:r>
               <a:rPr lang="en"/>
-              <a:t>Pacman4 is the finished game, and the starting point for the exercises</a:t>
+              <a:t>The course site: today’s concepts in full, the exercises, and questions to check yourself</a:t>
             </a:r>
             <a:endParaRPr/>
           </a:p>
@@ -15123,7 +17164,7 @@
         <p:spPr>
           <a:xfrm>
             <a:off x="311700" y="885950"/>
-            <a:ext cx="8520600" cy="4023300"/>
+            <a:ext cx="8520600" cy="521208"/>
           </a:xfrm>
           <a:prstGeom prst="rect">
             <a:avLst/>
@@ -15147,128 +17188,652 @@
             </a:pPr>
             <a:r>
               <a:rPr lang="en"/>
-              <a:t>In the house: waits, then leaves through the door</a:t>
+              <a:t>Every ghost is always in one of five modes. The mode decides where it heads.</a:t>
             </a:r>
             <a:endParaRPr/>
           </a:p>
-          <a:p>
-            <a:pPr indent="-330200" lvl="0" marL="457200" rtl="0" algn="l">
-              <a:spcBef>
-                <a:spcPts val="0"/>
-              </a:spcBef>
-              <a:spcAft>
-                <a:spcPts val="0"/>
-              </a:spcAft>
-              <a:buSzPts val="1600"/>
-              <a:buChar char="●"/>
-            </a:pPr>
-            <a:r>
-              <a:rPr lang="en"/>
-              <a:t>Scatter: heads for its own corner</a:t>
-            </a:r>
-            <a:endParaRPr/>
-          </a:p>
-          <a:p>
-            <a:pPr indent="-330200" lvl="0" marL="457200" rtl="0" algn="l">
-              <a:spcBef>
-                <a:spcPts val="0"/>
-              </a:spcBef>
-              <a:spcAft>
-                <a:spcPts val="0"/>
-              </a:spcAft>
-              <a:buSzPts val="1600"/>
-              <a:buChar char="●"/>
-            </a:pPr>
-            <a:r>
-              <a:rPr lang="en"/>
-              <a:t>Chase: hunts Pac-Man</a:t>
-            </a:r>
-            <a:endParaRPr/>
-          </a:p>
-          <a:p>
-            <a:pPr indent="-317500" lvl="1" marL="914400" rtl="0" algn="l">
-              <a:spcBef>
-                <a:spcPts val="0"/>
-              </a:spcBef>
-              <a:spcAft>
-                <a:spcPts val="0"/>
-              </a:spcAft>
-              <a:buSzPts val="1400"/>
-              <a:buChar char="○"/>
-            </a:pPr>
-            <a:r>
-              <a:rPr lang="en"/>
-              <a:t>Scatter and chase take turns on a schedule: 7 s, 20 s, …</a:t>
-            </a:r>
-            <a:endParaRPr/>
-          </a:p>
-          <a:p>
-            <a:pPr indent="-330200" lvl="0" marL="457200" rtl="0" algn="l">
-              <a:spcBef>
-                <a:spcPts val="0"/>
-              </a:spcBef>
-              <a:spcAft>
-                <a:spcPts val="0"/>
-              </a:spcAft>
-              <a:buSzPts val="1600"/>
-              <a:buChar char="●"/>
-            </a:pPr>
-            <a:r>
-              <a:rPr lang="en"/>
-              <a:t>Frightened: blue, slow, random; can be eaten</a:t>
-            </a:r>
-            <a:endParaRPr/>
-          </a:p>
-          <a:p>
-            <a:pPr indent="-330200" lvl="0" marL="457200" rtl="0" algn="l">
-              <a:spcBef>
-                <a:spcPts val="0"/>
-              </a:spcBef>
-              <a:spcAft>
-                <a:spcPts val="0"/>
-              </a:spcAft>
-              <a:buSzPts val="1600"/>
-              <a:buChar char="●"/>
-            </a:pPr>
-            <a:r>
-              <a:rPr lang="en"/>
-              <a:t>Eaten: only the eyes, racing back to the house</a:t>
-            </a:r>
-            <a:endParaRPr/>
-          </a:p>
-          <a:p>
-            <a:pPr indent="-330200" lvl="0" marL="457200" rtl="0" algn="l">
-              <a:spcBef>
-                <a:spcPts val="0"/>
-              </a:spcBef>
-              <a:spcAft>
-                <a:spcPts val="0"/>
-              </a:spcAft>
-              <a:buSzPts val="1600"/>
-              <a:buChar char="●"/>
-            </a:pPr>
-            <a:r>
-              <a:rPr lang="en"/>
-              <a:t>At each tile centre: never turn back, and take the direction closest to a target tile</a:t>
-            </a:r>
-            <a:endParaRPr/>
-          </a:p>
-          <a:p>
-            <a:pPr indent="-317500" lvl="1" marL="914400" rtl="0" algn="l">
-              <a:spcBef>
-                <a:spcPts val="0"/>
-              </a:spcBef>
-              <a:spcAft>
-                <a:spcPts val="0"/>
-              </a:spcAft>
-              <a:buSzPts val="1400"/>
-              <a:buChar char="○"/>
-            </a:pPr>
-            <a:r>
-              <a:rPr lang="en"/>
-              <a:t>The mode decides the target</a:t>
-            </a:r>
-            <a:endParaRPr/>
+        </p:txBody>
+      </p:sp>
+      <p:sp>
+        <p:nvSpPr>
+          <p:cNvPr id="295" name="Rounded Rectangle 294"/>
+          <p:cNvSpPr/>
+          <p:nvPr/>
+        </p:nvSpPr>
+        <p:spPr>
+          <a:xfrm>
+            <a:off x="365760" y="1828800"/>
+            <a:ext cx="1463040" cy="640080"/>
+          </a:xfrm>
+          <a:prstGeom prst="roundRect">
+            <a:avLst>
+              <a:gd name="adj" fmla="val 12000"/>
+            </a:avLst>
+          </a:prstGeom>
+          <a:solidFill>
+            <a:srgbClr val="2E3338"/>
+          </a:solidFill>
+          <a:ln>
+            <a:noFill/>
+          </a:ln>
+          <a:effectLst/>
+        </p:spPr>
+        <p:style>
+          <a:lnRef idx="1">
+            <a:schemeClr val="accent1"/>
+          </a:lnRef>
+          <a:fillRef idx="3">
+            <a:schemeClr val="accent1"/>
+          </a:fillRef>
+          <a:effectRef idx="2">
+            <a:schemeClr val="accent1"/>
+          </a:effectRef>
+          <a:fontRef idx="minor">
+            <a:schemeClr val="lt1"/>
+          </a:fontRef>
+        </p:style>
+        <p:txBody>
+          <a:bodyPr rtlCol="0" anchor="ctr" wrap="square" lIns="73152" rIns="73152"/>
+          <a:lstStyle/>
+          <a:p>
+            <a:pPr algn="ctr"/>
+            <a:r>
+              <a:rPr sz="1400" b="1">
+                <a:solidFill>
+                  <a:srgbClr val="DEE2E6"/>
+                </a:solidFill>
+              </a:rPr>
+              <a:t>In the house</a:t>
+            </a:r>
+          </a:p>
+          <a:p>
+            <a:pPr algn="ctr"/>
+            <a:r>
+              <a:rPr sz="1200" b="0">
+                <a:solidFill>
+                  <a:srgbClr val="9AA3AB"/>
+                </a:solidFill>
+              </a:rPr>
+              <a:t>waits</a:t>
+            </a:r>
+          </a:p>
+        </p:txBody>
+      </p:sp>
+      <p:sp>
+        <p:nvSpPr>
+          <p:cNvPr id="296" name="Rounded Rectangle 295"/>
+          <p:cNvSpPr/>
+          <p:nvPr/>
+        </p:nvSpPr>
+        <p:spPr>
+          <a:xfrm>
+            <a:off x="2468880" y="1325880"/>
+            <a:ext cx="1463040" cy="640080"/>
+          </a:xfrm>
+          <a:prstGeom prst="roundRect">
+            <a:avLst>
+              <a:gd name="adj" fmla="val 12000"/>
+            </a:avLst>
+          </a:prstGeom>
+          <a:solidFill>
+            <a:srgbClr val="2E3338"/>
+          </a:solidFill>
+          <a:ln>
+            <a:noFill/>
+          </a:ln>
+          <a:effectLst/>
+        </p:spPr>
+        <p:style>
+          <a:lnRef idx="1">
+            <a:schemeClr val="accent1"/>
+          </a:lnRef>
+          <a:fillRef idx="3">
+            <a:schemeClr val="accent1"/>
+          </a:fillRef>
+          <a:effectRef idx="2">
+            <a:schemeClr val="accent1"/>
+          </a:effectRef>
+          <a:fontRef idx="minor">
+            <a:schemeClr val="lt1"/>
+          </a:fontRef>
+        </p:style>
+        <p:txBody>
+          <a:bodyPr rtlCol="0" anchor="ctr" wrap="square" lIns="73152" rIns="73152"/>
+          <a:lstStyle/>
+          <a:p>
+            <a:pPr algn="ctr"/>
+            <a:r>
+              <a:rPr sz="1400" b="1">
+                <a:solidFill>
+                  <a:srgbClr val="DEE2E6"/>
+                </a:solidFill>
+              </a:rPr>
+              <a:t>Scatter</a:t>
+            </a:r>
+          </a:p>
+          <a:p>
+            <a:pPr algn="ctr"/>
+            <a:r>
+              <a:rPr sz="1200" b="0">
+                <a:solidFill>
+                  <a:srgbClr val="9AA3AB"/>
+                </a:solidFill>
+              </a:rPr>
+              <a:t>its corner</a:t>
+            </a:r>
+          </a:p>
+        </p:txBody>
+      </p:sp>
+      <p:sp>
+        <p:nvSpPr>
+          <p:cNvPr id="297" name="Rounded Rectangle 296"/>
+          <p:cNvSpPr/>
+          <p:nvPr/>
+        </p:nvSpPr>
+        <p:spPr>
+          <a:xfrm>
+            <a:off x="2468880" y="2331720"/>
+            <a:ext cx="1463040" cy="640080"/>
+          </a:xfrm>
+          <a:prstGeom prst="roundRect">
+            <a:avLst>
+              <a:gd name="adj" fmla="val 12000"/>
+            </a:avLst>
+          </a:prstGeom>
+          <a:solidFill>
+            <a:srgbClr val="2E3338"/>
+          </a:solidFill>
+          <a:ln w="25400">
+            <a:solidFill>
+              <a:srgbClr val="D45D35"/>
+            </a:solidFill>
+          </a:ln>
+          <a:effectLst/>
+        </p:spPr>
+        <p:style>
+          <a:lnRef idx="1">
+            <a:schemeClr val="accent1"/>
+          </a:lnRef>
+          <a:fillRef idx="3">
+            <a:schemeClr val="accent1"/>
+          </a:fillRef>
+          <a:effectRef idx="2">
+            <a:schemeClr val="accent1"/>
+          </a:effectRef>
+          <a:fontRef idx="minor">
+            <a:schemeClr val="lt1"/>
+          </a:fontRef>
+        </p:style>
+        <p:txBody>
+          <a:bodyPr rtlCol="0" anchor="ctr" wrap="square" lIns="73152" rIns="73152"/>
+          <a:lstStyle/>
+          <a:p>
+            <a:pPr algn="ctr"/>
+            <a:r>
+              <a:rPr sz="1400" b="1">
+                <a:solidFill>
+                  <a:srgbClr val="DEE2E6"/>
+                </a:solidFill>
+              </a:rPr>
+              <a:t>Chase</a:t>
+            </a:r>
+          </a:p>
+          <a:p>
+            <a:pPr algn="ctr"/>
+            <a:r>
+              <a:rPr sz="1200" b="0">
+                <a:solidFill>
+                  <a:srgbClr val="9AA3AB"/>
+                </a:solidFill>
+              </a:rPr>
+              <a:t>Pac-Man</a:t>
+            </a:r>
+          </a:p>
+        </p:txBody>
+      </p:sp>
+      <p:sp>
+        <p:nvSpPr>
+          <p:cNvPr id="298" name="Rounded Rectangle 297"/>
+          <p:cNvSpPr/>
+          <p:nvPr/>
+        </p:nvSpPr>
+        <p:spPr>
+          <a:xfrm>
+            <a:off x="4846320" y="1828800"/>
+            <a:ext cx="1645920" cy="640080"/>
+          </a:xfrm>
+          <a:prstGeom prst="roundRect">
+            <a:avLst>
+              <a:gd name="adj" fmla="val 12000"/>
+            </a:avLst>
+          </a:prstGeom>
+          <a:solidFill>
+            <a:srgbClr val="2E3338"/>
+          </a:solidFill>
+          <a:ln>
+            <a:noFill/>
+          </a:ln>
+          <a:effectLst/>
+        </p:spPr>
+        <p:style>
+          <a:lnRef idx="1">
+            <a:schemeClr val="accent1"/>
+          </a:lnRef>
+          <a:fillRef idx="3">
+            <a:schemeClr val="accent1"/>
+          </a:fillRef>
+          <a:effectRef idx="2">
+            <a:schemeClr val="accent1"/>
+          </a:effectRef>
+          <a:fontRef idx="minor">
+            <a:schemeClr val="lt1"/>
+          </a:fontRef>
+        </p:style>
+        <p:txBody>
+          <a:bodyPr rtlCol="0" anchor="ctr" wrap="square" lIns="73152" rIns="73152"/>
+          <a:lstStyle/>
+          <a:p>
+            <a:pPr algn="ctr"/>
+            <a:r>
+              <a:rPr sz="1400" b="1">
+                <a:solidFill>
+                  <a:srgbClr val="DEE2E6"/>
+                </a:solidFill>
+              </a:rPr>
+              <a:t>Frightened</a:t>
+            </a:r>
+          </a:p>
+          <a:p>
+            <a:pPr algn="ctr"/>
+            <a:r>
+              <a:rPr sz="1200" b="0">
+                <a:solidFill>
+                  <a:srgbClr val="9AA3AB"/>
+                </a:solidFill>
+              </a:rPr>
+              <a:t>blue, random</a:t>
+            </a:r>
+          </a:p>
+        </p:txBody>
+      </p:sp>
+      <p:sp>
+        <p:nvSpPr>
+          <p:cNvPr id="299" name="Rounded Rectangle 298"/>
+          <p:cNvSpPr/>
+          <p:nvPr/>
+        </p:nvSpPr>
+        <p:spPr>
+          <a:xfrm>
+            <a:off x="7132320" y="1828800"/>
+            <a:ext cx="1463040" cy="640080"/>
+          </a:xfrm>
+          <a:prstGeom prst="roundRect">
+            <a:avLst>
+              <a:gd name="adj" fmla="val 12000"/>
+            </a:avLst>
+          </a:prstGeom>
+          <a:solidFill>
+            <a:srgbClr val="2E3338"/>
+          </a:solidFill>
+          <a:ln>
+            <a:noFill/>
+          </a:ln>
+          <a:effectLst/>
+        </p:spPr>
+        <p:style>
+          <a:lnRef idx="1">
+            <a:schemeClr val="accent1"/>
+          </a:lnRef>
+          <a:fillRef idx="3">
+            <a:schemeClr val="accent1"/>
+          </a:fillRef>
+          <a:effectRef idx="2">
+            <a:schemeClr val="accent1"/>
+          </a:effectRef>
+          <a:fontRef idx="minor">
+            <a:schemeClr val="lt1"/>
+          </a:fontRef>
+        </p:style>
+        <p:txBody>
+          <a:bodyPr rtlCol="0" anchor="ctr" wrap="square" lIns="73152" rIns="73152"/>
+          <a:lstStyle/>
+          <a:p>
+            <a:pPr algn="ctr"/>
+            <a:r>
+              <a:rPr sz="1400" b="1">
+                <a:solidFill>
+                  <a:srgbClr val="DEE2E6"/>
+                </a:solidFill>
+              </a:rPr>
+              <a:t>Eaten</a:t>
+            </a:r>
+          </a:p>
+          <a:p>
+            <a:pPr algn="ctr"/>
+            <a:r>
+              <a:rPr sz="1200" b="0">
+                <a:solidFill>
+                  <a:srgbClr val="9AA3AB"/>
+                </a:solidFill>
+              </a:rPr>
+              <a:t>eyes go home</a:t>
+            </a:r>
+          </a:p>
+        </p:txBody>
+      </p:sp>
+      <p:cxnSp>
+        <p:nvCxnSpPr>
+          <p:cNvPr id="300" name="Connector 299"/>
+          <p:cNvCxnSpPr/>
+          <p:nvPr/>
+        </p:nvCxnSpPr>
+        <p:spPr>
+          <a:xfrm flipV="1">
+            <a:off x="1847088" y="1691640"/>
+            <a:ext cx="603504" cy="320040"/>
+          </a:xfrm>
+          <a:prstGeom prst="line">
+            <a:avLst/>
+          </a:prstGeom>
+          <a:ln w="25400">
+            <a:solidFill>
+              <a:srgbClr val="9AA3AB"/>
+            </a:solidFill>
+            <a:tailEnd type="triangle"/>
+          </a:ln>
+        </p:spPr>
+        <p:style>
+          <a:lnRef idx="2">
+            <a:schemeClr val="accent1"/>
+          </a:lnRef>
+          <a:fillRef idx="0">
+            <a:schemeClr val="accent1"/>
+          </a:fillRef>
+          <a:effectRef idx="1">
+            <a:schemeClr val="accent1"/>
+          </a:effectRef>
+          <a:fontRef idx="minor">
+            <a:schemeClr val="tx1"/>
+          </a:fontRef>
+        </p:style>
+      </p:cxnSp>
+      <p:cxnSp>
+        <p:nvCxnSpPr>
+          <p:cNvPr id="301" name="Connector 300"/>
+          <p:cNvCxnSpPr/>
+          <p:nvPr/>
+        </p:nvCxnSpPr>
+        <p:spPr>
+          <a:xfrm>
+            <a:off x="3108960" y="1984248"/>
+            <a:ext cx="0" cy="329184"/>
+          </a:xfrm>
+          <a:prstGeom prst="line">
+            <a:avLst/>
+          </a:prstGeom>
+          <a:ln w="25400">
+            <a:solidFill>
+              <a:srgbClr val="9AA3AB"/>
+            </a:solidFill>
+            <a:tailEnd type="triangle"/>
+          </a:ln>
+        </p:spPr>
+        <p:style>
+          <a:lnRef idx="2">
+            <a:schemeClr val="accent1"/>
+          </a:lnRef>
+          <a:fillRef idx="0">
+            <a:schemeClr val="accent1"/>
+          </a:fillRef>
+          <a:effectRef idx="1">
+            <a:schemeClr val="accent1"/>
+          </a:effectRef>
+          <a:fontRef idx="minor">
+            <a:schemeClr val="tx1"/>
+          </a:fontRef>
+        </p:style>
+      </p:cxnSp>
+      <p:cxnSp>
+        <p:nvCxnSpPr>
+          <p:cNvPr id="302" name="Connector 301"/>
+          <p:cNvCxnSpPr/>
+          <p:nvPr/>
+        </p:nvCxnSpPr>
+        <p:spPr>
+          <a:xfrm flipV="1">
+            <a:off x="3291840" y="1984248"/>
+            <a:ext cx="0" cy="329184"/>
+          </a:xfrm>
+          <a:prstGeom prst="line">
+            <a:avLst/>
+          </a:prstGeom>
+          <a:ln w="25400">
+            <a:solidFill>
+              <a:srgbClr val="9AA3AB"/>
+            </a:solidFill>
+            <a:tailEnd type="triangle"/>
+          </a:ln>
+        </p:spPr>
+        <p:style>
+          <a:lnRef idx="2">
+            <a:schemeClr val="accent1"/>
+          </a:lnRef>
+          <a:fillRef idx="0">
+            <a:schemeClr val="accent1"/>
+          </a:fillRef>
+          <a:effectRef idx="1">
+            <a:schemeClr val="accent1"/>
+          </a:effectRef>
+          <a:fontRef idx="minor">
+            <a:schemeClr val="tx1"/>
+          </a:fontRef>
+        </p:style>
+      </p:cxnSp>
+      <p:sp>
+        <p:nvSpPr>
+          <p:cNvPr id="303" name="TextBox 302"/>
+          <p:cNvSpPr txBox="1"/>
+          <p:nvPr/>
+        </p:nvSpPr>
+        <p:spPr>
+          <a:xfrm>
+            <a:off x="3429000" y="2011680"/>
+            <a:ext cx="1097280" cy="274320"/>
+          </a:xfrm>
+          <a:prstGeom prst="rect">
+            <a:avLst/>
+          </a:prstGeom>
+          <a:noFill/>
+        </p:spPr>
+        <p:txBody>
+          <a:bodyPr wrap="square">
+            <a:spAutoFit/>
+          </a:bodyPr>
+          <a:lstStyle/>
+          <a:p>
+            <a:pPr algn="l"/>
+            <a:r>
+              <a:rPr sz="1100" b="0" i="0">
+                <a:solidFill>
+                  <a:srgbClr val="9AA3AB"/>
+                </a:solidFill>
+              </a:rPr>
+              <a:t>schedule</a:t>
+            </a:r>
+          </a:p>
+        </p:txBody>
+      </p:sp>
+      <p:cxnSp>
+        <p:nvCxnSpPr>
+          <p:cNvPr id="304" name="Connector 303"/>
+          <p:cNvCxnSpPr/>
+          <p:nvPr/>
+        </p:nvCxnSpPr>
+        <p:spPr>
+          <a:xfrm flipV="1">
+            <a:off x="3950208" y="2331720"/>
+            <a:ext cx="877824" cy="320040"/>
+          </a:xfrm>
+          <a:prstGeom prst="line">
+            <a:avLst/>
+          </a:prstGeom>
+          <a:ln w="25400">
+            <a:solidFill>
+              <a:srgbClr val="9AA3AB"/>
+            </a:solidFill>
+            <a:tailEnd type="triangle"/>
+          </a:ln>
+        </p:spPr>
+        <p:style>
+          <a:lnRef idx="2">
+            <a:schemeClr val="accent1"/>
+          </a:lnRef>
+          <a:fillRef idx="0">
+            <a:schemeClr val="accent1"/>
+          </a:fillRef>
+          <a:effectRef idx="1">
+            <a:schemeClr val="accent1"/>
+          </a:effectRef>
+          <a:fontRef idx="minor">
+            <a:schemeClr val="tx1"/>
+          </a:fontRef>
+        </p:style>
+      </p:cxnSp>
+      <p:sp>
+        <p:nvSpPr>
+          <p:cNvPr id="305" name="TextBox 304"/>
+          <p:cNvSpPr txBox="1"/>
+          <p:nvPr/>
+        </p:nvSpPr>
+        <p:spPr>
+          <a:xfrm>
+            <a:off x="3977639" y="2560320"/>
+            <a:ext cx="1097280" cy="274320"/>
+          </a:xfrm>
+          <a:prstGeom prst="rect">
+            <a:avLst/>
+          </a:prstGeom>
+          <a:noFill/>
+        </p:spPr>
+        <p:txBody>
+          <a:bodyPr wrap="square">
+            <a:spAutoFit/>
+          </a:bodyPr>
+          <a:lstStyle/>
+          <a:p>
+            <a:pPr algn="l"/>
+            <a:r>
+              <a:rPr sz="1100" b="0" i="0">
+                <a:solidFill>
+                  <a:srgbClr val="9AA3AB"/>
+                </a:solidFill>
+              </a:rPr>
+              <a:t>power pellet</a:t>
+            </a:r>
+          </a:p>
+        </p:txBody>
+      </p:sp>
+      <p:cxnSp>
+        <p:nvCxnSpPr>
+          <p:cNvPr id="306" name="Connector 305"/>
+          <p:cNvCxnSpPr/>
+          <p:nvPr/>
+        </p:nvCxnSpPr>
+        <p:spPr>
+          <a:xfrm>
+            <a:off x="6510528" y="2148840"/>
+            <a:ext cx="603504" cy="0"/>
+          </a:xfrm>
+          <a:prstGeom prst="line">
+            <a:avLst/>
+          </a:prstGeom>
+          <a:ln w="25400">
+            <a:solidFill>
+              <a:srgbClr val="9AA3AB"/>
+            </a:solidFill>
+            <a:tailEnd type="triangle"/>
+          </a:ln>
+        </p:spPr>
+        <p:style>
+          <a:lnRef idx="2">
+            <a:schemeClr val="accent1"/>
+          </a:lnRef>
+          <a:fillRef idx="0">
+            <a:schemeClr val="accent1"/>
+          </a:fillRef>
+          <a:effectRef idx="1">
+            <a:schemeClr val="accent1"/>
+          </a:effectRef>
+          <a:fontRef idx="minor">
+            <a:schemeClr val="tx1"/>
+          </a:fontRef>
+        </p:style>
+      </p:cxnSp>
+      <p:sp>
+        <p:nvSpPr>
+          <p:cNvPr id="307" name="TextBox 306"/>
+          <p:cNvSpPr txBox="1"/>
+          <p:nvPr/>
+        </p:nvSpPr>
+        <p:spPr>
+          <a:xfrm>
+            <a:off x="6327648" y="1856232"/>
+            <a:ext cx="969264" cy="274320"/>
+          </a:xfrm>
+          <a:prstGeom prst="rect">
+            <a:avLst/>
+          </a:prstGeom>
+          <a:noFill/>
+        </p:spPr>
+        <p:txBody>
+          <a:bodyPr wrap="square">
+            <a:spAutoFit/>
+          </a:bodyPr>
+          <a:lstStyle/>
+          <a:p>
+            <a:pPr algn="ctr"/>
+            <a:r>
+              <a:rPr sz="1100" b="0" i="0">
+                <a:solidFill>
+                  <a:srgbClr val="9AA3AB"/>
+                </a:solidFill>
+              </a:rPr>
+              <a:t>touched</a:t>
+            </a:r>
+          </a:p>
+        </p:txBody>
+      </p:sp>
+      <p:sp>
+        <p:nvSpPr>
+          <p:cNvPr id="308" name="TextBox 307"/>
+          <p:cNvSpPr txBox="1"/>
+          <p:nvPr/>
+        </p:nvSpPr>
+        <p:spPr>
+          <a:xfrm>
+            <a:off x="365760" y="3200400"/>
+            <a:ext cx="8229600" cy="548640"/>
+          </a:xfrm>
+          <a:prstGeom prst="rect">
+            <a:avLst/>
+          </a:prstGeom>
+          <a:noFill/>
+        </p:spPr>
+        <p:txBody>
+          <a:bodyPr wrap="square">
+            <a:spAutoFit/>
+          </a:bodyPr>
+          <a:lstStyle/>
+          <a:p>
+            <a:pPr algn="ctr"/>
+            <a:r>
+              <a:rPr sz="1500" b="1" i="0">
+                <a:solidFill>
+                  <a:srgbClr val="DEE2E6"/>
+                </a:solidFill>
+              </a:rPr>
+              <a:t>At each tile centre: never turn back, and take the direction closest to a target tile.</a:t>
+            </a:r>
           </a:p>
         </p:txBody>
       </p:sp>

</xml_diff>

<commit_message>
Session 05: the fifth ghost and the cherry are in the sprite sheet
Co-Authored-By: Claude Opus 5.5 <noreply@anthropic.com>
Claude-Session: https://claude.ai/code/session_012sjsUQBbC7zon57rWHoo9d
</commit_message>
<xml_diff>
--- a/slides/05 Pac-Man.pptx
+++ b/slides/05 Pac-Man.pptx
@@ -2285,6 +2285,11 @@
           <a:p>
             <a:r>
               <a:t>Start from Pacman4. For the new mode, ask them to compare the classes they changed with Pacman1’s enum. Test first for the new ghost.</a:t>
+            </a:r>
+          </a:p>
+          <a:p>
+            <a:r>
+              <a:t>The fifth ghost (green) and a cherry are drawn in sprites.png but not in the XML: describing them is part of the exercise.</a:t>
             </a:r>
           </a:p>
         </p:txBody>

</xml_diff>

<commit_message>
Sessions 04-12: a short task after each demo, on the step just shown, so listening and doing alternate
Co-Authored-By: Claude Opus 5.5 <noreply@anthropic.com>
Claude-Session: https://claude.ai/code/session_012sjsUQBbC7zon57rWHoo9d
</commit_message>
<xml_diff>
--- a/slides/05 Pac-Man.pptx
+++ b/slides/05 Pac-Man.pptx
@@ -16,17 +16,21 @@
     <p:sldId id="297" r:id="rId56"/>
     <p:sldId id="298" r:id="rId57"/>
     <p:sldId id="299" r:id="rId58"/>
+    <p:sldId id="319" r:id="rId36"/>
     <p:sldId id="300" r:id="rId59"/>
     <p:sldId id="301" r:id="rId60"/>
     <p:sldId id="302" r:id="rId61"/>
     <p:sldId id="303" r:id="rId62"/>
+    <p:sldId id="318" r:id="rId37"/>
     <p:sldId id="304" r:id="rId63"/>
     <p:sldId id="305" r:id="rId64"/>
     <p:sldId id="306" r:id="rId65"/>
     <p:sldId id="307" r:id="rId66"/>
+    <p:sldId id="317" r:id="rId38"/>
     <p:sldId id="308" r:id="rId67"/>
     <p:sldId id="309" r:id="rId68"/>
     <p:sldId id="310" r:id="rId69"/>
+    <p:sldId id="316" r:id="rId39"/>
     <p:sldId id="311" r:id="rId70"/>
     <p:sldId id="312" r:id="rId71"/>
     <p:sldId id="313" r:id="rId72"/>
@@ -2183,6 +2187,64 @@
 </p:notes>
 </file>
 
+<file path=ppt/notesSlides/notesSlide29.xml><?xml version="1.0" encoding="utf-8"?>
+<p:notes xmlns:a="http://schemas.openxmlformats.org/drawingml/2006/main" xmlns:p="http://schemas.openxmlformats.org/presentationml/2006/main" xmlns:r="http://schemas.openxmlformats.org/officeDocument/2006/relationships">
+  <p:cSld>
+    <p:spTree>
+      <p:nvGrpSpPr>
+        <p:cNvPr id="1" name=""/>
+        <p:cNvGrpSpPr/>
+        <p:nvPr/>
+      </p:nvGrpSpPr>
+      <p:grpSpPr>
+        <a:xfrm>
+          <a:off x="0" y="0"/>
+          <a:ext cx="0" cy="0"/>
+          <a:chOff x="0" y="0"/>
+          <a:chExt cx="0" cy="0"/>
+        </a:xfrm>
+      </p:grpSpPr>
+      <p:sp>
+        <p:nvSpPr>
+          <p:cNvPr id="2" name="Slide Image Placeholder 1"/>
+          <p:cNvSpPr>
+            <a:spLocks noGrp="1"/>
+          </p:cNvSpPr>
+          <p:nvPr>
+            <p:ph type="sldImg" idx="2"/>
+          </p:nvPr>
+        </p:nvSpPr>
+        <p:spPr/>
+      </p:sp>
+      <p:sp>
+        <p:nvSpPr>
+          <p:cNvPr id="3" name="Notes Placeholder 2"/>
+          <p:cNvSpPr>
+            <a:spLocks noGrp="1"/>
+          </p:cNvSpPr>
+          <p:nvPr>
+            <p:ph type="body" idx="1"/>
+          </p:nvPr>
+        </p:nvSpPr>
+        <p:spPr/>
+        <p:txBody>
+          <a:bodyPr/>
+          <a:lstStyle/>
+          <a:p>
+            <a:r>
+              <a:t>Pairs, about 5 minutes. One argument in World. Two ghosts that chase straight at Pac-Man end up in a line behind him, which is easy to escape.</a:t>
+            </a:r>
+          </a:p>
+        </p:txBody>
+      </p:sp>
+    </p:spTree>
+  </p:cSld>
+  <p:clrMapOvr>
+    <a:masterClrMapping/>
+  </p:clrMapOvr>
+</p:notes>
+</file>
+
 <file path=ppt/notesSlides/notesSlide3.xml><?xml version="1.0" encoding="utf-8"?>
 <p:notes xmlns:a="http://schemas.openxmlformats.org/drawingml/2006/main" xmlns:r="http://schemas.openxmlformats.org/officeDocument/2006/relationships" xmlns:mc="http://schemas.openxmlformats.org/markup-compatibility/2006" xmlns:mv="urn:schemas-microsoft-com:mac:vml" xmlns:p="http://schemas.openxmlformats.org/presentationml/2006/main" xmlns:c="http://schemas.openxmlformats.org/drawingml/2006/chart" xmlns:dgm="http://schemas.openxmlformats.org/drawingml/2006/diagram" xmlns:o="urn:schemas-microsoft-com:office:office" xmlns:v="urn:schemas-microsoft-com:vml" xmlns:pvml="urn:schemas-microsoft-com:office:powerpoint" xmlns:com="http://schemas.openxmlformats.org/drawingml/2006/compatibility" xmlns:p14="http://schemas.microsoft.com/office/powerpoint/2010/main" xmlns:p15="http://schemas.microsoft.com/office/powerpoint/2012/main" xmlns:ahyp="http://schemas.microsoft.com/office/drawing/2018/hyperlinkcolor" showMasterPhAnim="0" showMasterSp="0">
   <p:cSld>
@@ -2260,6 +2322,185 @@
           <a:p>
             <a:r>
               <a:t>The main topic: the State pattern, through the ghosts’ modes. Then Strategy for their targeting, and how the two differ.</a:t>
+            </a:r>
+          </a:p>
+        </p:txBody>
+      </p:sp>
+    </p:spTree>
+  </p:cSld>
+  <p:clrMapOvr>
+    <a:masterClrMapping/>
+  </p:clrMapOvr>
+</p:notes>
+</file>
+
+<file path=ppt/notesSlides/notesSlide30.xml><?xml version="1.0" encoding="utf-8"?>
+<p:notes xmlns:a="http://schemas.openxmlformats.org/drawingml/2006/main" xmlns:p="http://schemas.openxmlformats.org/presentationml/2006/main" xmlns:r="http://schemas.openxmlformats.org/officeDocument/2006/relationships">
+  <p:cSld>
+    <p:spTree>
+      <p:nvGrpSpPr>
+        <p:cNvPr id="1" name=""/>
+        <p:cNvGrpSpPr/>
+        <p:nvPr/>
+      </p:nvGrpSpPr>
+      <p:grpSpPr>
+        <a:xfrm>
+          <a:off x="0" y="0"/>
+          <a:ext cx="0" cy="0"/>
+          <a:chOff x="0" y="0"/>
+          <a:chExt cx="0" cy="0"/>
+        </a:xfrm>
+      </p:grpSpPr>
+      <p:sp>
+        <p:nvSpPr>
+          <p:cNvPr id="2" name="Slide Image Placeholder 1"/>
+          <p:cNvSpPr>
+            <a:spLocks noGrp="1"/>
+          </p:cNvSpPr>
+          <p:nvPr>
+            <p:ph type="sldImg" idx="2"/>
+          </p:nvPr>
+        </p:nvSpPr>
+        <p:spPr/>
+      </p:sp>
+      <p:sp>
+        <p:nvSpPr>
+          <p:cNvPr id="3" name="Notes Placeholder 2"/>
+          <p:cNvSpPr>
+            <a:spLocks noGrp="1"/>
+          </p:cNvSpPr>
+          <p:nvPr>
+            <p:ph type="body" idx="1"/>
+          </p:nvPr>
+        </p:nvSpPr>
+        <p:spPr/>
+        <p:txBody>
+          <a:bodyPr/>
+          <a:lstStyle/>
+          <a:p>
+            <a:r>
+              <a:t>Pairs, about 5 minutes. Answer: one constant in FrightenedState. A FrozenState is one new class, and EatenState (or whatever state comes before it) changes to it. Compare with the seven switches.</a:t>
+            </a:r>
+          </a:p>
+        </p:txBody>
+      </p:sp>
+    </p:spTree>
+  </p:cSld>
+  <p:clrMapOvr>
+    <a:masterClrMapping/>
+  </p:clrMapOvr>
+</p:notes>
+</file>
+
+<file path=ppt/notesSlides/notesSlide31.xml><?xml version="1.0" encoding="utf-8"?>
+<p:notes xmlns:a="http://schemas.openxmlformats.org/drawingml/2006/main" xmlns:p="http://schemas.openxmlformats.org/presentationml/2006/main" xmlns:r="http://schemas.openxmlformats.org/officeDocument/2006/relationships">
+  <p:cSld>
+    <p:spTree>
+      <p:nvGrpSpPr>
+        <p:cNvPr id="1" name=""/>
+        <p:cNvGrpSpPr/>
+        <p:nvPr/>
+      </p:nvGrpSpPr>
+      <p:grpSpPr>
+        <a:xfrm>
+          <a:off x="0" y="0"/>
+          <a:ext cx="0" cy="0"/>
+          <a:chOff x="0" y="0"/>
+          <a:chExt cx="0" cy="0"/>
+        </a:xfrm>
+      </p:grpSpPr>
+      <p:sp>
+        <p:nvSpPr>
+          <p:cNvPr id="2" name="Slide Image Placeholder 1"/>
+          <p:cNvSpPr>
+            <a:spLocks noGrp="1"/>
+          </p:cNvSpPr>
+          <p:nvPr>
+            <p:ph type="sldImg" idx="2"/>
+          </p:nvPr>
+        </p:nvSpPr>
+        <p:spPr/>
+      </p:sp>
+      <p:sp>
+        <p:nvSpPr>
+          <p:cNvPr id="3" name="Notes Placeholder 2"/>
+          <p:cNvSpPr>
+            <a:spLocks noGrp="1"/>
+          </p:cNvSpPr>
+          <p:nvPr>
+            <p:ph type="body" idx="1"/>
+          </p:nvPr>
+        </p:nvSpPr>
+        <p:spPr/>
+        <p:txBody>
+          <a:bodyPr/>
+          <a:lstStyle/>
+          <a:p>
+            <a:r>
+              <a:t>Pairs, about 5 minutes. Answer: seven (six switch statements and the Look switch expression), and nothing warns you about the ones you miss. Keep the count on the board for the next slides.</a:t>
+            </a:r>
+          </a:p>
+        </p:txBody>
+      </p:sp>
+    </p:spTree>
+  </p:cSld>
+  <p:clrMapOvr>
+    <a:masterClrMapping/>
+  </p:clrMapOvr>
+</p:notes>
+</file>
+
+<file path=ppt/notesSlides/notesSlide32.xml><?xml version="1.0" encoding="utf-8"?>
+<p:notes xmlns:a="http://schemas.openxmlformats.org/drawingml/2006/main" xmlns:p="http://schemas.openxmlformats.org/presentationml/2006/main" xmlns:r="http://schemas.openxmlformats.org/officeDocument/2006/relationships">
+  <p:cSld>
+    <p:spTree>
+      <p:nvGrpSpPr>
+        <p:cNvPr id="1" name=""/>
+        <p:cNvGrpSpPr/>
+        <p:nvPr/>
+      </p:nvGrpSpPr>
+      <p:grpSpPr>
+        <a:xfrm>
+          <a:off x="0" y="0"/>
+          <a:ext cx="0" cy="0"/>
+          <a:chOff x="0" y="0"/>
+          <a:chExt cx="0" cy="0"/>
+        </a:xfrm>
+      </p:grpSpPr>
+      <p:sp>
+        <p:nvSpPr>
+          <p:cNvPr id="2" name="Slide Image Placeholder 1"/>
+          <p:cNvSpPr>
+            <a:spLocks noGrp="1"/>
+          </p:cNvSpPr>
+          <p:nvPr>
+            <p:ph type="sldImg" idx="2"/>
+          </p:nvPr>
+        </p:nvSpPr>
+        <p:spPr/>
+      </p:sp>
+      <p:sp>
+        <p:nvSpPr>
+          <p:cNvPr id="3" name="Notes Placeholder 2"/>
+          <p:cNvSpPr>
+            <a:spLocks noGrp="1"/>
+          </p:cNvSpPr>
+          <p:nvPr>
+            <p:ph type="body" idx="1"/>
+          </p:nvPr>
+        </p:nvSpPr>
+        <p:spPr/>
+        <p:txBody>
+          <a:bodyPr/>
+          <a:lstStyle/>
+          <a:p>
+            <a:r>
+              <a:t>Pairs, about 5 minutes. Pacman0 reads the maze at start-up, so a restart shows the change.</a:t>
+            </a:r>
+          </a:p>
+          <a:p>
+            <a:r>
+              <a:t>The early press shows the buffered turn: he turns when he reaches the corner.</a:t>
             </a:r>
           </a:p>
         </p:txBody>
@@ -6380,6 +6621,756 @@
       <p:grpSpPr/>
       <p:sp>
         <p:nvSpPr>
+          <p:cNvPr id="293" name="Google Shape;293;p45"/>
+          <p:cNvSpPr txBox="1"/>
+          <p:nvPr>
+            <p:ph type="title"/>
+          </p:nvPr>
+        </p:nvSpPr>
+        <p:spPr>
+          <a:xfrm>
+            <a:off x="311700" y="195615"/>
+            <a:ext cx="8520600" cy="572700"/>
+          </a:xfrm>
+          <a:prstGeom prst="rect">
+            <a:avLst/>
+          </a:prstGeom>
+        </p:spPr>
+        <p:txBody>
+          <a:bodyPr anchorCtr="0" anchor="t" bIns="91425" lIns="91425" spcFirstLastPara="1" rIns="91425" wrap="square" tIns="91425">
+            <a:normAutofit fontScale="90000"/>
+          </a:bodyPr>
+          <a:lstStyle/>
+          <a:p>
+            <a:pPr indent="0" lvl="0" marL="0" rtl="0" algn="l">
+              <a:spcBef>
+                <a:spcPts val="0"/>
+              </a:spcBef>
+              <a:spcAft>
+                <a:spcPts val="0"/>
+              </a:spcAft>
+              <a:buNone/>
+            </a:pPr>
+            <a:r>
+              <a:rPr lang="en">
+                <a:solidFill>
+                  <a:schemeClr val="accent5"/>
+                </a:solidFill>
+              </a:rPr>
+              <a:t>Five Ghost Modes</a:t>
+            </a:r>
+            <a:endParaRPr>
+              <a:solidFill>
+                <a:schemeClr val="accent5"/>
+              </a:solidFill>
+            </a:endParaRPr>
+          </a:p>
+        </p:txBody>
+      </p:sp>
+      <p:sp>
+        <p:nvSpPr>
+          <p:cNvPr id="294" name="Google Shape;294;p45"/>
+          <p:cNvSpPr txBox="1"/>
+          <p:nvPr>
+            <p:ph idx="1" type="body"/>
+          </p:nvPr>
+        </p:nvSpPr>
+        <p:spPr>
+          <a:xfrm>
+            <a:off x="311700" y="885950"/>
+            <a:ext cx="8520600" cy="521208"/>
+          </a:xfrm>
+          <a:prstGeom prst="rect">
+            <a:avLst/>
+          </a:prstGeom>
+        </p:spPr>
+        <p:txBody>
+          <a:bodyPr anchorCtr="0" anchor="t" bIns="91425" lIns="91425" spcFirstLastPara="1" rIns="91425" wrap="square" tIns="91425">
+            <a:normAutofit/>
+          </a:bodyPr>
+          <a:lstStyle/>
+          <a:p>
+            <a:pPr indent="-330200" lvl="0" marL="457200" rtl="0" algn="l">
+              <a:spcBef>
+                <a:spcPts val="0"/>
+              </a:spcBef>
+              <a:spcAft>
+                <a:spcPts val="0"/>
+              </a:spcAft>
+              <a:buSzPts val="1600"/>
+              <a:buChar char="●"/>
+            </a:pPr>
+            <a:r>
+              <a:rPr lang="en"/>
+              <a:t>Every ghost is always in one of five modes. The mode decides where it heads.</a:t>
+            </a:r>
+            <a:endParaRPr/>
+          </a:p>
+        </p:txBody>
+      </p:sp>
+      <p:sp>
+        <p:nvSpPr>
+          <p:cNvPr id="295" name="Rounded Rectangle 294"/>
+          <p:cNvSpPr/>
+          <p:nvPr/>
+        </p:nvSpPr>
+        <p:spPr>
+          <a:xfrm>
+            <a:off x="365760" y="1828800"/>
+            <a:ext cx="1463040" cy="640080"/>
+          </a:xfrm>
+          <a:prstGeom prst="roundRect">
+            <a:avLst>
+              <a:gd name="adj" fmla="val 12000"/>
+            </a:avLst>
+          </a:prstGeom>
+          <a:solidFill>
+            <a:srgbClr val="2E3338"/>
+          </a:solidFill>
+          <a:ln>
+            <a:noFill/>
+          </a:ln>
+          <a:effectLst/>
+        </p:spPr>
+        <p:style>
+          <a:lnRef idx="1">
+            <a:schemeClr val="accent1"/>
+          </a:lnRef>
+          <a:fillRef idx="3">
+            <a:schemeClr val="accent1"/>
+          </a:fillRef>
+          <a:effectRef idx="2">
+            <a:schemeClr val="accent1"/>
+          </a:effectRef>
+          <a:fontRef idx="minor">
+            <a:schemeClr val="lt1"/>
+          </a:fontRef>
+        </p:style>
+        <p:txBody>
+          <a:bodyPr rtlCol="0" anchor="ctr" wrap="square" lIns="73152" rIns="73152"/>
+          <a:lstStyle/>
+          <a:p>
+            <a:pPr algn="ctr"/>
+            <a:r>
+              <a:rPr sz="1400" b="1">
+                <a:solidFill>
+                  <a:srgbClr val="DEE2E6"/>
+                </a:solidFill>
+              </a:rPr>
+              <a:t>In the house</a:t>
+            </a:r>
+          </a:p>
+          <a:p>
+            <a:pPr algn="ctr"/>
+            <a:r>
+              <a:rPr sz="1200" b="0">
+                <a:solidFill>
+                  <a:srgbClr val="9AA3AB"/>
+                </a:solidFill>
+              </a:rPr>
+              <a:t>waits</a:t>
+            </a:r>
+          </a:p>
+        </p:txBody>
+      </p:sp>
+      <p:sp>
+        <p:nvSpPr>
+          <p:cNvPr id="296" name="Rounded Rectangle 295"/>
+          <p:cNvSpPr/>
+          <p:nvPr/>
+        </p:nvSpPr>
+        <p:spPr>
+          <a:xfrm>
+            <a:off x="2468880" y="1325880"/>
+            <a:ext cx="1463040" cy="640080"/>
+          </a:xfrm>
+          <a:prstGeom prst="roundRect">
+            <a:avLst>
+              <a:gd name="adj" fmla="val 12000"/>
+            </a:avLst>
+          </a:prstGeom>
+          <a:solidFill>
+            <a:srgbClr val="2E3338"/>
+          </a:solidFill>
+          <a:ln>
+            <a:noFill/>
+          </a:ln>
+          <a:effectLst/>
+        </p:spPr>
+        <p:style>
+          <a:lnRef idx="1">
+            <a:schemeClr val="accent1"/>
+          </a:lnRef>
+          <a:fillRef idx="3">
+            <a:schemeClr val="accent1"/>
+          </a:fillRef>
+          <a:effectRef idx="2">
+            <a:schemeClr val="accent1"/>
+          </a:effectRef>
+          <a:fontRef idx="minor">
+            <a:schemeClr val="lt1"/>
+          </a:fontRef>
+        </p:style>
+        <p:txBody>
+          <a:bodyPr rtlCol="0" anchor="ctr" wrap="square" lIns="73152" rIns="73152"/>
+          <a:lstStyle/>
+          <a:p>
+            <a:pPr algn="ctr"/>
+            <a:r>
+              <a:rPr sz="1400" b="1">
+                <a:solidFill>
+                  <a:srgbClr val="DEE2E6"/>
+                </a:solidFill>
+              </a:rPr>
+              <a:t>Scatter</a:t>
+            </a:r>
+          </a:p>
+          <a:p>
+            <a:pPr algn="ctr"/>
+            <a:r>
+              <a:rPr sz="1200" b="0">
+                <a:solidFill>
+                  <a:srgbClr val="9AA3AB"/>
+                </a:solidFill>
+              </a:rPr>
+              <a:t>its corner</a:t>
+            </a:r>
+          </a:p>
+        </p:txBody>
+      </p:sp>
+      <p:sp>
+        <p:nvSpPr>
+          <p:cNvPr id="297" name="Rounded Rectangle 296"/>
+          <p:cNvSpPr/>
+          <p:nvPr/>
+        </p:nvSpPr>
+        <p:spPr>
+          <a:xfrm>
+            <a:off x="2468880" y="2331720"/>
+            <a:ext cx="1463040" cy="640080"/>
+          </a:xfrm>
+          <a:prstGeom prst="roundRect">
+            <a:avLst>
+              <a:gd name="adj" fmla="val 12000"/>
+            </a:avLst>
+          </a:prstGeom>
+          <a:solidFill>
+            <a:srgbClr val="2E3338"/>
+          </a:solidFill>
+          <a:ln w="25400">
+            <a:solidFill>
+              <a:srgbClr val="D45D35"/>
+            </a:solidFill>
+          </a:ln>
+          <a:effectLst/>
+        </p:spPr>
+        <p:style>
+          <a:lnRef idx="1">
+            <a:schemeClr val="accent1"/>
+          </a:lnRef>
+          <a:fillRef idx="3">
+            <a:schemeClr val="accent1"/>
+          </a:fillRef>
+          <a:effectRef idx="2">
+            <a:schemeClr val="accent1"/>
+          </a:effectRef>
+          <a:fontRef idx="minor">
+            <a:schemeClr val="lt1"/>
+          </a:fontRef>
+        </p:style>
+        <p:txBody>
+          <a:bodyPr rtlCol="0" anchor="ctr" wrap="square" lIns="73152" rIns="73152"/>
+          <a:lstStyle/>
+          <a:p>
+            <a:pPr algn="ctr"/>
+            <a:r>
+              <a:rPr sz="1400" b="1">
+                <a:solidFill>
+                  <a:srgbClr val="DEE2E6"/>
+                </a:solidFill>
+              </a:rPr>
+              <a:t>Chase</a:t>
+            </a:r>
+          </a:p>
+          <a:p>
+            <a:pPr algn="ctr"/>
+            <a:r>
+              <a:rPr sz="1200" b="0">
+                <a:solidFill>
+                  <a:srgbClr val="9AA3AB"/>
+                </a:solidFill>
+              </a:rPr>
+              <a:t>Pac-Man</a:t>
+            </a:r>
+          </a:p>
+        </p:txBody>
+      </p:sp>
+      <p:sp>
+        <p:nvSpPr>
+          <p:cNvPr id="298" name="Rounded Rectangle 297"/>
+          <p:cNvSpPr/>
+          <p:nvPr/>
+        </p:nvSpPr>
+        <p:spPr>
+          <a:xfrm>
+            <a:off x="4846320" y="1828800"/>
+            <a:ext cx="1645920" cy="640080"/>
+          </a:xfrm>
+          <a:prstGeom prst="roundRect">
+            <a:avLst>
+              <a:gd name="adj" fmla="val 12000"/>
+            </a:avLst>
+          </a:prstGeom>
+          <a:solidFill>
+            <a:srgbClr val="2E3338"/>
+          </a:solidFill>
+          <a:ln>
+            <a:noFill/>
+          </a:ln>
+          <a:effectLst/>
+        </p:spPr>
+        <p:style>
+          <a:lnRef idx="1">
+            <a:schemeClr val="accent1"/>
+          </a:lnRef>
+          <a:fillRef idx="3">
+            <a:schemeClr val="accent1"/>
+          </a:fillRef>
+          <a:effectRef idx="2">
+            <a:schemeClr val="accent1"/>
+          </a:effectRef>
+          <a:fontRef idx="minor">
+            <a:schemeClr val="lt1"/>
+          </a:fontRef>
+        </p:style>
+        <p:txBody>
+          <a:bodyPr rtlCol="0" anchor="ctr" wrap="square" lIns="73152" rIns="73152"/>
+          <a:lstStyle/>
+          <a:p>
+            <a:pPr algn="ctr"/>
+            <a:r>
+              <a:rPr sz="1400" b="1">
+                <a:solidFill>
+                  <a:srgbClr val="DEE2E6"/>
+                </a:solidFill>
+              </a:rPr>
+              <a:t>Frightened</a:t>
+            </a:r>
+          </a:p>
+          <a:p>
+            <a:pPr algn="ctr"/>
+            <a:r>
+              <a:rPr sz="1200" b="0">
+                <a:solidFill>
+                  <a:srgbClr val="9AA3AB"/>
+                </a:solidFill>
+              </a:rPr>
+              <a:t>blue, random</a:t>
+            </a:r>
+          </a:p>
+        </p:txBody>
+      </p:sp>
+      <p:sp>
+        <p:nvSpPr>
+          <p:cNvPr id="299" name="Rounded Rectangle 298"/>
+          <p:cNvSpPr/>
+          <p:nvPr/>
+        </p:nvSpPr>
+        <p:spPr>
+          <a:xfrm>
+            <a:off x="7132320" y="1828800"/>
+            <a:ext cx="1463040" cy="640080"/>
+          </a:xfrm>
+          <a:prstGeom prst="roundRect">
+            <a:avLst>
+              <a:gd name="adj" fmla="val 12000"/>
+            </a:avLst>
+          </a:prstGeom>
+          <a:solidFill>
+            <a:srgbClr val="2E3338"/>
+          </a:solidFill>
+          <a:ln>
+            <a:noFill/>
+          </a:ln>
+          <a:effectLst/>
+        </p:spPr>
+        <p:style>
+          <a:lnRef idx="1">
+            <a:schemeClr val="accent1"/>
+          </a:lnRef>
+          <a:fillRef idx="3">
+            <a:schemeClr val="accent1"/>
+          </a:fillRef>
+          <a:effectRef idx="2">
+            <a:schemeClr val="accent1"/>
+          </a:effectRef>
+          <a:fontRef idx="minor">
+            <a:schemeClr val="lt1"/>
+          </a:fontRef>
+        </p:style>
+        <p:txBody>
+          <a:bodyPr rtlCol="0" anchor="ctr" wrap="square" lIns="73152" rIns="73152"/>
+          <a:lstStyle/>
+          <a:p>
+            <a:pPr algn="ctr"/>
+            <a:r>
+              <a:rPr sz="1400" b="1">
+                <a:solidFill>
+                  <a:srgbClr val="DEE2E6"/>
+                </a:solidFill>
+              </a:rPr>
+              <a:t>Eaten</a:t>
+            </a:r>
+          </a:p>
+          <a:p>
+            <a:pPr algn="ctr"/>
+            <a:r>
+              <a:rPr sz="1200" b="0">
+                <a:solidFill>
+                  <a:srgbClr val="9AA3AB"/>
+                </a:solidFill>
+              </a:rPr>
+              <a:t>eyes go home</a:t>
+            </a:r>
+          </a:p>
+        </p:txBody>
+      </p:sp>
+      <p:cxnSp>
+        <p:nvCxnSpPr>
+          <p:cNvPr id="300" name="Connector 299"/>
+          <p:cNvCxnSpPr/>
+          <p:nvPr/>
+        </p:nvCxnSpPr>
+        <p:spPr>
+          <a:xfrm flipV="1">
+            <a:off x="1847088" y="1691640"/>
+            <a:ext cx="603504" cy="320040"/>
+          </a:xfrm>
+          <a:prstGeom prst="line">
+            <a:avLst/>
+          </a:prstGeom>
+          <a:ln w="25400">
+            <a:solidFill>
+              <a:srgbClr val="9AA3AB"/>
+            </a:solidFill>
+            <a:tailEnd type="triangle"/>
+          </a:ln>
+        </p:spPr>
+        <p:style>
+          <a:lnRef idx="2">
+            <a:schemeClr val="accent1"/>
+          </a:lnRef>
+          <a:fillRef idx="0">
+            <a:schemeClr val="accent1"/>
+          </a:fillRef>
+          <a:effectRef idx="1">
+            <a:schemeClr val="accent1"/>
+          </a:effectRef>
+          <a:fontRef idx="minor">
+            <a:schemeClr val="tx1"/>
+          </a:fontRef>
+        </p:style>
+      </p:cxnSp>
+      <p:cxnSp>
+        <p:nvCxnSpPr>
+          <p:cNvPr id="301" name="Connector 300"/>
+          <p:cNvCxnSpPr/>
+          <p:nvPr/>
+        </p:nvCxnSpPr>
+        <p:spPr>
+          <a:xfrm>
+            <a:off x="3108960" y="1984248"/>
+            <a:ext cx="0" cy="329184"/>
+          </a:xfrm>
+          <a:prstGeom prst="line">
+            <a:avLst/>
+          </a:prstGeom>
+          <a:ln w="25400">
+            <a:solidFill>
+              <a:srgbClr val="9AA3AB"/>
+            </a:solidFill>
+            <a:tailEnd type="triangle"/>
+          </a:ln>
+        </p:spPr>
+        <p:style>
+          <a:lnRef idx="2">
+            <a:schemeClr val="accent1"/>
+          </a:lnRef>
+          <a:fillRef idx="0">
+            <a:schemeClr val="accent1"/>
+          </a:fillRef>
+          <a:effectRef idx="1">
+            <a:schemeClr val="accent1"/>
+          </a:effectRef>
+          <a:fontRef idx="minor">
+            <a:schemeClr val="tx1"/>
+          </a:fontRef>
+        </p:style>
+      </p:cxnSp>
+      <p:cxnSp>
+        <p:nvCxnSpPr>
+          <p:cNvPr id="302" name="Connector 301"/>
+          <p:cNvCxnSpPr/>
+          <p:nvPr/>
+        </p:nvCxnSpPr>
+        <p:spPr>
+          <a:xfrm flipV="1">
+            <a:off x="3291840" y="1984248"/>
+            <a:ext cx="0" cy="329184"/>
+          </a:xfrm>
+          <a:prstGeom prst="line">
+            <a:avLst/>
+          </a:prstGeom>
+          <a:ln w="25400">
+            <a:solidFill>
+              <a:srgbClr val="9AA3AB"/>
+            </a:solidFill>
+            <a:tailEnd type="triangle"/>
+          </a:ln>
+        </p:spPr>
+        <p:style>
+          <a:lnRef idx="2">
+            <a:schemeClr val="accent1"/>
+          </a:lnRef>
+          <a:fillRef idx="0">
+            <a:schemeClr val="accent1"/>
+          </a:fillRef>
+          <a:effectRef idx="1">
+            <a:schemeClr val="accent1"/>
+          </a:effectRef>
+          <a:fontRef idx="minor">
+            <a:schemeClr val="tx1"/>
+          </a:fontRef>
+        </p:style>
+      </p:cxnSp>
+      <p:sp>
+        <p:nvSpPr>
+          <p:cNvPr id="303" name="TextBox 302"/>
+          <p:cNvSpPr txBox="1"/>
+          <p:nvPr/>
+        </p:nvSpPr>
+        <p:spPr>
+          <a:xfrm>
+            <a:off x="3429000" y="2011680"/>
+            <a:ext cx="1097280" cy="274320"/>
+          </a:xfrm>
+          <a:prstGeom prst="rect">
+            <a:avLst/>
+          </a:prstGeom>
+          <a:noFill/>
+        </p:spPr>
+        <p:txBody>
+          <a:bodyPr wrap="square">
+            <a:spAutoFit/>
+          </a:bodyPr>
+          <a:lstStyle/>
+          <a:p>
+            <a:pPr algn="l"/>
+            <a:r>
+              <a:rPr sz="1100" b="0" i="0">
+                <a:solidFill>
+                  <a:srgbClr val="9AA3AB"/>
+                </a:solidFill>
+              </a:rPr>
+              <a:t>schedule</a:t>
+            </a:r>
+          </a:p>
+        </p:txBody>
+      </p:sp>
+      <p:cxnSp>
+        <p:nvCxnSpPr>
+          <p:cNvPr id="304" name="Connector 303"/>
+          <p:cNvCxnSpPr/>
+          <p:nvPr/>
+        </p:nvCxnSpPr>
+        <p:spPr>
+          <a:xfrm flipV="1">
+            <a:off x="3950208" y="2331720"/>
+            <a:ext cx="877824" cy="320040"/>
+          </a:xfrm>
+          <a:prstGeom prst="line">
+            <a:avLst/>
+          </a:prstGeom>
+          <a:ln w="25400">
+            <a:solidFill>
+              <a:srgbClr val="9AA3AB"/>
+            </a:solidFill>
+            <a:tailEnd type="triangle"/>
+          </a:ln>
+        </p:spPr>
+        <p:style>
+          <a:lnRef idx="2">
+            <a:schemeClr val="accent1"/>
+          </a:lnRef>
+          <a:fillRef idx="0">
+            <a:schemeClr val="accent1"/>
+          </a:fillRef>
+          <a:effectRef idx="1">
+            <a:schemeClr val="accent1"/>
+          </a:effectRef>
+          <a:fontRef idx="minor">
+            <a:schemeClr val="tx1"/>
+          </a:fontRef>
+        </p:style>
+      </p:cxnSp>
+      <p:sp>
+        <p:nvSpPr>
+          <p:cNvPr id="305" name="TextBox 304"/>
+          <p:cNvSpPr txBox="1"/>
+          <p:nvPr/>
+        </p:nvSpPr>
+        <p:spPr>
+          <a:xfrm>
+            <a:off x="3977639" y="2560320"/>
+            <a:ext cx="1097280" cy="274320"/>
+          </a:xfrm>
+          <a:prstGeom prst="rect">
+            <a:avLst/>
+          </a:prstGeom>
+          <a:noFill/>
+        </p:spPr>
+        <p:txBody>
+          <a:bodyPr wrap="square">
+            <a:spAutoFit/>
+          </a:bodyPr>
+          <a:lstStyle/>
+          <a:p>
+            <a:pPr algn="l"/>
+            <a:r>
+              <a:rPr sz="1100" b="0" i="0">
+                <a:solidFill>
+                  <a:srgbClr val="9AA3AB"/>
+                </a:solidFill>
+              </a:rPr>
+              <a:t>power pellet</a:t>
+            </a:r>
+          </a:p>
+        </p:txBody>
+      </p:sp>
+      <p:cxnSp>
+        <p:nvCxnSpPr>
+          <p:cNvPr id="306" name="Connector 305"/>
+          <p:cNvCxnSpPr/>
+          <p:nvPr/>
+        </p:nvCxnSpPr>
+        <p:spPr>
+          <a:xfrm>
+            <a:off x="6510528" y="2148840"/>
+            <a:ext cx="603504" cy="0"/>
+          </a:xfrm>
+          <a:prstGeom prst="line">
+            <a:avLst/>
+          </a:prstGeom>
+          <a:ln w="25400">
+            <a:solidFill>
+              <a:srgbClr val="9AA3AB"/>
+            </a:solidFill>
+            <a:tailEnd type="triangle"/>
+          </a:ln>
+        </p:spPr>
+        <p:style>
+          <a:lnRef idx="2">
+            <a:schemeClr val="accent1"/>
+          </a:lnRef>
+          <a:fillRef idx="0">
+            <a:schemeClr val="accent1"/>
+          </a:fillRef>
+          <a:effectRef idx="1">
+            <a:schemeClr val="accent1"/>
+          </a:effectRef>
+          <a:fontRef idx="minor">
+            <a:schemeClr val="tx1"/>
+          </a:fontRef>
+        </p:style>
+      </p:cxnSp>
+      <p:sp>
+        <p:nvSpPr>
+          <p:cNvPr id="307" name="TextBox 306"/>
+          <p:cNvSpPr txBox="1"/>
+          <p:nvPr/>
+        </p:nvSpPr>
+        <p:spPr>
+          <a:xfrm>
+            <a:off x="6327648" y="1856232"/>
+            <a:ext cx="969264" cy="274320"/>
+          </a:xfrm>
+          <a:prstGeom prst="rect">
+            <a:avLst/>
+          </a:prstGeom>
+          <a:noFill/>
+        </p:spPr>
+        <p:txBody>
+          <a:bodyPr wrap="square">
+            <a:spAutoFit/>
+          </a:bodyPr>
+          <a:lstStyle/>
+          <a:p>
+            <a:pPr algn="ctr"/>
+            <a:r>
+              <a:rPr sz="1100" b="0" i="0">
+                <a:solidFill>
+                  <a:srgbClr val="9AA3AB"/>
+                </a:solidFill>
+              </a:rPr>
+              <a:t>touched</a:t>
+            </a:r>
+          </a:p>
+        </p:txBody>
+      </p:sp>
+      <p:sp>
+        <p:nvSpPr>
+          <p:cNvPr id="308" name="TextBox 307"/>
+          <p:cNvSpPr txBox="1"/>
+          <p:nvPr/>
+        </p:nvSpPr>
+        <p:spPr>
+          <a:xfrm>
+            <a:off x="365760" y="3200400"/>
+            <a:ext cx="8229600" cy="548640"/>
+          </a:xfrm>
+          <a:prstGeom prst="rect">
+            <a:avLst/>
+          </a:prstGeom>
+          <a:noFill/>
+        </p:spPr>
+        <p:txBody>
+          <a:bodyPr wrap="square">
+            <a:spAutoFit/>
+          </a:bodyPr>
+          <a:lstStyle/>
+          <a:p>
+            <a:pPr algn="ctr"/>
+            <a:r>
+              <a:rPr sz="1500" b="1" i="0">
+                <a:solidFill>
+                  <a:srgbClr val="DEE2E6"/>
+                </a:solidFill>
+              </a:rPr>
+              <a:t>At each tile centre: never turn back, and take the direction closest to a target tile.</a:t>
+            </a:r>
+          </a:p>
+        </p:txBody>
+      </p:sp>
+    </p:spTree>
+  </p:cSld>
+  <p:clrMapOvr>
+    <a:masterClrMapping/>
+  </p:clrMapOvr>
+</p:sld>
+</file>
+
+<file path=ppt/slides/slide11.xml><?xml version="1.0" encoding="utf-8"?>
+<p:sld xmlns:a="http://schemas.openxmlformats.org/drawingml/2006/main" xmlns:p="http://schemas.openxmlformats.org/presentationml/2006/main" xmlns:r="http://schemas.openxmlformats.org/officeDocument/2006/relationships">
+  <p:cSld>
+    <p:spTree>
+      <p:nvGrpSpPr>
+        <p:cNvPr id="1" name=""/>
+        <p:cNvGrpSpPr/>
+        <p:nvPr/>
+      </p:nvGrpSpPr>
+      <p:grpSpPr/>
+      <p:sp>
+        <p:nvSpPr>
           <p:cNvPr id="140" name="Google Shape;140;p23"/>
           <p:cNvSpPr txBox="1"/>
           <p:nvPr>
@@ -7268,7 +8259,7 @@
 </p:sld>
 </file>
 
-<file path=ppt/slides/slide11.xml><?xml version="1.0" encoding="utf-8"?>
+<file path=ppt/slides/slide12.xml><?xml version="1.0" encoding="utf-8"?>
 <p:sld xmlns:a="http://schemas.openxmlformats.org/drawingml/2006/main" xmlns:p="http://schemas.openxmlformats.org/presentationml/2006/main" xmlns:r="http://schemas.openxmlformats.org/officeDocument/2006/relationships">
   <p:cSld>
     <p:spTree>
@@ -7833,7 +8824,7 @@
 </p:sld>
 </file>
 
-<file path=ppt/slides/slide12.xml><?xml version="1.0" encoding="utf-8"?>
+<file path=ppt/slides/slide13.xml><?xml version="1.0" encoding="utf-8"?>
 <p:sld xmlns:a="http://schemas.openxmlformats.org/drawingml/2006/main" xmlns:p="http://schemas.openxmlformats.org/presentationml/2006/main" xmlns:r="http://schemas.openxmlformats.org/officeDocument/2006/relationships">
   <p:cSld>
     <p:spTree>
@@ -7960,7 +8951,129 @@
 </p:sld>
 </file>
 
-<file path=ppt/slides/slide13.xml><?xml version="1.0" encoding="utf-8"?>
+<file path=ppt/slides/slide14.xml><?xml version="1.0" encoding="utf-8"?>
+<p:sld xmlns:a="http://schemas.openxmlformats.org/drawingml/2006/main" xmlns:p="http://schemas.openxmlformats.org/presentationml/2006/main" xmlns:r="http://schemas.openxmlformats.org/officeDocument/2006/relationships">
+  <p:cSld>
+    <p:spTree>
+      <p:nvGrpSpPr>
+        <p:cNvPr id="1" name=""/>
+        <p:cNvGrpSpPr/>
+        <p:nvPr/>
+      </p:nvGrpSpPr>
+      <p:grpSpPr/>
+      <p:sp>
+        <p:nvSpPr>
+          <p:cNvPr id="2" name="Title 1"/>
+          <p:cNvSpPr>
+            <a:spLocks noGrp="1"/>
+          </p:cNvSpPr>
+          <p:nvPr>
+            <p:ph type="title"/>
+          </p:nvPr>
+        </p:nvSpPr>
+        <p:spPr/>
+        <p:txBody>
+          <a:bodyPr/>
+          <a:lstStyle/>
+          <a:p>
+            <a:pPr indent="0" lvl="0" marL="0" rtl="0" algn="l">
+              <a:spcBef>
+                <a:spcPts val="0"/>
+              </a:spcBef>
+              <a:spcAft>
+                <a:spcPts val="0"/>
+              </a:spcAft>
+              <a:buNone/>
+            </a:pPr>
+            <a:r>
+              <a:rPr lang="en"/>
+              <a:t>Try It: A Frozen Mode</a:t>
+            </a:r>
+            <a:endParaRPr/>
+          </a:p>
+        </p:txBody>
+      </p:sp>
+      <p:sp>
+        <p:nvSpPr>
+          <p:cNvPr id="3" name="Text Placeholder 2"/>
+          <p:cNvSpPr>
+            <a:spLocks noGrp="1"/>
+          </p:cNvSpPr>
+          <p:nvPr>
+            <p:ph type="body" idx="1"/>
+          </p:nvPr>
+        </p:nvSpPr>
+        <p:spPr>
+          <a:xfrm>
+            <a:off x="311700" y="885950"/>
+            <a:ext cx="8520600" cy="1289304"/>
+          </a:xfrm>
+        </p:spPr>
+        <p:txBody>
+          <a:bodyPr/>
+          <a:lstStyle/>
+          <a:p>
+            <a:pPr indent="-330200" lvl="0" marL="457200" rtl="0" algn="l">
+              <a:spcBef>
+                <a:spcPts val="0"/>
+              </a:spcBef>
+              <a:spcAft>
+                <a:spcPts val="0"/>
+              </a:spcAft>
+              <a:buSzPts val="1600"/>
+              <a:buChar char="●"/>
+            </a:pPr>
+            <a:r>
+              <a:rPr lang="en"/>
+              <a:t>In Pacman1, add Frozen to GhostMode:</a:t>
+            </a:r>
+            <a:endParaRPr/>
+          </a:p>
+          <a:p>
+            <a:pPr indent="-330200" lvl="0" marL="457200" rtl="0" algn="l">
+              <a:spcBef>
+                <a:spcPts val="0"/>
+              </a:spcBef>
+              <a:spcAft>
+                <a:spcPts val="0"/>
+              </a:spcAft>
+              <a:buSzPts val="1600"/>
+              <a:buChar char="●"/>
+            </a:pPr>
+            <a:r>
+              <a:rPr lang="en"/>
+              <a:t>an eaten ghost stands still for a second first</a:t>
+            </a:r>
+            <a:endParaRPr/>
+          </a:p>
+          <a:p>
+            <a:pPr indent="-330200" lvl="0" marL="457200" rtl="0" algn="l">
+              <a:spcBef>
+                <a:spcPts val="0"/>
+              </a:spcBef>
+              <a:spcAft>
+                <a:spcPts val="0"/>
+              </a:spcAft>
+              <a:buSzPts val="1600"/>
+              <a:buChar char="●"/>
+            </a:pPr>
+            <a:r>
+              <a:rPr lang="en"/>
+              <a:t>Don’t finish it. Count the switches you would have to change</a:t>
+            </a:r>
+            <a:endParaRPr/>
+          </a:p>
+        </p:txBody>
+      </p:sp>
+    </p:spTree>
+  </p:cSld>
+  <p:clrMapOvr>
+    <a:masterClrMapping/>
+  </p:clrMapOvr>
+</p:sld>
+</file>
+
+<file path=ppt/slides/slide15.xml><?xml version="1.0" encoding="utf-8"?>
 <p:sld xmlns:a="http://schemas.openxmlformats.org/drawingml/2006/main" xmlns:p="http://schemas.openxmlformats.org/presentationml/2006/main" xmlns:r="http://schemas.openxmlformats.org/officeDocument/2006/relationships">
   <p:cSld>
     <p:spTree>
@@ -8680,7 +9793,7 @@
 </p:sld>
 </file>
 
-<file path=ppt/slides/slide14.xml><?xml version="1.0" encoding="utf-8"?>
+<file path=ppt/slides/slide16.xml><?xml version="1.0" encoding="utf-8"?>
 <p:sld xmlns:a="http://schemas.openxmlformats.org/drawingml/2006/main" xmlns:p="http://schemas.openxmlformats.org/presentationml/2006/main" xmlns:r="http://schemas.openxmlformats.org/officeDocument/2006/relationships">
   <p:cSld>
     <p:spTree>
@@ -9652,7 +10765,7 @@
 </p:sld>
 </file>
 
-<file path=ppt/slides/slide15.xml><?xml version="1.0" encoding="utf-8"?>
+<file path=ppt/slides/slide17.xml><?xml version="1.0" encoding="utf-8"?>
 <p:sld xmlns:a="http://schemas.openxmlformats.org/drawingml/2006/main" xmlns:p="http://schemas.openxmlformats.org/presentationml/2006/main" xmlns:r="http://schemas.openxmlformats.org/officeDocument/2006/relationships">
   <p:cSld>
     <p:spTree>
@@ -10010,7 +11123,7 @@
 </p:sld>
 </file>
 
-<file path=ppt/slides/slide16.xml><?xml version="1.0" encoding="utf-8"?>
+<file path=ppt/slides/slide18.xml><?xml version="1.0" encoding="utf-8"?>
 <p:sld xmlns:a="http://schemas.openxmlformats.org/drawingml/2006/main" xmlns:p="http://schemas.openxmlformats.org/presentationml/2006/main" xmlns:r="http://schemas.openxmlformats.org/officeDocument/2006/relationships">
   <p:cSld>
     <p:spTree>
@@ -10137,7 +11250,259 @@
 </p:sld>
 </file>
 
-<file path=ppt/slides/slide17.xml><?xml version="1.0" encoding="utf-8"?>
+<file path=ppt/slides/slide19.xml><?xml version="1.0" encoding="utf-8"?>
+<p:sld xmlns:a="http://schemas.openxmlformats.org/drawingml/2006/main" xmlns:p="http://schemas.openxmlformats.org/presentationml/2006/main" xmlns:r="http://schemas.openxmlformats.org/officeDocument/2006/relationships">
+  <p:cSld>
+    <p:spTree>
+      <p:nvGrpSpPr>
+        <p:cNvPr id="1" name=""/>
+        <p:cNvGrpSpPr/>
+        <p:nvPr/>
+      </p:nvGrpSpPr>
+      <p:grpSpPr/>
+      <p:sp>
+        <p:nvSpPr>
+          <p:cNvPr id="2" name="Title 1"/>
+          <p:cNvSpPr>
+            <a:spLocks noGrp="1"/>
+          </p:cNvSpPr>
+          <p:nvPr>
+            <p:ph type="title"/>
+          </p:nvPr>
+        </p:nvSpPr>
+        <p:spPr/>
+        <p:txBody>
+          <a:bodyPr/>
+          <a:lstStyle/>
+          <a:p>
+            <a:pPr indent="0" lvl="0" marL="0" rtl="0" algn="l">
+              <a:spcBef>
+                <a:spcPts val="0"/>
+              </a:spcBef>
+              <a:spcAft>
+                <a:spcPts val="0"/>
+              </a:spcAft>
+              <a:buNone/>
+            </a:pPr>
+            <a:r>
+              <a:rPr lang="en"/>
+              <a:t>Try It: The Same Change, With States</a:t>
+            </a:r>
+            <a:endParaRPr/>
+          </a:p>
+        </p:txBody>
+      </p:sp>
+      <p:sp>
+        <p:nvSpPr>
+          <p:cNvPr id="3" name="Text Placeholder 2"/>
+          <p:cNvSpPr>
+            <a:spLocks noGrp="1"/>
+          </p:cNvSpPr>
+          <p:nvPr>
+            <p:ph type="body" idx="1"/>
+          </p:nvPr>
+        </p:nvSpPr>
+        <p:spPr>
+          <a:xfrm>
+            <a:off x="311700" y="885950"/>
+            <a:ext cx="8520600" cy="1673352"/>
+          </a:xfrm>
+        </p:spPr>
+        <p:txBody>
+          <a:bodyPr/>
+          <a:lstStyle/>
+          <a:p>
+            <a:pPr indent="-330200" lvl="0" marL="457200" rtl="0" algn="l">
+              <a:spcBef>
+                <a:spcPts val="0"/>
+              </a:spcBef>
+              <a:spcAft>
+                <a:spcPts val="0"/>
+              </a:spcAft>
+              <a:buSzPts val="1600"/>
+              <a:buChar char="●"/>
+            </a:pPr>
+            <a:r>
+              <a:rPr lang="en"/>
+              <a:t>In Pacman2:</a:t>
+            </a:r>
+            <a:endParaRPr/>
+          </a:p>
+          <a:p>
+            <a:pPr indent="-330200" lvl="0" marL="457200" rtl="0" algn="l">
+              <a:spcBef>
+                <a:spcPts val="0"/>
+              </a:spcBef>
+              <a:spcAft>
+                <a:spcPts val="0"/>
+              </a:spcAft>
+              <a:buSzPts val="1600"/>
+              <a:buChar char="●"/>
+            </a:pPr>
+            <a:r>
+              <a:rPr lang="en"/>
+              <a:t>Make frightened ghosts last 3 seconds instead of 6</a:t>
+            </a:r>
+            <a:endParaRPr/>
+          </a:p>
+          <a:p>
+            <a:pPr indent="-330200" lvl="0" marL="457200" rtl="0" algn="l">
+              <a:spcBef>
+                <a:spcPts val="0"/>
+              </a:spcBef>
+              <a:spcAft>
+                <a:spcPts val="0"/>
+              </a:spcAft>
+              <a:buSzPts val="1600"/>
+              <a:buChar char="●"/>
+            </a:pPr>
+            <a:r>
+              <a:rPr lang="en"/>
+              <a:t>How many files did it take?</a:t>
+            </a:r>
+            <a:endParaRPr/>
+          </a:p>
+          <a:p>
+            <a:pPr indent="-330200" lvl="0" marL="457200" rtl="0" algn="l">
+              <a:spcBef>
+                <a:spcPts val="0"/>
+              </a:spcBef>
+              <a:spcAft>
+                <a:spcPts val="0"/>
+              </a:spcAft>
+              <a:buSzPts val="1600"/>
+              <a:buChar char="●"/>
+            </a:pPr>
+            <a:r>
+              <a:rPr lang="en"/>
+              <a:t>Where would a FrozenState go, and what would change?</a:t>
+            </a:r>
+            <a:endParaRPr/>
+          </a:p>
+        </p:txBody>
+      </p:sp>
+    </p:spTree>
+  </p:cSld>
+  <p:clrMapOvr>
+    <a:masterClrMapping/>
+  </p:clrMapOvr>
+</p:sld>
+</file>
+
+<file path=ppt/slides/slide2.xml><?xml version="1.0" encoding="utf-8"?>
+<p:sld xmlns:a="http://schemas.openxmlformats.org/drawingml/2006/main" xmlns:p="http://schemas.openxmlformats.org/presentationml/2006/main" xmlns:r="http://schemas.openxmlformats.org/officeDocument/2006/relationships">
+  <p:cSld>
+    <p:spTree>
+      <p:nvGrpSpPr>
+        <p:cNvPr id="1" name=""/>
+        <p:cNvGrpSpPr/>
+        <p:nvPr/>
+      </p:nvGrpSpPr>
+      <p:grpSpPr/>
+      <p:sp>
+        <p:nvSpPr>
+          <p:cNvPr id="2" name="Title 1"/>
+          <p:cNvSpPr>
+            <a:spLocks noGrp="1"/>
+          </p:cNvSpPr>
+          <p:nvPr>
+            <p:ph type="title"/>
+          </p:nvPr>
+        </p:nvSpPr>
+        <p:spPr>
+          <a:xfrm>
+            <a:off x="311700" y="195615"/>
+            <a:ext cx="8520600" cy="572700"/>
+          </a:xfrm>
+        </p:spPr>
+        <p:txBody>
+          <a:bodyPr/>
+          <a:lstStyle/>
+          <a:p>
+            <a:pPr indent="0" lvl="0" marL="0" rtl="0" algn="l">
+              <a:spcBef>
+                <a:spcPts val="0"/>
+              </a:spcBef>
+              <a:spcAft>
+                <a:spcPts val="0"/>
+              </a:spcAft>
+              <a:buNone/>
+            </a:pPr>
+            <a:r>
+              <a:rPr lang="en"/>
+              <a:t>Pac-Man</a:t>
+            </a:r>
+            <a:endParaRPr/>
+          </a:p>
+        </p:txBody>
+      </p:sp>
+      <p:pic>
+        <p:nvPicPr>
+          <p:cNvPr id="3" name="Picture 2" descr="pac-man.png"/>
+          <p:cNvPicPr>
+            <a:picLocks noChangeAspect="1"/>
+          </p:cNvPicPr>
+          <p:nvPr/>
+        </p:nvPicPr>
+        <p:blipFill>
+          <a:blip r:embed="rId2"/>
+          <a:stretch>
+            <a:fillRect/>
+          </a:stretch>
+        </p:blipFill>
+        <p:spPr>
+          <a:xfrm>
+            <a:off x="3149600" y="960120"/>
+            <a:ext cx="2844800" cy="3657600"/>
+          </a:xfrm>
+          <a:prstGeom prst="rect">
+            <a:avLst/>
+          </a:prstGeom>
+        </p:spPr>
+      </p:pic>
+      <p:sp>
+        <p:nvSpPr>
+          <p:cNvPr id="4" name="TextBox 3"/>
+          <p:cNvSpPr txBox="1"/>
+          <p:nvPr/>
+        </p:nvSpPr>
+        <p:spPr>
+          <a:xfrm>
+            <a:off x="457200" y="4736592"/>
+            <a:ext cx="8229600" cy="274320"/>
+          </a:xfrm>
+          <a:prstGeom prst="rect">
+            <a:avLst/>
+          </a:prstGeom>
+          <a:noFill/>
+        </p:spPr>
+        <p:txBody>
+          <a:bodyPr wrap="square">
+            <a:spAutoFit/>
+          </a:bodyPr>
+          <a:lstStyle/>
+          <a:p>
+            <a:pPr algn="ctr"/>
+            <a:r>
+              <a:rPr sz="900" b="0" i="0">
+                <a:solidFill>
+                  <a:srgbClr val="9AA3AB"/>
+                </a:solidFill>
+              </a:rPr>
+              <a:t>Pac-Man (Namco, 1980). Image: Bandai Namco Entertainment America, CC BY 3.0, via Wikimedia Commons.</a:t>
+            </a:r>
+          </a:p>
+        </p:txBody>
+      </p:sp>
+    </p:spTree>
+  </p:cSld>
+  <p:clrMapOvr>
+    <a:masterClrMapping/>
+  </p:clrMapOvr>
+</p:sld>
+</file>
+
+<file path=ppt/slides/slide20.xml><?xml version="1.0" encoding="utf-8"?>
 <p:sld xmlns:a="http://schemas.openxmlformats.org/drawingml/2006/main" xmlns:p="http://schemas.openxmlformats.org/presentationml/2006/main" xmlns:r="http://schemas.openxmlformats.org/officeDocument/2006/relationships">
   <p:cSld>
     <p:spTree>
@@ -10656,7 +12021,7 @@
 </p:sld>
 </file>
 
-<file path=ppt/slides/slide18.xml><?xml version="1.0" encoding="utf-8"?>
+<file path=ppt/slides/slide21.xml><?xml version="1.0" encoding="utf-8"?>
 <p:sld xmlns:a="http://schemas.openxmlformats.org/drawingml/2006/main" xmlns:p="http://schemas.openxmlformats.org/presentationml/2006/main" xmlns:r="http://schemas.openxmlformats.org/officeDocument/2006/relationships">
   <p:cSld>
     <p:spTree>
@@ -11566,7 +12931,7 @@
 </p:sld>
 </file>
 
-<file path=ppt/slides/slide19.xml><?xml version="1.0" encoding="utf-8"?>
+<file path=ppt/slides/slide22.xml><?xml version="1.0" encoding="utf-8"?>
 <p:sld xmlns:a="http://schemas.openxmlformats.org/drawingml/2006/main" xmlns:p="http://schemas.openxmlformats.org/presentationml/2006/main" xmlns:r="http://schemas.openxmlformats.org/officeDocument/2006/relationships">
   <p:cSld>
     <p:spTree>
@@ -11693,7 +13058,7 @@
 </p:sld>
 </file>
 
-<file path=ppt/slides/slide2.xml><?xml version="1.0" encoding="utf-8"?>
+<file path=ppt/slides/slide23.xml><?xml version="1.0" encoding="utf-8"?>
 <p:sld xmlns:a="http://schemas.openxmlformats.org/drawingml/2006/main" xmlns:p="http://schemas.openxmlformats.org/presentationml/2006/main" xmlns:r="http://schemas.openxmlformats.org/officeDocument/2006/relationships">
   <p:cSld>
     <p:spTree>
@@ -11713,88 +13078,97 @@
             <p:ph type="title"/>
           </p:nvPr>
         </p:nvSpPr>
+        <p:spPr/>
+        <p:txBody>
+          <a:bodyPr/>
+          <a:lstStyle/>
+          <a:p>
+            <a:pPr indent="0" lvl="0" marL="0" rtl="0" algn="l">
+              <a:spcBef>
+                <a:spcPts val="0"/>
+              </a:spcBef>
+              <a:spcAft>
+                <a:spcPts val="0"/>
+              </a:spcAft>
+              <a:buNone/>
+            </a:pPr>
+            <a:r>
+              <a:rPr lang="en"/>
+              <a:t>Try It: Swap a Personality</a:t>
+            </a:r>
+            <a:endParaRPr/>
+          </a:p>
+        </p:txBody>
+      </p:sp>
+      <p:sp>
+        <p:nvSpPr>
+          <p:cNvPr id="3" name="Text Placeholder 2"/>
+          <p:cNvSpPr>
+            <a:spLocks noGrp="1"/>
+          </p:cNvSpPr>
+          <p:nvPr>
+            <p:ph type="body" idx="1"/>
+          </p:nvPr>
+        </p:nvSpPr>
         <p:spPr>
           <a:xfrm>
-            <a:off x="311700" y="195615"/>
-            <a:ext cx="8520600" cy="572700"/>
+            <a:off x="311700" y="885950"/>
+            <a:ext cx="8520600" cy="1289304"/>
           </a:xfrm>
         </p:spPr>
         <p:txBody>
           <a:bodyPr/>
           <a:lstStyle/>
           <a:p>
-            <a:pPr indent="0" lvl="0" marL="0" rtl="0" algn="l">
-              <a:spcBef>
-                <a:spcPts val="0"/>
-              </a:spcBef>
-              <a:spcAft>
-                <a:spcPts val="0"/>
-              </a:spcAft>
-              <a:buNone/>
+            <a:pPr indent="-330200" lvl="0" marL="457200" rtl="0" algn="l">
+              <a:spcBef>
+                <a:spcPts val="0"/>
+              </a:spcBef>
+              <a:spcAft>
+                <a:spcPts val="0"/>
+              </a:spcAft>
+              <a:buSzPts val="1600"/>
+              <a:buChar char="●"/>
             </a:pPr>
             <a:r>
               <a:rPr lang="en"/>
-              <a:t>Pac-Man</a:t>
+              <a:t>In Pacman3’s World:</a:t>
             </a:r>
             <a:endParaRPr/>
           </a:p>
-        </p:txBody>
-      </p:sp>
-      <p:pic>
-        <p:nvPicPr>
-          <p:cNvPr id="3" name="Picture 2" descr="pac-man.png"/>
-          <p:cNvPicPr>
-            <a:picLocks noChangeAspect="1"/>
-          </p:cNvPicPr>
-          <p:nvPr/>
-        </p:nvPicPr>
-        <p:blipFill>
-          <a:blip r:embed="rId2"/>
-          <a:stretch>
-            <a:fillRect/>
-          </a:stretch>
-        </p:blipFill>
-        <p:spPr>
-          <a:xfrm>
-            <a:off x="3149600" y="960120"/>
-            <a:ext cx="2844800" cy="3657600"/>
-          </a:xfrm>
-          <a:prstGeom prst="rect">
-            <a:avLst/>
-          </a:prstGeom>
-        </p:spPr>
-      </p:pic>
-      <p:sp>
-        <p:nvSpPr>
-          <p:cNvPr id="4" name="TextBox 3"/>
-          <p:cNvSpPr txBox="1"/>
-          <p:nvPr/>
-        </p:nvSpPr>
-        <p:spPr>
-          <a:xfrm>
-            <a:off x="457200" y="4736592"/>
-            <a:ext cx="8229600" cy="274320"/>
-          </a:xfrm>
-          <a:prstGeom prst="rect">
-            <a:avLst/>
-          </a:prstGeom>
-          <a:noFill/>
-        </p:spPr>
-        <p:txBody>
-          <a:bodyPr wrap="square">
-            <a:spAutoFit/>
-          </a:bodyPr>
-          <a:lstStyle/>
-          <a:p>
-            <a:pPr algn="ctr"/>
-            <a:r>
-              <a:rPr sz="900" b="0" i="0">
-                <a:solidFill>
-                  <a:srgbClr val="9AA3AB"/>
-                </a:solidFill>
-              </a:rPr>
-              <a:t>Pac-Man (Namco, 1980). Image: Bandai Namco Entertainment America, CC BY 3.0, via Wikimedia Commons.</a:t>
-            </a:r>
+          <a:p>
+            <a:pPr indent="-330200" lvl="0" marL="457200" rtl="0" algn="l">
+              <a:spcBef>
+                <a:spcPts val="0"/>
+              </a:spcBef>
+              <a:spcAft>
+                <a:spcPts val="0"/>
+              </a:spcAft>
+              <a:buSzPts val="1600"/>
+              <a:buChar char="●"/>
+            </a:pPr>
+            <a:r>
+              <a:rPr lang="en"/>
+              <a:t>Give Clyde Blinky’s strategy</a:t>
+            </a:r>
+            <a:endParaRPr/>
+          </a:p>
+          <a:p>
+            <a:pPr indent="-330200" lvl="0" marL="457200" rtl="0" algn="l">
+              <a:spcBef>
+                <a:spcPts val="0"/>
+              </a:spcBef>
+              <a:spcAft>
+                <a:spcPts val="0"/>
+              </a:spcAft>
+              <a:buSzPts val="1600"/>
+              <a:buChar char="●"/>
+            </a:pPr>
+            <a:r>
+              <a:rPr lang="en"/>
+              <a:t>Play: how does the chase change?</a:t>
+            </a:r>
+            <a:endParaRPr/>
           </a:p>
         </p:txBody>
       </p:sp>
@@ -11806,7 +13180,7 @@
 </p:sld>
 </file>
 
-<file path=ppt/slides/slide20.xml><?xml version="1.0" encoding="utf-8"?>
+<file path=ppt/slides/slide24.xml><?xml version="1.0" encoding="utf-8"?>
 <p:sld xmlns:a="http://schemas.openxmlformats.org/drawingml/2006/main" xmlns:p="http://schemas.openxmlformats.org/presentationml/2006/main" xmlns:r="http://schemas.openxmlformats.org/officeDocument/2006/relationships">
   <p:cSld>
     <p:spTree>
@@ -12123,7 +13497,7 @@
 </p:sld>
 </file>
 
-<file path=ppt/slides/slide21.xml><?xml version="1.0" encoding="utf-8"?>
+<file path=ppt/slides/slide25.xml><?xml version="1.0" encoding="utf-8"?>
 <p:sld xmlns:a="http://schemas.openxmlformats.org/drawingml/2006/main" xmlns:p="http://schemas.openxmlformats.org/presentationml/2006/main" xmlns:r="http://schemas.openxmlformats.org/officeDocument/2006/relationships">
   <p:cSld>
     <p:spTree>
@@ -12867,7 +14241,7 @@
 </p:sld>
 </file>
 
-<file path=ppt/slides/slide22.xml><?xml version="1.0" encoding="utf-8"?>
+<file path=ppt/slides/slide26.xml><?xml version="1.0" encoding="utf-8"?>
 <p:sld xmlns:a="http://schemas.openxmlformats.org/drawingml/2006/main" xmlns:p="http://schemas.openxmlformats.org/presentationml/2006/main" xmlns:r="http://schemas.openxmlformats.org/officeDocument/2006/relationships">
   <p:cSld>
     <p:spTree>
@@ -13435,7 +14809,7 @@
 </p:sld>
 </file>
 
-<file path=ppt/slides/slide23.xml><?xml version="1.0" encoding="utf-8"?>
+<file path=ppt/slides/slide27.xml><?xml version="1.0" encoding="utf-8"?>
 <p:sld xmlns:a="http://schemas.openxmlformats.org/drawingml/2006/main" xmlns:r="http://schemas.openxmlformats.org/officeDocument/2006/relationships" xmlns:mc="http://schemas.openxmlformats.org/markup-compatibility/2006" xmlns:mv="urn:schemas-microsoft-com:mac:vml" xmlns:p="http://schemas.openxmlformats.org/presentationml/2006/main" xmlns:c="http://schemas.openxmlformats.org/drawingml/2006/chart" xmlns:dgm="http://schemas.openxmlformats.org/drawingml/2006/diagram" xmlns:o="urn:schemas-microsoft-com:office:office" xmlns:v="urn:schemas-microsoft-com:vml" xmlns:pvml="urn:schemas-microsoft-com:office:powerpoint" xmlns:com="http://schemas.openxmlformats.org/drawingml/2006/compatibility" xmlns:p14="http://schemas.microsoft.com/office/powerpoint/2010/main" xmlns:p15="http://schemas.microsoft.com/office/powerpoint/2012/main" xmlns:ahyp="http://schemas.microsoft.com/office/drawing/2018/hyperlinkcolor">
   <p:cSld>
     <p:spTree>
@@ -13569,7 +14943,7 @@
 </p:sld>
 </file>
 
-<file path=ppt/slides/slide24.xml><?xml version="1.0" encoding="utf-8"?>
+<file path=ppt/slides/slide28.xml><?xml version="1.0" encoding="utf-8"?>
 <p:sld xmlns:a="http://schemas.openxmlformats.org/drawingml/2006/main" xmlns:r="http://schemas.openxmlformats.org/officeDocument/2006/relationships" xmlns:mc="http://schemas.openxmlformats.org/markup-compatibility/2006" xmlns:mv="urn:schemas-microsoft-com:mac:vml" xmlns:p="http://schemas.openxmlformats.org/presentationml/2006/main" xmlns:c="http://schemas.openxmlformats.org/drawingml/2006/chart" xmlns:dgm="http://schemas.openxmlformats.org/drawingml/2006/diagram" xmlns:o="urn:schemas-microsoft-com:office:office" xmlns:v="urn:schemas-microsoft-com:vml" xmlns:pvml="urn:schemas-microsoft-com:office:powerpoint" xmlns:com="http://schemas.openxmlformats.org/drawingml/2006/compatibility" xmlns:p14="http://schemas.microsoft.com/office/powerpoint/2010/main" xmlns:p15="http://schemas.microsoft.com/office/powerpoint/2012/main" xmlns:ahyp="http://schemas.microsoft.com/office/drawing/2018/hyperlinkcolor">
   <p:cSld>
     <p:spTree>
@@ -14452,7 +15826,7 @@
 </p:sld>
 </file>
 
-<file path=ppt/slides/slide25.xml><?xml version="1.0" encoding="utf-8"?>
+<file path=ppt/slides/slide29.xml><?xml version="1.0" encoding="utf-8"?>
 <p:sld xmlns:a="http://schemas.openxmlformats.org/drawingml/2006/main" xmlns:r="http://schemas.openxmlformats.org/officeDocument/2006/relationships" xmlns:mc="http://schemas.openxmlformats.org/markup-compatibility/2006" xmlns:mv="urn:schemas-microsoft-com:mac:vml" xmlns:p="http://schemas.openxmlformats.org/presentationml/2006/main" xmlns:c="http://schemas.openxmlformats.org/drawingml/2006/chart" xmlns:dgm="http://schemas.openxmlformats.org/drawingml/2006/diagram" xmlns:o="urn:schemas-microsoft-com:office:office" xmlns:v="urn:schemas-microsoft-com:vml" xmlns:pvml="urn:schemas-microsoft-com:office:powerpoint" xmlns:com="http://schemas.openxmlformats.org/drawingml/2006/compatibility" xmlns:p14="http://schemas.microsoft.com/office/powerpoint/2010/main" xmlns:p15="http://schemas.microsoft.com/office/powerpoint/2012/main" xmlns:ahyp="http://schemas.microsoft.com/office/drawing/2018/hyperlinkcolor">
   <p:cSld>
     <p:spTree>
@@ -15284,7 +16658,96 @@
 </p:sld>
 </file>
 
-<file path=ppt/slides/slide26.xml><?xml version="1.0" encoding="utf-8"?>
+<file path=ppt/slides/slide3.xml><?xml version="1.0" encoding="utf-8"?>
+<p:sld xmlns:a="http://schemas.openxmlformats.org/drawingml/2006/main" xmlns:r="http://schemas.openxmlformats.org/officeDocument/2006/relationships" xmlns:mc="http://schemas.openxmlformats.org/markup-compatibility/2006" xmlns:mv="urn:schemas-microsoft-com:mac:vml" xmlns:p="http://schemas.openxmlformats.org/presentationml/2006/main" xmlns:c="http://schemas.openxmlformats.org/drawingml/2006/chart" xmlns:dgm="http://schemas.openxmlformats.org/drawingml/2006/diagram" xmlns:o="urn:schemas-microsoft-com:office:office" xmlns:v="urn:schemas-microsoft-com:vml" xmlns:pvml="urn:schemas-microsoft-com:office:powerpoint" xmlns:com="http://schemas.openxmlformats.org/drawingml/2006/compatibility" xmlns:p14="http://schemas.microsoft.com/office/powerpoint/2010/main" xmlns:p15="http://schemas.microsoft.com/office/powerpoint/2012/main" xmlns:ahyp="http://schemas.microsoft.com/office/drawing/2018/hyperlinkcolor">
+  <p:cSld>
+    <p:spTree>
+      <p:nvGrpSpPr>
+        <p:cNvPr id="44" name="Shape 44"/>
+        <p:cNvGrpSpPr/>
+        <p:nvPr/>
+      </p:nvGrpSpPr>
+      <p:grpSpPr>
+        <a:xfrm>
+          <a:off x="0" y="0"/>
+          <a:ext cx="0" cy="0"/>
+          <a:chOff x="0" y="0"/>
+          <a:chExt cx="0" cy="0"/>
+        </a:xfrm>
+      </p:grpSpPr>
+      <p:sp>
+        <p:nvSpPr>
+          <p:cNvPr id="45" name="Google Shape;45;p10"/>
+          <p:cNvSpPr txBox="1"/>
+          <p:nvPr>
+            <p:ph type="title"/>
+          </p:nvPr>
+        </p:nvSpPr>
+        <p:spPr>
+          <a:xfrm>
+            <a:off x="311700" y="195615"/>
+            <a:ext cx="8520600" cy="572700"/>
+          </a:xfrm>
+          <a:prstGeom prst="rect">
+            <a:avLst/>
+          </a:prstGeom>
+        </p:spPr>
+        <p:txBody>
+          <a:bodyPr anchorCtr="0" anchor="t" bIns="91425" lIns="91425" spcFirstLastPara="1" rIns="91425" wrap="square" tIns="91425">
+            <a:normAutofit fontScale="90000"/>
+          </a:bodyPr>
+          <a:lstStyle/>
+          <a:p>
+            <a:pPr indent="0" lvl="0" marL="0" rtl="0" algn="l">
+              <a:spcBef>
+                <a:spcPts val="0"/>
+              </a:spcBef>
+              <a:spcAft>
+                <a:spcPts val="0"/>
+              </a:spcAft>
+              <a:buNone/>
+            </a:pPr>
+            <a:r>
+              <a:rPr lang="en"/>
+              <a:t>Today’s Goal</a:t>
+            </a:r>
+            <a:endParaRPr/>
+          </a:p>
+        </p:txBody>
+      </p:sp>
+      <p:pic>
+        <p:nvPicPr>
+          <p:cNvPr id="46" name="Picture 46" descr="pacman-play.png"/>
+          <p:cNvPicPr>
+            <a:picLocks noChangeAspect="1"/>
+          </p:cNvPicPr>
+          <p:nvPr/>
+        </p:nvPicPr>
+        <p:blipFill>
+          <a:blip r:embed="rId4"/>
+          <a:stretch>
+            <a:fillRect/>
+          </a:stretch>
+        </p:blipFill>
+        <p:spPr>
+          <a:xfrm>
+            <a:off x="3101255" y="1531275"/>
+            <a:ext cx="2941489" cy="3256648"/>
+          </a:xfrm>
+          <a:prstGeom prst="rect">
+            <a:avLst/>
+          </a:prstGeom>
+        </p:spPr>
+      </p:pic>
+    </p:spTree>
+  </p:cSld>
+  <p:clrMapOvr>
+    <a:masterClrMapping/>
+  </p:clrMapOvr>
+</p:sld>
+</file>
+
+<file path=ppt/slides/slide30.xml><?xml version="1.0" encoding="utf-8"?>
 <p:sld xmlns:a="http://schemas.openxmlformats.org/drawingml/2006/main" xmlns:p="http://schemas.openxmlformats.org/presentationml/2006/main" xmlns:r="http://schemas.openxmlformats.org/officeDocument/2006/relationships">
   <p:cSld>
     <p:spTree>
@@ -15457,7 +16920,7 @@
 </p:sld>
 </file>
 
-<file path=ppt/slides/slide27.xml><?xml version="1.0" encoding="utf-8"?>
+<file path=ppt/slides/slide31.xml><?xml version="1.0" encoding="utf-8"?>
 <p:sld xmlns:a="http://schemas.openxmlformats.org/drawingml/2006/main" xmlns:r="http://schemas.openxmlformats.org/officeDocument/2006/relationships" xmlns:mc="http://schemas.openxmlformats.org/markup-compatibility/2006" xmlns:mv="urn:schemas-microsoft-com:mac:vml" xmlns:p="http://schemas.openxmlformats.org/presentationml/2006/main" xmlns:c="http://schemas.openxmlformats.org/drawingml/2006/chart" xmlns:dgm="http://schemas.openxmlformats.org/drawingml/2006/diagram" xmlns:o="urn:schemas-microsoft-com:office:office" xmlns:v="urn:schemas-microsoft-com:vml" xmlns:pvml="urn:schemas-microsoft-com:office:powerpoint" xmlns:com="http://schemas.openxmlformats.org/drawingml/2006/compatibility" xmlns:p14="http://schemas.microsoft.com/office/powerpoint/2010/main" xmlns:p15="http://schemas.microsoft.com/office/powerpoint/2012/main" xmlns:ahyp="http://schemas.microsoft.com/office/drawing/2018/hyperlinkcolor">
   <p:cSld>
     <p:spTree>
@@ -16306,7 +17769,7 @@
 </p:sld>
 </file>
 
-<file path=ppt/slides/slide28.xml><?xml version="1.0" encoding="utf-8"?>
+<file path=ppt/slides/slide32.xml><?xml version="1.0" encoding="utf-8"?>
 <p:sld xmlns:a="http://schemas.openxmlformats.org/drawingml/2006/main" xmlns:r="http://schemas.openxmlformats.org/officeDocument/2006/relationships" xmlns:mc="http://schemas.openxmlformats.org/markup-compatibility/2006" xmlns:mv="urn:schemas-microsoft-com:mac:vml" xmlns:p="http://schemas.openxmlformats.org/presentationml/2006/main" xmlns:c="http://schemas.openxmlformats.org/drawingml/2006/chart" xmlns:dgm="http://schemas.openxmlformats.org/drawingml/2006/diagram" xmlns:o="urn:schemas-microsoft-com:office:office" xmlns:v="urn:schemas-microsoft-com:vml" xmlns:pvml="urn:schemas-microsoft-com:office:powerpoint" xmlns:com="http://schemas.openxmlformats.org/drawingml/2006/compatibility" xmlns:p14="http://schemas.microsoft.com/office/powerpoint/2010/main" xmlns:p15="http://schemas.microsoft.com/office/powerpoint/2012/main" xmlns:ahyp="http://schemas.microsoft.com/office/drawing/2018/hyperlinkcolor">
   <p:cSld>
     <p:spTree>
@@ -16472,95 +17935,6 @@
           </a:p>
         </p:txBody>
       </p:sp>
-    </p:spTree>
-  </p:cSld>
-  <p:clrMapOvr>
-    <a:masterClrMapping/>
-  </p:clrMapOvr>
-</p:sld>
-</file>
-
-<file path=ppt/slides/slide3.xml><?xml version="1.0" encoding="utf-8"?>
-<p:sld xmlns:a="http://schemas.openxmlformats.org/drawingml/2006/main" xmlns:r="http://schemas.openxmlformats.org/officeDocument/2006/relationships" xmlns:mc="http://schemas.openxmlformats.org/markup-compatibility/2006" xmlns:mv="urn:schemas-microsoft-com:mac:vml" xmlns:p="http://schemas.openxmlformats.org/presentationml/2006/main" xmlns:c="http://schemas.openxmlformats.org/drawingml/2006/chart" xmlns:dgm="http://schemas.openxmlformats.org/drawingml/2006/diagram" xmlns:o="urn:schemas-microsoft-com:office:office" xmlns:v="urn:schemas-microsoft-com:vml" xmlns:pvml="urn:schemas-microsoft-com:office:powerpoint" xmlns:com="http://schemas.openxmlformats.org/drawingml/2006/compatibility" xmlns:p14="http://schemas.microsoft.com/office/powerpoint/2010/main" xmlns:p15="http://schemas.microsoft.com/office/powerpoint/2012/main" xmlns:ahyp="http://schemas.microsoft.com/office/drawing/2018/hyperlinkcolor">
-  <p:cSld>
-    <p:spTree>
-      <p:nvGrpSpPr>
-        <p:cNvPr id="44" name="Shape 44"/>
-        <p:cNvGrpSpPr/>
-        <p:nvPr/>
-      </p:nvGrpSpPr>
-      <p:grpSpPr>
-        <a:xfrm>
-          <a:off x="0" y="0"/>
-          <a:ext cx="0" cy="0"/>
-          <a:chOff x="0" y="0"/>
-          <a:chExt cx="0" cy="0"/>
-        </a:xfrm>
-      </p:grpSpPr>
-      <p:sp>
-        <p:nvSpPr>
-          <p:cNvPr id="45" name="Google Shape;45;p10"/>
-          <p:cNvSpPr txBox="1"/>
-          <p:nvPr>
-            <p:ph type="title"/>
-          </p:nvPr>
-        </p:nvSpPr>
-        <p:spPr>
-          <a:xfrm>
-            <a:off x="311700" y="195615"/>
-            <a:ext cx="8520600" cy="572700"/>
-          </a:xfrm>
-          <a:prstGeom prst="rect">
-            <a:avLst/>
-          </a:prstGeom>
-        </p:spPr>
-        <p:txBody>
-          <a:bodyPr anchorCtr="0" anchor="t" bIns="91425" lIns="91425" spcFirstLastPara="1" rIns="91425" wrap="square" tIns="91425">
-            <a:normAutofit fontScale="90000"/>
-          </a:bodyPr>
-          <a:lstStyle/>
-          <a:p>
-            <a:pPr indent="0" lvl="0" marL="0" rtl="0" algn="l">
-              <a:spcBef>
-                <a:spcPts val="0"/>
-              </a:spcBef>
-              <a:spcAft>
-                <a:spcPts val="0"/>
-              </a:spcAft>
-              <a:buNone/>
-            </a:pPr>
-            <a:r>
-              <a:rPr lang="en"/>
-              <a:t>Today’s Goal</a:t>
-            </a:r>
-            <a:endParaRPr/>
-          </a:p>
-        </p:txBody>
-      </p:sp>
-      <p:pic>
-        <p:nvPicPr>
-          <p:cNvPr id="46" name="Picture 46" descr="pacman-play.png"/>
-          <p:cNvPicPr>
-            <a:picLocks noChangeAspect="1"/>
-          </p:cNvPicPr>
-          <p:nvPr/>
-        </p:nvPicPr>
-        <p:blipFill>
-          <a:blip r:embed="rId4"/>
-          <a:stretch>
-            <a:fillRect/>
-          </a:stretch>
-        </p:blipFill>
-        <p:spPr>
-          <a:xfrm>
-            <a:off x="3101255" y="1531275"/>
-            <a:ext cx="2941489" cy="3256648"/>
-          </a:xfrm>
-          <a:prstGeom prst="rect">
-            <a:avLst/>
-          </a:prstGeom>
-        </p:spPr>
-      </p:pic>
     </p:spTree>
   </p:cSld>
   <p:clrMapOvr>
@@ -18860,25 +20234,17 @@
       <p:grpSpPr/>
       <p:sp>
         <p:nvSpPr>
-          <p:cNvPr id="293" name="Google Shape;293;p45"/>
-          <p:cNvSpPr txBox="1"/>
+          <p:cNvPr id="2" name="Title 1"/>
+          <p:cNvSpPr>
+            <a:spLocks noGrp="1"/>
+          </p:cNvSpPr>
           <p:nvPr>
             <p:ph type="title"/>
           </p:nvPr>
         </p:nvSpPr>
-        <p:spPr>
-          <a:xfrm>
-            <a:off x="311700" y="195615"/>
-            <a:ext cx="8520600" cy="572700"/>
-          </a:xfrm>
-          <a:prstGeom prst="rect">
-            <a:avLst/>
-          </a:prstGeom>
-        </p:spPr>
+        <p:spPr/>
         <p:txBody>
-          <a:bodyPr anchorCtr="0" anchor="t" bIns="91425" lIns="91425" spcFirstLastPara="1" rIns="91425" wrap="square" tIns="91425">
-            <a:normAutofit fontScale="90000"/>
-          </a:bodyPr>
+          <a:bodyPr/>
           <a:lstStyle/>
           <a:p>
             <a:pPr indent="0" lvl="0" marL="0" rtl="0" algn="l">
@@ -18891,42 +20257,31 @@
               <a:buNone/>
             </a:pPr>
             <a:r>
-              <a:rPr lang="en">
-                <a:solidFill>
-                  <a:schemeClr val="accent5"/>
-                </a:solidFill>
-              </a:rPr>
-              <a:t>Five Ghost Modes</a:t>
-            </a:r>
-            <a:endParaRPr>
-              <a:solidFill>
-                <a:schemeClr val="accent5"/>
-              </a:solidFill>
-            </a:endParaRPr>
+              <a:rPr lang="en"/>
+              <a:t>Try It: Change the Maze</a:t>
+            </a:r>
+            <a:endParaRPr/>
           </a:p>
         </p:txBody>
       </p:sp>
       <p:sp>
         <p:nvSpPr>
-          <p:cNvPr id="294" name="Google Shape;294;p45"/>
-          <p:cNvSpPr txBox="1"/>
+          <p:cNvPr id="3" name="Text Placeholder 2"/>
+          <p:cNvSpPr>
+            <a:spLocks noGrp="1"/>
+          </p:cNvSpPr>
           <p:nvPr>
-            <p:ph idx="1" type="body"/>
+            <p:ph type="body" idx="1"/>
           </p:nvPr>
         </p:nvSpPr>
         <p:spPr>
           <a:xfrm>
             <a:off x="311700" y="885950"/>
-            <a:ext cx="8520600" cy="521208"/>
+            <a:ext cx="8520600" cy="1289304"/>
           </a:xfrm>
-          <a:prstGeom prst="rect">
-            <a:avLst/>
-          </a:prstGeom>
         </p:spPr>
         <p:txBody>
-          <a:bodyPr anchorCtr="0" anchor="t" bIns="91425" lIns="91425" spcFirstLastPara="1" rIns="91425" wrap="square" tIns="91425">
-            <a:normAutofit/>
-          </a:bodyPr>
+          <a:bodyPr/>
           <a:lstStyle/>
           <a:p>
             <a:pPr indent="-330200" lvl="0" marL="457200" rtl="0" algn="l">
@@ -18941,652 +20296,43 @@
             </a:pPr>
             <a:r>
               <a:rPr lang="en"/>
-              <a:t>Every ghost is always in one of five modes. The mode decides where it heads.</a:t>
+              <a:t>In maze.txt:</a:t>
             </a:r>
             <a:endParaRPr/>
           </a:p>
-        </p:txBody>
-      </p:sp>
-      <p:sp>
-        <p:nvSpPr>
-          <p:cNvPr id="295" name="Rounded Rectangle 294"/>
-          <p:cNvSpPr/>
-          <p:nvPr/>
-        </p:nvSpPr>
-        <p:spPr>
-          <a:xfrm>
-            <a:off x="365760" y="1828800"/>
-            <a:ext cx="1463040" cy="640080"/>
-          </a:xfrm>
-          <a:prstGeom prst="roundRect">
-            <a:avLst>
-              <a:gd name="adj" fmla="val 12000"/>
-            </a:avLst>
-          </a:prstGeom>
-          <a:solidFill>
-            <a:srgbClr val="2E3338"/>
-          </a:solidFill>
-          <a:ln>
-            <a:noFill/>
-          </a:ln>
-          <a:effectLst/>
-        </p:spPr>
-        <p:style>
-          <a:lnRef idx="1">
-            <a:schemeClr val="accent1"/>
-          </a:lnRef>
-          <a:fillRef idx="3">
-            <a:schemeClr val="accent1"/>
-          </a:fillRef>
-          <a:effectRef idx="2">
-            <a:schemeClr val="accent1"/>
-          </a:effectRef>
-          <a:fontRef idx="minor">
-            <a:schemeClr val="lt1"/>
-          </a:fontRef>
-        </p:style>
-        <p:txBody>
-          <a:bodyPr rtlCol="0" anchor="ctr" wrap="square" lIns="73152" rIns="73152"/>
-          <a:lstStyle/>
-          <a:p>
-            <a:pPr algn="ctr"/>
-            <a:r>
-              <a:rPr sz="1400" b="1">
-                <a:solidFill>
-                  <a:srgbClr val="DEE2E6"/>
-                </a:solidFill>
-              </a:rPr>
-              <a:t>In the house</a:t>
-            </a:r>
-          </a:p>
-          <a:p>
-            <a:pPr algn="ctr"/>
-            <a:r>
-              <a:rPr sz="1200" b="0">
-                <a:solidFill>
-                  <a:srgbClr val="9AA3AB"/>
-                </a:solidFill>
-              </a:rPr>
-              <a:t>waits</a:t>
-            </a:r>
-          </a:p>
-        </p:txBody>
-      </p:sp>
-      <p:sp>
-        <p:nvSpPr>
-          <p:cNvPr id="296" name="Rounded Rectangle 295"/>
-          <p:cNvSpPr/>
-          <p:nvPr/>
-        </p:nvSpPr>
-        <p:spPr>
-          <a:xfrm>
-            <a:off x="2468880" y="1325880"/>
-            <a:ext cx="1463040" cy="640080"/>
-          </a:xfrm>
-          <a:prstGeom prst="roundRect">
-            <a:avLst>
-              <a:gd name="adj" fmla="val 12000"/>
-            </a:avLst>
-          </a:prstGeom>
-          <a:solidFill>
-            <a:srgbClr val="2E3338"/>
-          </a:solidFill>
-          <a:ln>
-            <a:noFill/>
-          </a:ln>
-          <a:effectLst/>
-        </p:spPr>
-        <p:style>
-          <a:lnRef idx="1">
-            <a:schemeClr val="accent1"/>
-          </a:lnRef>
-          <a:fillRef idx="3">
-            <a:schemeClr val="accent1"/>
-          </a:fillRef>
-          <a:effectRef idx="2">
-            <a:schemeClr val="accent1"/>
-          </a:effectRef>
-          <a:fontRef idx="minor">
-            <a:schemeClr val="lt1"/>
-          </a:fontRef>
-        </p:style>
-        <p:txBody>
-          <a:bodyPr rtlCol="0" anchor="ctr" wrap="square" lIns="73152" rIns="73152"/>
-          <a:lstStyle/>
-          <a:p>
-            <a:pPr algn="ctr"/>
-            <a:r>
-              <a:rPr sz="1400" b="1">
-                <a:solidFill>
-                  <a:srgbClr val="DEE2E6"/>
-                </a:solidFill>
-              </a:rPr>
-              <a:t>Scatter</a:t>
-            </a:r>
-          </a:p>
-          <a:p>
-            <a:pPr algn="ctr"/>
-            <a:r>
-              <a:rPr sz="1200" b="0">
-                <a:solidFill>
-                  <a:srgbClr val="9AA3AB"/>
-                </a:solidFill>
-              </a:rPr>
-              <a:t>its corner</a:t>
-            </a:r>
-          </a:p>
-        </p:txBody>
-      </p:sp>
-      <p:sp>
-        <p:nvSpPr>
-          <p:cNvPr id="297" name="Rounded Rectangle 296"/>
-          <p:cNvSpPr/>
-          <p:nvPr/>
-        </p:nvSpPr>
-        <p:spPr>
-          <a:xfrm>
-            <a:off x="2468880" y="2331720"/>
-            <a:ext cx="1463040" cy="640080"/>
-          </a:xfrm>
-          <a:prstGeom prst="roundRect">
-            <a:avLst>
-              <a:gd name="adj" fmla="val 12000"/>
-            </a:avLst>
-          </a:prstGeom>
-          <a:solidFill>
-            <a:srgbClr val="2E3338"/>
-          </a:solidFill>
-          <a:ln w="25400">
-            <a:solidFill>
-              <a:srgbClr val="D45D35"/>
-            </a:solidFill>
-          </a:ln>
-          <a:effectLst/>
-        </p:spPr>
-        <p:style>
-          <a:lnRef idx="1">
-            <a:schemeClr val="accent1"/>
-          </a:lnRef>
-          <a:fillRef idx="3">
-            <a:schemeClr val="accent1"/>
-          </a:fillRef>
-          <a:effectRef idx="2">
-            <a:schemeClr val="accent1"/>
-          </a:effectRef>
-          <a:fontRef idx="minor">
-            <a:schemeClr val="lt1"/>
-          </a:fontRef>
-        </p:style>
-        <p:txBody>
-          <a:bodyPr rtlCol="0" anchor="ctr" wrap="square" lIns="73152" rIns="73152"/>
-          <a:lstStyle/>
-          <a:p>
-            <a:pPr algn="ctr"/>
-            <a:r>
-              <a:rPr sz="1400" b="1">
-                <a:solidFill>
-                  <a:srgbClr val="DEE2E6"/>
-                </a:solidFill>
-              </a:rPr>
-              <a:t>Chase</a:t>
-            </a:r>
-          </a:p>
-          <a:p>
-            <a:pPr algn="ctr"/>
-            <a:r>
-              <a:rPr sz="1200" b="0">
-                <a:solidFill>
-                  <a:srgbClr val="9AA3AB"/>
-                </a:solidFill>
-              </a:rPr>
-              <a:t>Pac-Man</a:t>
-            </a:r>
-          </a:p>
-        </p:txBody>
-      </p:sp>
-      <p:sp>
-        <p:nvSpPr>
-          <p:cNvPr id="298" name="Rounded Rectangle 297"/>
-          <p:cNvSpPr/>
-          <p:nvPr/>
-        </p:nvSpPr>
-        <p:spPr>
-          <a:xfrm>
-            <a:off x="4846320" y="1828800"/>
-            <a:ext cx="1645920" cy="640080"/>
-          </a:xfrm>
-          <a:prstGeom prst="roundRect">
-            <a:avLst>
-              <a:gd name="adj" fmla="val 12000"/>
-            </a:avLst>
-          </a:prstGeom>
-          <a:solidFill>
-            <a:srgbClr val="2E3338"/>
-          </a:solidFill>
-          <a:ln>
-            <a:noFill/>
-          </a:ln>
-          <a:effectLst/>
-        </p:spPr>
-        <p:style>
-          <a:lnRef idx="1">
-            <a:schemeClr val="accent1"/>
-          </a:lnRef>
-          <a:fillRef idx="3">
-            <a:schemeClr val="accent1"/>
-          </a:fillRef>
-          <a:effectRef idx="2">
-            <a:schemeClr val="accent1"/>
-          </a:effectRef>
-          <a:fontRef idx="minor">
-            <a:schemeClr val="lt1"/>
-          </a:fontRef>
-        </p:style>
-        <p:txBody>
-          <a:bodyPr rtlCol="0" anchor="ctr" wrap="square" lIns="73152" rIns="73152"/>
-          <a:lstStyle/>
-          <a:p>
-            <a:pPr algn="ctr"/>
-            <a:r>
-              <a:rPr sz="1400" b="1">
-                <a:solidFill>
-                  <a:srgbClr val="DEE2E6"/>
-                </a:solidFill>
-              </a:rPr>
-              <a:t>Frightened</a:t>
-            </a:r>
-          </a:p>
-          <a:p>
-            <a:pPr algn="ctr"/>
-            <a:r>
-              <a:rPr sz="1200" b="0">
-                <a:solidFill>
-                  <a:srgbClr val="9AA3AB"/>
-                </a:solidFill>
-              </a:rPr>
-              <a:t>blue, random</a:t>
-            </a:r>
-          </a:p>
-        </p:txBody>
-      </p:sp>
-      <p:sp>
-        <p:nvSpPr>
-          <p:cNvPr id="299" name="Rounded Rectangle 298"/>
-          <p:cNvSpPr/>
-          <p:nvPr/>
-        </p:nvSpPr>
-        <p:spPr>
-          <a:xfrm>
-            <a:off x="7132320" y="1828800"/>
-            <a:ext cx="1463040" cy="640080"/>
-          </a:xfrm>
-          <a:prstGeom prst="roundRect">
-            <a:avLst>
-              <a:gd name="adj" fmla="val 12000"/>
-            </a:avLst>
-          </a:prstGeom>
-          <a:solidFill>
-            <a:srgbClr val="2E3338"/>
-          </a:solidFill>
-          <a:ln>
-            <a:noFill/>
-          </a:ln>
-          <a:effectLst/>
-        </p:spPr>
-        <p:style>
-          <a:lnRef idx="1">
-            <a:schemeClr val="accent1"/>
-          </a:lnRef>
-          <a:fillRef idx="3">
-            <a:schemeClr val="accent1"/>
-          </a:fillRef>
-          <a:effectRef idx="2">
-            <a:schemeClr val="accent1"/>
-          </a:effectRef>
-          <a:fontRef idx="minor">
-            <a:schemeClr val="lt1"/>
-          </a:fontRef>
-        </p:style>
-        <p:txBody>
-          <a:bodyPr rtlCol="0" anchor="ctr" wrap="square" lIns="73152" rIns="73152"/>
-          <a:lstStyle/>
-          <a:p>
-            <a:pPr algn="ctr"/>
-            <a:r>
-              <a:rPr sz="1400" b="1">
-                <a:solidFill>
-                  <a:srgbClr val="DEE2E6"/>
-                </a:solidFill>
-              </a:rPr>
-              <a:t>Eaten</a:t>
-            </a:r>
-          </a:p>
-          <a:p>
-            <a:pPr algn="ctr"/>
-            <a:r>
-              <a:rPr sz="1200" b="0">
-                <a:solidFill>
-                  <a:srgbClr val="9AA3AB"/>
-                </a:solidFill>
-              </a:rPr>
-              <a:t>eyes go home</a:t>
-            </a:r>
-          </a:p>
-        </p:txBody>
-      </p:sp>
-      <p:cxnSp>
-        <p:nvCxnSpPr>
-          <p:cNvPr id="300" name="Connector 299"/>
-          <p:cNvCxnSpPr/>
-          <p:nvPr/>
-        </p:nvCxnSpPr>
-        <p:spPr>
-          <a:xfrm flipV="1">
-            <a:off x="1847088" y="1691640"/>
-            <a:ext cx="603504" cy="320040"/>
-          </a:xfrm>
-          <a:prstGeom prst="line">
-            <a:avLst/>
-          </a:prstGeom>
-          <a:ln w="25400">
-            <a:solidFill>
-              <a:srgbClr val="9AA3AB"/>
-            </a:solidFill>
-            <a:tailEnd type="triangle"/>
-          </a:ln>
-        </p:spPr>
-        <p:style>
-          <a:lnRef idx="2">
-            <a:schemeClr val="accent1"/>
-          </a:lnRef>
-          <a:fillRef idx="0">
-            <a:schemeClr val="accent1"/>
-          </a:fillRef>
-          <a:effectRef idx="1">
-            <a:schemeClr val="accent1"/>
-          </a:effectRef>
-          <a:fontRef idx="minor">
-            <a:schemeClr val="tx1"/>
-          </a:fontRef>
-        </p:style>
-      </p:cxnSp>
-      <p:cxnSp>
-        <p:nvCxnSpPr>
-          <p:cNvPr id="301" name="Connector 300"/>
-          <p:cNvCxnSpPr/>
-          <p:nvPr/>
-        </p:nvCxnSpPr>
-        <p:spPr>
-          <a:xfrm>
-            <a:off x="3108960" y="1984248"/>
-            <a:ext cx="0" cy="329184"/>
-          </a:xfrm>
-          <a:prstGeom prst="line">
-            <a:avLst/>
-          </a:prstGeom>
-          <a:ln w="25400">
-            <a:solidFill>
-              <a:srgbClr val="9AA3AB"/>
-            </a:solidFill>
-            <a:tailEnd type="triangle"/>
-          </a:ln>
-        </p:spPr>
-        <p:style>
-          <a:lnRef idx="2">
-            <a:schemeClr val="accent1"/>
-          </a:lnRef>
-          <a:fillRef idx="0">
-            <a:schemeClr val="accent1"/>
-          </a:fillRef>
-          <a:effectRef idx="1">
-            <a:schemeClr val="accent1"/>
-          </a:effectRef>
-          <a:fontRef idx="minor">
-            <a:schemeClr val="tx1"/>
-          </a:fontRef>
-        </p:style>
-      </p:cxnSp>
-      <p:cxnSp>
-        <p:nvCxnSpPr>
-          <p:cNvPr id="302" name="Connector 301"/>
-          <p:cNvCxnSpPr/>
-          <p:nvPr/>
-        </p:nvCxnSpPr>
-        <p:spPr>
-          <a:xfrm flipV="1">
-            <a:off x="3291840" y="1984248"/>
-            <a:ext cx="0" cy="329184"/>
-          </a:xfrm>
-          <a:prstGeom prst="line">
-            <a:avLst/>
-          </a:prstGeom>
-          <a:ln w="25400">
-            <a:solidFill>
-              <a:srgbClr val="9AA3AB"/>
-            </a:solidFill>
-            <a:tailEnd type="triangle"/>
-          </a:ln>
-        </p:spPr>
-        <p:style>
-          <a:lnRef idx="2">
-            <a:schemeClr val="accent1"/>
-          </a:lnRef>
-          <a:fillRef idx="0">
-            <a:schemeClr val="accent1"/>
-          </a:fillRef>
-          <a:effectRef idx="1">
-            <a:schemeClr val="accent1"/>
-          </a:effectRef>
-          <a:fontRef idx="minor">
-            <a:schemeClr val="tx1"/>
-          </a:fontRef>
-        </p:style>
-      </p:cxnSp>
-      <p:sp>
-        <p:nvSpPr>
-          <p:cNvPr id="303" name="TextBox 302"/>
-          <p:cNvSpPr txBox="1"/>
-          <p:nvPr/>
-        </p:nvSpPr>
-        <p:spPr>
-          <a:xfrm>
-            <a:off x="3429000" y="2011680"/>
-            <a:ext cx="1097280" cy="274320"/>
-          </a:xfrm>
-          <a:prstGeom prst="rect">
-            <a:avLst/>
-          </a:prstGeom>
-          <a:noFill/>
-        </p:spPr>
-        <p:txBody>
-          <a:bodyPr wrap="square">
-            <a:spAutoFit/>
-          </a:bodyPr>
-          <a:lstStyle/>
-          <a:p>
-            <a:pPr algn="l"/>
-            <a:r>
-              <a:rPr sz="1100" b="0" i="0">
-                <a:solidFill>
-                  <a:srgbClr val="9AA3AB"/>
-                </a:solidFill>
-              </a:rPr>
-              <a:t>schedule</a:t>
-            </a:r>
-          </a:p>
-        </p:txBody>
-      </p:sp>
-      <p:cxnSp>
-        <p:nvCxnSpPr>
-          <p:cNvPr id="304" name="Connector 303"/>
-          <p:cNvCxnSpPr/>
-          <p:nvPr/>
-        </p:nvCxnSpPr>
-        <p:spPr>
-          <a:xfrm flipV="1">
-            <a:off x="3950208" y="2331720"/>
-            <a:ext cx="877824" cy="320040"/>
-          </a:xfrm>
-          <a:prstGeom prst="line">
-            <a:avLst/>
-          </a:prstGeom>
-          <a:ln w="25400">
-            <a:solidFill>
-              <a:srgbClr val="9AA3AB"/>
-            </a:solidFill>
-            <a:tailEnd type="triangle"/>
-          </a:ln>
-        </p:spPr>
-        <p:style>
-          <a:lnRef idx="2">
-            <a:schemeClr val="accent1"/>
-          </a:lnRef>
-          <a:fillRef idx="0">
-            <a:schemeClr val="accent1"/>
-          </a:fillRef>
-          <a:effectRef idx="1">
-            <a:schemeClr val="accent1"/>
-          </a:effectRef>
-          <a:fontRef idx="minor">
-            <a:schemeClr val="tx1"/>
-          </a:fontRef>
-        </p:style>
-      </p:cxnSp>
-      <p:sp>
-        <p:nvSpPr>
-          <p:cNvPr id="305" name="TextBox 304"/>
-          <p:cNvSpPr txBox="1"/>
-          <p:nvPr/>
-        </p:nvSpPr>
-        <p:spPr>
-          <a:xfrm>
-            <a:off x="3977639" y="2560320"/>
-            <a:ext cx="1097280" cy="274320"/>
-          </a:xfrm>
-          <a:prstGeom prst="rect">
-            <a:avLst/>
-          </a:prstGeom>
-          <a:noFill/>
-        </p:spPr>
-        <p:txBody>
-          <a:bodyPr wrap="square">
-            <a:spAutoFit/>
-          </a:bodyPr>
-          <a:lstStyle/>
-          <a:p>
-            <a:pPr algn="l"/>
-            <a:r>
-              <a:rPr sz="1100" b="0" i="0">
-                <a:solidFill>
-                  <a:srgbClr val="9AA3AB"/>
-                </a:solidFill>
-              </a:rPr>
-              <a:t>power pellet</a:t>
-            </a:r>
-          </a:p>
-        </p:txBody>
-      </p:sp>
-      <p:cxnSp>
-        <p:nvCxnSpPr>
-          <p:cNvPr id="306" name="Connector 305"/>
-          <p:cNvCxnSpPr/>
-          <p:nvPr/>
-        </p:nvCxnSpPr>
-        <p:spPr>
-          <a:xfrm>
-            <a:off x="6510528" y="2148840"/>
-            <a:ext cx="603504" cy="0"/>
-          </a:xfrm>
-          <a:prstGeom prst="line">
-            <a:avLst/>
-          </a:prstGeom>
-          <a:ln w="25400">
-            <a:solidFill>
-              <a:srgbClr val="9AA3AB"/>
-            </a:solidFill>
-            <a:tailEnd type="triangle"/>
-          </a:ln>
-        </p:spPr>
-        <p:style>
-          <a:lnRef idx="2">
-            <a:schemeClr val="accent1"/>
-          </a:lnRef>
-          <a:fillRef idx="0">
-            <a:schemeClr val="accent1"/>
-          </a:fillRef>
-          <a:effectRef idx="1">
-            <a:schemeClr val="accent1"/>
-          </a:effectRef>
-          <a:fontRef idx="minor">
-            <a:schemeClr val="tx1"/>
-          </a:fontRef>
-        </p:style>
-      </p:cxnSp>
-      <p:sp>
-        <p:nvSpPr>
-          <p:cNvPr id="307" name="TextBox 306"/>
-          <p:cNvSpPr txBox="1"/>
-          <p:nvPr/>
-        </p:nvSpPr>
-        <p:spPr>
-          <a:xfrm>
-            <a:off x="6327648" y="1856232"/>
-            <a:ext cx="969264" cy="274320"/>
-          </a:xfrm>
-          <a:prstGeom prst="rect">
-            <a:avLst/>
-          </a:prstGeom>
-          <a:noFill/>
-        </p:spPr>
-        <p:txBody>
-          <a:bodyPr wrap="square">
-            <a:spAutoFit/>
-          </a:bodyPr>
-          <a:lstStyle/>
-          <a:p>
-            <a:pPr algn="ctr"/>
-            <a:r>
-              <a:rPr sz="1100" b="0" i="0">
-                <a:solidFill>
-                  <a:srgbClr val="9AA3AB"/>
-                </a:solidFill>
-              </a:rPr>
-              <a:t>touched</a:t>
-            </a:r>
-          </a:p>
-        </p:txBody>
-      </p:sp>
-      <p:sp>
-        <p:nvSpPr>
-          <p:cNvPr id="308" name="TextBox 307"/>
-          <p:cNvSpPr txBox="1"/>
-          <p:nvPr/>
-        </p:nvSpPr>
-        <p:spPr>
-          <a:xfrm>
-            <a:off x="365760" y="3200400"/>
-            <a:ext cx="8229600" cy="548640"/>
-          </a:xfrm>
-          <a:prstGeom prst="rect">
-            <a:avLst/>
-          </a:prstGeom>
-          <a:noFill/>
-        </p:spPr>
-        <p:txBody>
-          <a:bodyPr wrap="square">
-            <a:spAutoFit/>
-          </a:bodyPr>
-          <a:lstStyle/>
-          <a:p>
-            <a:pPr algn="ctr"/>
-            <a:r>
-              <a:rPr sz="1500" b="1" i="0">
-                <a:solidFill>
-                  <a:srgbClr val="DEE2E6"/>
-                </a:solidFill>
-              </a:rPr>
-              <a:t>At each tile centre: never turn back, and take the direction closest to a target tile.</a:t>
-            </a:r>
+          <a:p>
+            <a:pPr indent="-330200" lvl="0" marL="457200" rtl="0" algn="l">
+              <a:spcBef>
+                <a:spcPts val="0"/>
+              </a:spcBef>
+              <a:spcAft>
+                <a:spcPts val="0"/>
+              </a:spcAft>
+              <a:buSzPts val="1600"/>
+              <a:buChar char="●"/>
+            </a:pPr>
+            <a:r>
+              <a:rPr lang="en"/>
+              <a:t>Open a new tunnel, or move Pac-Man’s start</a:t>
+            </a:r>
+            <a:endParaRPr/>
+          </a:p>
+          <a:p>
+            <a:pPr indent="-330200" lvl="0" marL="457200" rtl="0" algn="l">
+              <a:spcBef>
+                <a:spcPts val="0"/>
+              </a:spcBef>
+              <a:spcAft>
+                <a:spcPts val="0"/>
+              </a:spcAft>
+              <a:buSzPts val="1600"/>
+              <a:buChar char="●"/>
+            </a:pPr>
+            <a:r>
+              <a:rPr lang="en"/>
+              <a:t>Then press a direction just before a corner</a:t>
+            </a:r>
+            <a:endParaRPr/>
           </a:p>
         </p:txBody>
       </p:sp>

</xml_diff>

<commit_message>
Animated game images for Sokoban, Pac-Man, Angry Birds, PvZ, Geometry Wars and Vampire Survivors, on the site and in the decks
Co-Authored-By: Claude Opus 5.5 <noreply@anthropic.com>
Claude-Session: https://claude.ai/code/session_012sjsUQBbC7zon57rWHoo9d
</commit_message>
<xml_diff>
--- a/slides/05 Pac-Man.pptx
+++ b/slides/05 Pac-Man.pptx
@@ -16717,14 +16717,14 @@
       </p:sp>
       <p:pic>
         <p:nvPicPr>
-          <p:cNvPr id="46" name="Picture 46" descr="pacman-play.png"/>
+          <p:cNvPr id="46" name="Picture 46" descr="gif-pacman.gif"/>
           <p:cNvPicPr>
             <a:picLocks noChangeAspect="1"/>
           </p:cNvPicPr>
           <p:nvPr/>
         </p:nvPicPr>
         <p:blipFill>
-          <a:blip r:embed="rId4"/>
+          <a:blip r:embed="rId3"/>
           <a:stretch>
             <a:fillRect/>
           </a:stretch>
@@ -16732,7 +16732,7 @@
         <p:spPr>
           <a:xfrm>
             <a:off x="3101255" y="1531275"/>
-            <a:ext cx="2941489" cy="3256648"/>
+            <a:ext cx="2941488" cy="3256648"/>
           </a:xfrm>
           <a:prstGeom prst="rect">
             <a:avLst/>

</xml_diff>

<commit_message>
Pac-Man page, deck and notes follow its own characters
Co-Authored-By: Claude Opus 5.5 <noreply@anthropic.com>
Claude-Session: https://claude.ai/code/session_012sjsUQBbC7zon57rWHoo9d
</commit_message>
<xml_diff>
--- a/slides/05 Pac-Man.pptx
+++ b/slides/05 Pac-Man.pptx
@@ -11544,14 +11544,14 @@
       </p:sp>
       <p:pic>
         <p:nvPicPr>
-          <p:cNvPr id="295" name="Picture 294" descr="ghost_blinky.png"/>
+          <p:cNvPr id="295" name="Picture 303" descr="ghost0.png"/>
           <p:cNvPicPr>
             <a:picLocks noChangeAspect="1"/>
           </p:cNvPicPr>
           <p:nvPr/>
         </p:nvPicPr>
         <p:blipFill>
-          <a:blip r:embed="rId3"/>
+          <a:blip r:embed="rId7"/>
           <a:stretch>
             <a:fillRect/>
           </a:stretch>
@@ -11633,14 +11633,14 @@
       </p:sp>
       <p:pic>
         <p:nvPicPr>
-          <p:cNvPr id="297" name="Picture 296" descr="ghost_pinky.png"/>
+          <p:cNvPr id="297" name="Picture 303" descr="ghost1.png"/>
           <p:cNvPicPr>
             <a:picLocks noChangeAspect="1"/>
           </p:cNvPicPr>
           <p:nvPr/>
         </p:nvPicPr>
         <p:blipFill>
-          <a:blip r:embed="rId4"/>
+          <a:blip r:embed="rId8"/>
           <a:stretch>
             <a:fillRect/>
           </a:stretch>
@@ -11722,14 +11722,14 @@
       </p:sp>
       <p:pic>
         <p:nvPicPr>
-          <p:cNvPr id="299" name="Picture 298" descr="ghost_inky.png"/>
+          <p:cNvPr id="299" name="Picture 303" descr="ghost2.png"/>
           <p:cNvPicPr>
             <a:picLocks noChangeAspect="1"/>
           </p:cNvPicPr>
           <p:nvPr/>
         </p:nvPicPr>
         <p:blipFill>
-          <a:blip r:embed="rId5"/>
+          <a:blip r:embed="rId9"/>
           <a:stretch>
             <a:fillRect/>
           </a:stretch>
@@ -11822,14 +11822,14 @@
       </p:sp>
       <p:pic>
         <p:nvPicPr>
-          <p:cNvPr id="301" name="Picture 300" descr="ghost_clyde.png"/>
+          <p:cNvPr id="301" name="Picture 303" descr="ghost3.png"/>
           <p:cNvPicPr>
             <a:picLocks noChangeAspect="1"/>
           </p:cNvPicPr>
           <p:nvPr/>
         </p:nvPicPr>
         <p:blipFill>
-          <a:blip r:embed="rId6"/>
+          <a:blip r:embed="rId10"/>
           <a:stretch>
             <a:fillRect/>
           </a:stretch>

</xml_diff>

<commit_message>
Pac-Man page and deck show the new maze's rows
Co-Authored-By: Claude Opus 5.5 <noreply@anthropic.com>
Claude-Session: https://claude.ai/code/session_012sjsUQBbC7zon57rWHoo9d
</commit_message>
<xml_diff>
--- a/slides/05 Pac-Man.pptx
+++ b/slides/05 Pac-Man.pptx
@@ -18668,7 +18668,7 @@
                 <a:cs typeface="Consolas"/>
                 <a:sym typeface="Consolas"/>
               </a:rPr>
-              <a:t>############################</a:t>
+              <a:t>####################################</a:t>
             </a:r>
             <a:endParaRPr sz="1000">
               <a:solidFill>
@@ -18706,7 +18706,7 @@
                 <a:cs typeface="Consolas"/>
                 <a:sym typeface="Consolas"/>
               </a:rPr>
-              <a:t>#............##............#</a:t>
+              <a:t>#..................................#</a:t>
             </a:r>
             <a:endParaRPr sz="1000">
               <a:solidFill>
@@ -18744,7 +18744,7 @@
                 <a:cs typeface="Consolas"/>
                 <a:sym typeface="Consolas"/>
               </a:rPr>
-              <a:t>#.####.#####.##.#####.####.#</a:t>
+              <a:t>#.###.#######.########.#######.###.#</a:t>
             </a:r>
             <a:endParaRPr sz="1000">
               <a:solidFill>
@@ -18782,7 +18782,7 @@
                 <a:cs typeface="Consolas"/>
                 <a:sym typeface="Consolas"/>
               </a:rPr>
-              <a:t>#o####.#####.##.#####.####o#</a:t>
+              <a:t>#.###.........########.........###.#</a:t>
             </a:r>
             <a:endParaRPr sz="1000">
               <a:solidFill>
@@ -18820,7 +18820,7 @@
                 <a:cs typeface="Consolas"/>
                 <a:sym typeface="Consolas"/>
               </a:rPr>
-              <a:t>#.####.#####.##.#####.####.#</a:t>
+              <a:t>#.###.#######.########.#######.###.#</a:t>
             </a:r>
             <a:endParaRPr sz="1000">
               <a:solidFill>
@@ -18858,7 +18858,7 @@
                 <a:cs typeface="Consolas"/>
                 <a:sym typeface="Consolas"/>
               </a:rPr>
-              <a:t>#..........................#</a:t>
+              <a:t>#..................................#</a:t>
             </a:r>
             <a:endParaRPr sz="1000">
               <a:solidFill>
@@ -18934,7 +18934,7 @@
                 <a:cs typeface="Consolas"/>
                 <a:sym typeface="Consolas"/>
               </a:rPr>
-              <a:t>######.##.###--###.##.######</a:t>
+              <a:t>#####.###.##.####--####.##.###.#####</a:t>
             </a:r>
             <a:endParaRPr sz="1000">
               <a:solidFill>
@@ -18972,7 +18972,7 @@
                 <a:cs typeface="Consolas"/>
                 <a:sym typeface="Consolas"/>
               </a:rPr>
-              <a:t>######.##.#HHHHHH#.##.######</a:t>
+              <a:t>#####.###.##.#HHHHHHHH#.##.###.#####</a:t>
             </a:r>
             <a:endParaRPr sz="1000">
               <a:solidFill>
@@ -19010,7 +19010,7 @@
                 <a:cs typeface="Consolas"/>
                 <a:sym typeface="Consolas"/>
               </a:rPr>
-              <a:t>      .   #iHpHHc#   .      </a:t>
+              <a:t>     .....##.#HiHpHHcH#.##.....     </a:t>
             </a:r>
             <a:endParaRPr sz="1000">
               <a:solidFill>
@@ -19048,7 +19048,7 @@
                 <a:cs typeface="Consolas"/>
                 <a:sym typeface="Consolas"/>
               </a:rPr>
-              <a:t>######.##.#HHHHHH#.##.######</a:t>
+              <a:t>...</a:t>
             </a:r>
             <a:endParaRPr sz="1000">
               <a:solidFill>

</xml_diff>